<commit_message>
docs: carry the live Gmail run and the current test count into the deck
Slide 2's supporting figure still read 179 passed. Slide 4's third column
described the one A/B case in prose that repeated what the column beside it
already said; it now records that the same path was walked against real Gmail
with three newly sent mails and closed at ASK_USER.

Co-Authored-By: Claude Opus 5 <noreply@anthropic.com>
</commit_message>
<xml_diff>
--- a/Docs/PRESENTATION/2. 최종/09285_백준현_AI_Master_최종발표자료_v8.pptx
+++ b/Docs/PRESENTATION/2. 최종/09285_백준현_AI_Master_최종발표자료_v8.pptx
@@ -2,16 +2,16 @@
 <file path=ppt/presentation.xml><?xml version="1.0" encoding="utf-8"?>
 <p:presentation xmlns:p="http://schemas.openxmlformats.org/presentationml/2006/main">
   <p:sldMasterIdLst>
-    <p:sldMasterId xmlns:r="http://schemas.openxmlformats.org/officeDocument/2006/relationships" id="2147483648" r:id="Rfcf27fd5c8d54038"/>
+    <p:sldMasterId xmlns:r="http://schemas.openxmlformats.org/officeDocument/2006/relationships" id="2147483648" r:id="R2a71922ec204473a"/>
   </p:sldMasterIdLst>
   <p:notesMasterIdLst>
-    <p:notesMasterId xmlns:r="http://schemas.openxmlformats.org/officeDocument/2006/relationships" r:id="R0a8184bb296747da"/>
+    <p:notesMasterId xmlns:r="http://schemas.openxmlformats.org/officeDocument/2006/relationships" r:id="Rea0e1c29e7584e4e"/>
   </p:notesMasterIdLst>
   <p:sldIdLst>
-    <p:sldId xmlns:r="http://schemas.openxmlformats.org/officeDocument/2006/relationships" id="256" r:id="Rd92f558f5b0e4caf"/>
-    <p:sldId xmlns:r="http://schemas.openxmlformats.org/officeDocument/2006/relationships" id="257" r:id="Rc956308a99d24fb3"/>
-    <p:sldId xmlns:r="http://schemas.openxmlformats.org/officeDocument/2006/relationships" id="258" r:id="Rf3ba52f8f75248c3"/>
-    <p:sldId xmlns:r="http://schemas.openxmlformats.org/officeDocument/2006/relationships" id="259" r:id="Rfb7794da1f4f4200"/>
+    <p:sldId xmlns:r="http://schemas.openxmlformats.org/officeDocument/2006/relationships" id="256" r:id="R3f7c8f7213f04f7b"/>
+    <p:sldId xmlns:r="http://schemas.openxmlformats.org/officeDocument/2006/relationships" id="257" r:id="R3417ac2bdc71405d"/>
+    <p:sldId xmlns:r="http://schemas.openxmlformats.org/officeDocument/2006/relationships" id="258" r:id="R1de59b96e48c435b"/>
+    <p:sldId xmlns:r="http://schemas.openxmlformats.org/officeDocument/2006/relationships" id="259" r:id="R8ace2014f4ab45bd"/>
   </p:sldIdLst>
   <p:sldSz cx="12192000" cy="6858000"/>
   <p:notesSz cx="6858000" cy="9144000"/>
@@ -933,7 +933,7 @@
   </p:cSld>
   <p:clrMap bg1="lt1" tx1="dk1" bg2="lt2" tx2="dk2" accent1="accent1" accent2="accent2" accent3="accent3" accent4="accent4" accent5="accent5" accent6="accent6" hlink="hlink" folHlink="folHlink"/>
   <p:sldLayoutIdLst>
-    <p:sldLayoutId xmlns:r="http://schemas.openxmlformats.org/officeDocument/2006/relationships" id="2147483649" r:id="Re46a3b60ec2e4889"/>
+    <p:sldLayoutId xmlns:r="http://schemas.openxmlformats.org/officeDocument/2006/relationships" id="2147483649" r:id="R720b743c4d314160"/>
   </p:sldLayoutIdLst>
   <p:txStyles>
     <p:titleStyle>
@@ -1484,7 +1484,7 @@
           <p:cNvPr id="9" name="">
             <a:extLst xmlns:a="http://schemas.openxmlformats.org/drawingml/2006/main">
               <a:ext uri="{FF2B5EF4-FFF2-40B4-BE49-F238E27FC236}">
-                <a16:creationId xmlns:a16="http://schemas.microsoft.com/office/drawing/2014/main" id="{90FEFBF4-C522-4E35-A2FE-2A8C91DA4D50}"/>
+                <a16:creationId xmlns:a16="http://schemas.microsoft.com/office/drawing/2014/main" id="{EFC8F352-DBAB-44DC-9EC4-47963E076916}"/>
               </a:ext>
             </a:extLst>
           </p:cNvPr>
@@ -1514,7 +1514,7 @@
           <p:cNvPr id="2" name="">
             <a:extLst xmlns:a="http://schemas.openxmlformats.org/drawingml/2006/main">
               <a:ext uri="{FF2B5EF4-FFF2-40B4-BE49-F238E27FC236}">
-                <a16:creationId xmlns:a16="http://schemas.microsoft.com/office/drawing/2014/main" id="{9EEADA74-C853-4C0F-9190-B28B8E2F6273}"/>
+                <a16:creationId xmlns:a16="http://schemas.microsoft.com/office/drawing/2014/main" id="{0B806969-6FC1-4728-8125-C21B58D3DF8F}"/>
               </a:ext>
             </a:extLst>
           </p:cNvPr>
@@ -1571,7 +1571,7 @@
           <p:cNvPr id="3" name="">
             <a:extLst xmlns:a="http://schemas.openxmlformats.org/drawingml/2006/main">
               <a:ext uri="{FF2B5EF4-FFF2-40B4-BE49-F238E27FC236}">
-                <a16:creationId xmlns:a16="http://schemas.microsoft.com/office/drawing/2014/main" id="{B30BCFC0-1A72-4DC6-A27D-792F184C53B8}"/>
+                <a16:creationId xmlns:a16="http://schemas.microsoft.com/office/drawing/2014/main" id="{773E8115-BE31-4970-8A56-CCFC4765A8F6}"/>
               </a:ext>
             </a:extLst>
           </p:cNvPr>
@@ -1628,7 +1628,7 @@
           <p:cNvPr id="4" name="">
             <a:extLst xmlns:a="http://schemas.openxmlformats.org/drawingml/2006/main">
               <a:ext uri="{FF2B5EF4-FFF2-40B4-BE49-F238E27FC236}">
-                <a16:creationId xmlns:a16="http://schemas.microsoft.com/office/drawing/2014/main" id="{55D62BA0-ADA9-4568-8C40-43743C1AE6D3}"/>
+                <a16:creationId xmlns:a16="http://schemas.microsoft.com/office/drawing/2014/main" id="{F449C9C5-14E9-4A9F-9C68-C7944A4B4326}"/>
               </a:ext>
             </a:extLst>
           </p:cNvPr>
@@ -1685,7 +1685,7 @@
           <p:cNvPr id="5" name="">
             <a:extLst xmlns:a="http://schemas.openxmlformats.org/drawingml/2006/main">
               <a:ext uri="{FF2B5EF4-FFF2-40B4-BE49-F238E27FC236}">
-                <a16:creationId xmlns:a16="http://schemas.microsoft.com/office/drawing/2014/main" id="{7BF29381-0FAF-4258-B081-638B2CAEBB18}"/>
+                <a16:creationId xmlns:a16="http://schemas.microsoft.com/office/drawing/2014/main" id="{DADE25B2-9712-42CB-A79C-D5144FEB603B}"/>
               </a:ext>
             </a:extLst>
           </p:cNvPr>
@@ -1715,7 +1715,7 @@
           <p:cNvPr id="6" name="">
             <a:extLst xmlns:a="http://schemas.openxmlformats.org/drawingml/2006/main">
               <a:ext uri="{FF2B5EF4-FFF2-40B4-BE49-F238E27FC236}">
-                <a16:creationId xmlns:a16="http://schemas.microsoft.com/office/drawing/2014/main" id="{FDAF7A5D-C140-4A03-B095-04D48640C65C}"/>
+                <a16:creationId xmlns:a16="http://schemas.microsoft.com/office/drawing/2014/main" id="{418CEB92-AD68-4269-81D1-BC2884F700A2}"/>
               </a:ext>
             </a:extLst>
           </p:cNvPr>
@@ -1772,7 +1772,7 @@
           <p:cNvPr id="7" name="">
             <a:extLst xmlns:a="http://schemas.openxmlformats.org/drawingml/2006/main">
               <a:ext uri="{FF2B5EF4-FFF2-40B4-BE49-F238E27FC236}">
-                <a16:creationId xmlns:a16="http://schemas.microsoft.com/office/drawing/2014/main" id="{87EA95CA-D328-4410-817F-D8E83C02C13A}"/>
+                <a16:creationId xmlns:a16="http://schemas.microsoft.com/office/drawing/2014/main" id="{2078F427-6E5D-4E83-8ACA-75E3C9564848}"/>
               </a:ext>
             </a:extLst>
           </p:cNvPr>
@@ -1829,7 +1829,7 @@
           <p:cNvPr id="8" name="">
             <a:extLst xmlns:a="http://schemas.openxmlformats.org/drawingml/2006/main">
               <a:ext uri="{FF2B5EF4-FFF2-40B4-BE49-F238E27FC236}">
-                <a16:creationId xmlns:a16="http://schemas.microsoft.com/office/drawing/2014/main" id="{A71FC11B-8331-49EE-A160-E08A6260D51D}"/>
+                <a16:creationId xmlns:a16="http://schemas.microsoft.com/office/drawing/2014/main" id="{AA795D95-0B37-479F-8777-1D9FC446B8EA}"/>
               </a:ext>
             </a:extLst>
           </p:cNvPr>
@@ -1884,7 +1884,7 @@
     </p:spTree>
     <p:extLst>
       <p:ext uri="{BB962C8B-B14F-4D97-AF65-F5344CB8AC3E}">
-        <p14:creationId xmlns:p14="http://schemas.microsoft.com/office/powerpoint/2010/main" val="1201496953"/>
+        <p14:creationId xmlns:p14="http://schemas.microsoft.com/office/powerpoint/2010/main" val="550010036"/>
       </p:ext>
     </p:extLst>
   </p:cSld>
@@ -1915,7 +1915,7 @@
           <p:cNvPr id="45" name="">
             <a:extLst xmlns:a="http://schemas.openxmlformats.org/drawingml/2006/main">
               <a:ext uri="{FF2B5EF4-FFF2-40B4-BE49-F238E27FC236}">
-                <a16:creationId xmlns:a16="http://schemas.microsoft.com/office/drawing/2014/main" id="{3D9DFC07-2B0C-46AE-8F33-B5DE06E3DF03}"/>
+                <a16:creationId xmlns:a16="http://schemas.microsoft.com/office/drawing/2014/main" id="{466B8E65-DF6A-43D7-BE0A-3777B2F90C12}"/>
               </a:ext>
             </a:extLst>
           </p:cNvPr>
@@ -1945,7 +1945,7 @@
           <p:cNvPr id="2" name="">
             <a:extLst xmlns:a="http://schemas.openxmlformats.org/drawingml/2006/main">
               <a:ext uri="{FF2B5EF4-FFF2-40B4-BE49-F238E27FC236}">
-                <a16:creationId xmlns:a16="http://schemas.microsoft.com/office/drawing/2014/main" id="{19D2931A-A20B-4EAD-97AF-8782727B198C}"/>
+                <a16:creationId xmlns:a16="http://schemas.microsoft.com/office/drawing/2014/main" id="{2C5247B1-1B82-42B7-B914-29021BB094F9}"/>
               </a:ext>
             </a:extLst>
           </p:cNvPr>
@@ -2002,7 +2002,7 @@
           <p:cNvPr id="3" name="">
             <a:extLst xmlns:a="http://schemas.openxmlformats.org/drawingml/2006/main">
               <a:ext uri="{FF2B5EF4-FFF2-40B4-BE49-F238E27FC236}">
-                <a16:creationId xmlns:a16="http://schemas.microsoft.com/office/drawing/2014/main" id="{0FE89F47-4A2D-4C1E-8F98-1DDA4A513738}"/>
+                <a16:creationId xmlns:a16="http://schemas.microsoft.com/office/drawing/2014/main" id="{AC9F1720-5BB6-4666-8F42-E182F2A2E2F9}"/>
               </a:ext>
             </a:extLst>
           </p:cNvPr>
@@ -2032,7 +2032,7 @@
           <p:cNvPr id="4" name="">
             <a:extLst xmlns:a="http://schemas.openxmlformats.org/drawingml/2006/main">
               <a:ext uri="{FF2B5EF4-FFF2-40B4-BE49-F238E27FC236}">
-                <a16:creationId xmlns:a16="http://schemas.microsoft.com/office/drawing/2014/main" id="{8B3FE3F9-1284-4B0B-BE3C-3346E413923E}"/>
+                <a16:creationId xmlns:a16="http://schemas.microsoft.com/office/drawing/2014/main" id="{C1F7EE13-3267-4BE1-A7FA-5BD32EB09895}"/>
               </a:ext>
             </a:extLst>
           </p:cNvPr>
@@ -2089,7 +2089,7 @@
           <p:cNvPr id="5" name="">
             <a:extLst xmlns:a="http://schemas.openxmlformats.org/drawingml/2006/main">
               <a:ext uri="{FF2B5EF4-FFF2-40B4-BE49-F238E27FC236}">
-                <a16:creationId xmlns:a16="http://schemas.microsoft.com/office/drawing/2014/main" id="{455FEE0A-5D2A-4C93-A39D-E50DEA31CA51}"/>
+                <a16:creationId xmlns:a16="http://schemas.microsoft.com/office/drawing/2014/main" id="{4F35DD48-53BA-4CEA-BFAC-B194F102F955}"/>
               </a:ext>
             </a:extLst>
           </p:cNvPr>
@@ -2146,7 +2146,7 @@
           <p:cNvPr id="6" name="">
             <a:extLst xmlns:a="http://schemas.openxmlformats.org/drawingml/2006/main">
               <a:ext uri="{FF2B5EF4-FFF2-40B4-BE49-F238E27FC236}">
-                <a16:creationId xmlns:a16="http://schemas.microsoft.com/office/drawing/2014/main" id="{79FB2027-8F12-4585-90D2-799B2730D509}"/>
+                <a16:creationId xmlns:a16="http://schemas.microsoft.com/office/drawing/2014/main" id="{E6C914CA-F164-4F01-B09F-90C931055BDD}"/>
               </a:ext>
             </a:extLst>
           </p:cNvPr>
@@ -2203,7 +2203,7 @@
           <p:cNvPr id="7" name="">
             <a:extLst xmlns:a="http://schemas.openxmlformats.org/drawingml/2006/main">
               <a:ext uri="{FF2B5EF4-FFF2-40B4-BE49-F238E27FC236}">
-                <a16:creationId xmlns:a16="http://schemas.microsoft.com/office/drawing/2014/main" id="{70959FAC-E80F-446A-8CBA-8EA5F7876D5A}"/>
+                <a16:creationId xmlns:a16="http://schemas.microsoft.com/office/drawing/2014/main" id="{E590AAE8-469E-4A79-B970-E0D2849BF8D2}"/>
               </a:ext>
             </a:extLst>
           </p:cNvPr>
@@ -2237,7 +2237,7 @@
           <p:cNvPr id="8" name="">
             <a:extLst xmlns:a="http://schemas.openxmlformats.org/drawingml/2006/main">
               <a:ext uri="{FF2B5EF4-FFF2-40B4-BE49-F238E27FC236}">
-                <a16:creationId xmlns:a16="http://schemas.microsoft.com/office/drawing/2014/main" id="{EC3DA6EE-BA4D-49FA-84BF-E1AAB818E376}"/>
+                <a16:creationId xmlns:a16="http://schemas.microsoft.com/office/drawing/2014/main" id="{29AECD61-0241-47E0-8AFF-F4BBF435DEE9}"/>
               </a:ext>
             </a:extLst>
           </p:cNvPr>
@@ -2269,7 +2269,7 @@
           <p:cNvPr id="9" name="">
             <a:extLst xmlns:a="http://schemas.openxmlformats.org/drawingml/2006/main">
               <a:ext uri="{FF2B5EF4-FFF2-40B4-BE49-F238E27FC236}">
-                <a16:creationId xmlns:a16="http://schemas.microsoft.com/office/drawing/2014/main" id="{6277F404-733F-4E89-B1D1-3515852D902C}"/>
+                <a16:creationId xmlns:a16="http://schemas.microsoft.com/office/drawing/2014/main" id="{2D2132D6-1FA8-44E8-8B53-DADBE395A9EB}"/>
               </a:ext>
             </a:extLst>
           </p:cNvPr>
@@ -2326,7 +2326,7 @@
           <p:cNvPr id="10" name="">
             <a:extLst xmlns:a="http://schemas.openxmlformats.org/drawingml/2006/main">
               <a:ext uri="{FF2B5EF4-FFF2-40B4-BE49-F238E27FC236}">
-                <a16:creationId xmlns:a16="http://schemas.microsoft.com/office/drawing/2014/main" id="{3115DB86-F1EC-4B0E-B1E5-A5ABD7AB3AC9}"/>
+                <a16:creationId xmlns:a16="http://schemas.microsoft.com/office/drawing/2014/main" id="{398A6958-290F-4345-92FF-E9553747B667}"/>
               </a:ext>
             </a:extLst>
           </p:cNvPr>
@@ -2406,7 +2406,7 @@
           <p:cNvPr id="11" name="">
             <a:extLst xmlns:a="http://schemas.openxmlformats.org/drawingml/2006/main">
               <a:ext uri="{FF2B5EF4-FFF2-40B4-BE49-F238E27FC236}">
-                <a16:creationId xmlns:a16="http://schemas.microsoft.com/office/drawing/2014/main" id="{85D9F9FC-0A6E-43A6-B3D4-D2F685C2D316}"/>
+                <a16:creationId xmlns:a16="http://schemas.microsoft.com/office/drawing/2014/main" id="{8CA9391B-D674-44DD-9A17-7E9B37B14FCB}"/>
               </a:ext>
             </a:extLst>
           </p:cNvPr>
@@ -2436,7 +2436,7 @@
           <p:cNvPr id="12" name="">
             <a:extLst xmlns:a="http://schemas.openxmlformats.org/drawingml/2006/main">
               <a:ext uri="{FF2B5EF4-FFF2-40B4-BE49-F238E27FC236}">
-                <a16:creationId xmlns:a16="http://schemas.microsoft.com/office/drawing/2014/main" id="{BB56FB75-4DCF-4F16-A8A6-94FDF70503F9}"/>
+                <a16:creationId xmlns:a16="http://schemas.microsoft.com/office/drawing/2014/main" id="{E6500ABA-06CE-4D39-9B5C-593A99E85793}"/>
               </a:ext>
             </a:extLst>
           </p:cNvPr>
@@ -2470,7 +2470,7 @@
           <p:cNvPr id="13" name="">
             <a:extLst xmlns:a="http://schemas.openxmlformats.org/drawingml/2006/main">
               <a:ext uri="{FF2B5EF4-FFF2-40B4-BE49-F238E27FC236}">
-                <a16:creationId xmlns:a16="http://schemas.microsoft.com/office/drawing/2014/main" id="{58BDF5D2-ACB8-44DC-A080-D090AF9A4084}"/>
+                <a16:creationId xmlns:a16="http://schemas.microsoft.com/office/drawing/2014/main" id="{EC823ED8-C977-4E26-9122-38FBD29B2A69}"/>
               </a:ext>
             </a:extLst>
           </p:cNvPr>
@@ -2502,7 +2502,7 @@
           <p:cNvPr id="14" name="">
             <a:extLst xmlns:a="http://schemas.openxmlformats.org/drawingml/2006/main">
               <a:ext uri="{FF2B5EF4-FFF2-40B4-BE49-F238E27FC236}">
-                <a16:creationId xmlns:a16="http://schemas.microsoft.com/office/drawing/2014/main" id="{6034939E-2665-41C3-9330-8E4F560AF908}"/>
+                <a16:creationId xmlns:a16="http://schemas.microsoft.com/office/drawing/2014/main" id="{CFEAAFF7-0552-4F47-9C8F-49EB83507EB7}"/>
               </a:ext>
             </a:extLst>
           </p:cNvPr>
@@ -2559,7 +2559,7 @@
           <p:cNvPr id="15" name="">
             <a:extLst xmlns:a="http://schemas.openxmlformats.org/drawingml/2006/main">
               <a:ext uri="{FF2B5EF4-FFF2-40B4-BE49-F238E27FC236}">
-                <a16:creationId xmlns:a16="http://schemas.microsoft.com/office/drawing/2014/main" id="{DE7B30FF-0BEB-487E-A963-A8C46B0AE132}"/>
+                <a16:creationId xmlns:a16="http://schemas.microsoft.com/office/drawing/2014/main" id="{1FC3D539-3CD3-4810-987A-AC9352AA83D5}"/>
               </a:ext>
             </a:extLst>
           </p:cNvPr>
@@ -2639,7 +2639,7 @@
           <p:cNvPr id="16" name="">
             <a:extLst xmlns:a="http://schemas.openxmlformats.org/drawingml/2006/main">
               <a:ext uri="{FF2B5EF4-FFF2-40B4-BE49-F238E27FC236}">
-                <a16:creationId xmlns:a16="http://schemas.microsoft.com/office/drawing/2014/main" id="{3D9BA0D2-2B4E-449C-92BC-F65CDF8412B9}"/>
+                <a16:creationId xmlns:a16="http://schemas.microsoft.com/office/drawing/2014/main" id="{CA6ED2A8-5C02-4728-8C19-ADD6111E12D4}"/>
               </a:ext>
             </a:extLst>
           </p:cNvPr>
@@ -2669,7 +2669,7 @@
           <p:cNvPr id="17" name="">
             <a:extLst xmlns:a="http://schemas.openxmlformats.org/drawingml/2006/main">
               <a:ext uri="{FF2B5EF4-FFF2-40B4-BE49-F238E27FC236}">
-                <a16:creationId xmlns:a16="http://schemas.microsoft.com/office/drawing/2014/main" id="{0A85CCF3-32FB-4FF3-99C8-5BCF8AB57471}"/>
+                <a16:creationId xmlns:a16="http://schemas.microsoft.com/office/drawing/2014/main" id="{EFB55766-D657-45AD-904E-0248102A1089}"/>
               </a:ext>
             </a:extLst>
           </p:cNvPr>
@@ -2703,7 +2703,7 @@
           <p:cNvPr id="18" name="">
             <a:extLst xmlns:a="http://schemas.openxmlformats.org/drawingml/2006/main">
               <a:ext uri="{FF2B5EF4-FFF2-40B4-BE49-F238E27FC236}">
-                <a16:creationId xmlns:a16="http://schemas.microsoft.com/office/drawing/2014/main" id="{86A2A5EE-E030-4DB3-975D-0C0949061BF7}"/>
+                <a16:creationId xmlns:a16="http://schemas.microsoft.com/office/drawing/2014/main" id="{6EF46A4F-9BE3-49D8-80CC-1680FA161E19}"/>
               </a:ext>
             </a:extLst>
           </p:cNvPr>
@@ -2735,7 +2735,7 @@
           <p:cNvPr id="19" name="">
             <a:extLst xmlns:a="http://schemas.openxmlformats.org/drawingml/2006/main">
               <a:ext uri="{FF2B5EF4-FFF2-40B4-BE49-F238E27FC236}">
-                <a16:creationId xmlns:a16="http://schemas.microsoft.com/office/drawing/2014/main" id="{1A75E61A-EA54-4ADE-B944-1966CB25F13F}"/>
+                <a16:creationId xmlns:a16="http://schemas.microsoft.com/office/drawing/2014/main" id="{B55C37B9-6A7B-4CC0-9FB2-D4AF60AA942A}"/>
               </a:ext>
             </a:extLst>
           </p:cNvPr>
@@ -2792,7 +2792,7 @@
           <p:cNvPr id="20" name="">
             <a:extLst xmlns:a="http://schemas.openxmlformats.org/drawingml/2006/main">
               <a:ext uri="{FF2B5EF4-FFF2-40B4-BE49-F238E27FC236}">
-                <a16:creationId xmlns:a16="http://schemas.microsoft.com/office/drawing/2014/main" id="{38DD47E5-C400-4C3B-93D7-AB138512E83E}"/>
+                <a16:creationId xmlns:a16="http://schemas.microsoft.com/office/drawing/2014/main" id="{78DD94B6-3A12-480F-B00C-D6A412A30EF0}"/>
               </a:ext>
             </a:extLst>
           </p:cNvPr>
@@ -2872,7 +2872,7 @@
           <p:cNvPr id="21" name="">
             <a:extLst xmlns:a="http://schemas.openxmlformats.org/drawingml/2006/main">
               <a:ext uri="{FF2B5EF4-FFF2-40B4-BE49-F238E27FC236}">
-                <a16:creationId xmlns:a16="http://schemas.microsoft.com/office/drawing/2014/main" id="{265E6D86-85F9-4D72-953A-33FAA9959267}"/>
+                <a16:creationId xmlns:a16="http://schemas.microsoft.com/office/drawing/2014/main" id="{772C9AE0-8737-4306-8B52-F266712A3D28}"/>
               </a:ext>
             </a:extLst>
           </p:cNvPr>
@@ -2902,7 +2902,7 @@
           <p:cNvPr id="22" name="">
             <a:extLst xmlns:a="http://schemas.openxmlformats.org/drawingml/2006/main">
               <a:ext uri="{FF2B5EF4-FFF2-40B4-BE49-F238E27FC236}">
-                <a16:creationId xmlns:a16="http://schemas.microsoft.com/office/drawing/2014/main" id="{61D82F41-7741-44FC-B303-337B6F92F7F3}"/>
+                <a16:creationId xmlns:a16="http://schemas.microsoft.com/office/drawing/2014/main" id="{BD17DF5D-73F2-40F4-876C-5636D841C951}"/>
               </a:ext>
             </a:extLst>
           </p:cNvPr>
@@ -2936,7 +2936,7 @@
           <p:cNvPr id="23" name="">
             <a:extLst xmlns:a="http://schemas.openxmlformats.org/drawingml/2006/main">
               <a:ext uri="{FF2B5EF4-FFF2-40B4-BE49-F238E27FC236}">
-                <a16:creationId xmlns:a16="http://schemas.microsoft.com/office/drawing/2014/main" id="{E5CCBAF8-572D-464D-B559-2D0D644DB15B}"/>
+                <a16:creationId xmlns:a16="http://schemas.microsoft.com/office/drawing/2014/main" id="{074AF708-C5F8-47DC-A736-2A7E0B6E7B89}"/>
               </a:ext>
             </a:extLst>
           </p:cNvPr>
@@ -2968,7 +2968,7 @@
           <p:cNvPr id="24" name="">
             <a:extLst xmlns:a="http://schemas.openxmlformats.org/drawingml/2006/main">
               <a:ext uri="{FF2B5EF4-FFF2-40B4-BE49-F238E27FC236}">
-                <a16:creationId xmlns:a16="http://schemas.microsoft.com/office/drawing/2014/main" id="{682488D9-2D26-4634-B513-89FA91B3FAB5}"/>
+                <a16:creationId xmlns:a16="http://schemas.microsoft.com/office/drawing/2014/main" id="{B19703B4-A079-45DF-A3E2-08571E321A4D}"/>
               </a:ext>
             </a:extLst>
           </p:cNvPr>
@@ -3025,7 +3025,7 @@
           <p:cNvPr id="25" name="">
             <a:extLst xmlns:a="http://schemas.openxmlformats.org/drawingml/2006/main">
               <a:ext uri="{FF2B5EF4-FFF2-40B4-BE49-F238E27FC236}">
-                <a16:creationId xmlns:a16="http://schemas.microsoft.com/office/drawing/2014/main" id="{417F4FF7-D710-49C6-92DB-739870C523BA}"/>
+                <a16:creationId xmlns:a16="http://schemas.microsoft.com/office/drawing/2014/main" id="{FEF881FF-D07E-4672-95D4-83D329931EB7}"/>
               </a:ext>
             </a:extLst>
           </p:cNvPr>
@@ -3105,7 +3105,7 @@
           <p:cNvPr id="26" name="">
             <a:extLst xmlns:a="http://schemas.openxmlformats.org/drawingml/2006/main">
               <a:ext uri="{FF2B5EF4-FFF2-40B4-BE49-F238E27FC236}">
-                <a16:creationId xmlns:a16="http://schemas.microsoft.com/office/drawing/2014/main" id="{B7E5F08B-FCE4-4D0E-BB08-664F399F6A4D}"/>
+                <a16:creationId xmlns:a16="http://schemas.microsoft.com/office/drawing/2014/main" id="{28154C7E-63F5-4F3D-BCCF-C10E9D190F87}"/>
               </a:ext>
             </a:extLst>
           </p:cNvPr>
@@ -3135,7 +3135,7 @@
           <p:cNvPr id="27" name="">
             <a:extLst xmlns:a="http://schemas.openxmlformats.org/drawingml/2006/main">
               <a:ext uri="{FF2B5EF4-FFF2-40B4-BE49-F238E27FC236}">
-                <a16:creationId xmlns:a16="http://schemas.microsoft.com/office/drawing/2014/main" id="{830C8417-98F9-4BCA-BC76-D3C96126E4D3}"/>
+                <a16:creationId xmlns:a16="http://schemas.microsoft.com/office/drawing/2014/main" id="{4E413B4A-8D0F-44E5-BCC6-E48E66689A1B}"/>
               </a:ext>
             </a:extLst>
           </p:cNvPr>
@@ -3169,7 +3169,7 @@
           <p:cNvPr id="28" name="">
             <a:extLst xmlns:a="http://schemas.openxmlformats.org/drawingml/2006/main">
               <a:ext uri="{FF2B5EF4-FFF2-40B4-BE49-F238E27FC236}">
-                <a16:creationId xmlns:a16="http://schemas.microsoft.com/office/drawing/2014/main" id="{A41B2833-003B-45B1-B1B1-545BC7A60887}"/>
+                <a16:creationId xmlns:a16="http://schemas.microsoft.com/office/drawing/2014/main" id="{25A49EE0-378B-4A3E-B5F5-2F56FFA90D2B}"/>
               </a:ext>
             </a:extLst>
           </p:cNvPr>
@@ -3201,7 +3201,7 @@
           <p:cNvPr id="29" name="">
             <a:extLst xmlns:a="http://schemas.openxmlformats.org/drawingml/2006/main">
               <a:ext uri="{FF2B5EF4-FFF2-40B4-BE49-F238E27FC236}">
-                <a16:creationId xmlns:a16="http://schemas.microsoft.com/office/drawing/2014/main" id="{0DAEF5DC-3857-43FC-80AF-CB9A634E8C0B}"/>
+                <a16:creationId xmlns:a16="http://schemas.microsoft.com/office/drawing/2014/main" id="{53FC9CD2-1450-42BE-880A-8B206EA31249}"/>
               </a:ext>
             </a:extLst>
           </p:cNvPr>
@@ -3258,7 +3258,7 @@
           <p:cNvPr id="30" name="">
             <a:extLst xmlns:a="http://schemas.openxmlformats.org/drawingml/2006/main">
               <a:ext uri="{FF2B5EF4-FFF2-40B4-BE49-F238E27FC236}">
-                <a16:creationId xmlns:a16="http://schemas.microsoft.com/office/drawing/2014/main" id="{3A527159-EAF2-4DBC-A6E8-9BC33819F10E}"/>
+                <a16:creationId xmlns:a16="http://schemas.microsoft.com/office/drawing/2014/main" id="{467678EE-A701-4624-894C-E77EA4466143}"/>
               </a:ext>
             </a:extLst>
           </p:cNvPr>
@@ -3338,7 +3338,7 @@
           <p:cNvPr id="31" name="">
             <a:extLst xmlns:a="http://schemas.openxmlformats.org/drawingml/2006/main">
               <a:ext uri="{FF2B5EF4-FFF2-40B4-BE49-F238E27FC236}">
-                <a16:creationId xmlns:a16="http://schemas.microsoft.com/office/drawing/2014/main" id="{3797B6C4-17D2-48E7-97F2-584DD0621808}"/>
+                <a16:creationId xmlns:a16="http://schemas.microsoft.com/office/drawing/2014/main" id="{0A935648-678D-4B14-A1E4-FAC8F7DB8834}"/>
               </a:ext>
             </a:extLst>
           </p:cNvPr>
@@ -3395,7 +3395,7 @@
           <p:cNvPr id="32" name="">
             <a:extLst xmlns:a="http://schemas.openxmlformats.org/drawingml/2006/main">
               <a:ext uri="{FF2B5EF4-FFF2-40B4-BE49-F238E27FC236}">
-                <a16:creationId xmlns:a16="http://schemas.microsoft.com/office/drawing/2014/main" id="{CC7B37C7-BFEA-4084-B289-B0488F873BCD}"/>
+                <a16:creationId xmlns:a16="http://schemas.microsoft.com/office/drawing/2014/main" id="{13E31A25-71B4-4207-B7DA-3B114B403808}"/>
               </a:ext>
             </a:extLst>
           </p:cNvPr>
@@ -3452,7 +3452,7 @@
           <p:cNvPr id="33" name="">
             <a:extLst xmlns:a="http://schemas.openxmlformats.org/drawingml/2006/main">
               <a:ext uri="{FF2B5EF4-FFF2-40B4-BE49-F238E27FC236}">
-                <a16:creationId xmlns:a16="http://schemas.microsoft.com/office/drawing/2014/main" id="{0ADD6516-84F6-46D4-92EB-FF4EB4698BD3}"/>
+                <a16:creationId xmlns:a16="http://schemas.microsoft.com/office/drawing/2014/main" id="{55377C47-7D72-4F60-ADAA-94A813450FC1}"/>
               </a:ext>
             </a:extLst>
           </p:cNvPr>
@@ -3509,7 +3509,7 @@
           <p:cNvPr id="34" name="">
             <a:extLst xmlns:a="http://schemas.openxmlformats.org/drawingml/2006/main">
               <a:ext uri="{FF2B5EF4-FFF2-40B4-BE49-F238E27FC236}">
-                <a16:creationId xmlns:a16="http://schemas.microsoft.com/office/drawing/2014/main" id="{8D2E41B3-789B-4BCF-9804-1D3F43D845EE}"/>
+                <a16:creationId xmlns:a16="http://schemas.microsoft.com/office/drawing/2014/main" id="{35588D4E-F31C-409A-943E-50E39AFF418D}"/>
               </a:ext>
             </a:extLst>
           </p:cNvPr>
@@ -3566,7 +3566,7 @@
           <p:cNvPr id="35" name="">
             <a:extLst xmlns:a="http://schemas.openxmlformats.org/drawingml/2006/main">
               <a:ext uri="{FF2B5EF4-FFF2-40B4-BE49-F238E27FC236}">
-                <a16:creationId xmlns:a16="http://schemas.microsoft.com/office/drawing/2014/main" id="{94A49C27-B905-41A1-AAA9-64010C344BCF}"/>
+                <a16:creationId xmlns:a16="http://schemas.microsoft.com/office/drawing/2014/main" id="{E735B1DA-B9D0-476C-8897-7AE93C9A341B}"/>
               </a:ext>
             </a:extLst>
           </p:cNvPr>
@@ -3623,7 +3623,7 @@
           <p:cNvPr id="36" name="">
             <a:extLst xmlns:a="http://schemas.openxmlformats.org/drawingml/2006/main">
               <a:ext uri="{FF2B5EF4-FFF2-40B4-BE49-F238E27FC236}">
-                <a16:creationId xmlns:a16="http://schemas.microsoft.com/office/drawing/2014/main" id="{5918798C-16E9-4F68-AB98-0ABB5F684ED2}"/>
+                <a16:creationId xmlns:a16="http://schemas.microsoft.com/office/drawing/2014/main" id="{68E6D471-387A-41AB-B1F7-30317DF61479}"/>
               </a:ext>
             </a:extLst>
           </p:cNvPr>
@@ -3680,7 +3680,7 @@
           <p:cNvPr id="37" name="">
             <a:extLst xmlns:a="http://schemas.openxmlformats.org/drawingml/2006/main">
               <a:ext uri="{FF2B5EF4-FFF2-40B4-BE49-F238E27FC236}">
-                <a16:creationId xmlns:a16="http://schemas.microsoft.com/office/drawing/2014/main" id="{52EDD4F6-37BC-465C-B269-C540B48660D2}"/>
+                <a16:creationId xmlns:a16="http://schemas.microsoft.com/office/drawing/2014/main" id="{77C5B1A6-3AE3-40FD-9C27-C1DBE39AFF14}"/>
               </a:ext>
             </a:extLst>
           </p:cNvPr>
@@ -3737,7 +3737,7 @@
           <p:cNvPr id="38" name="">
             <a:extLst xmlns:a="http://schemas.openxmlformats.org/drawingml/2006/main">
               <a:ext uri="{FF2B5EF4-FFF2-40B4-BE49-F238E27FC236}">
-                <a16:creationId xmlns:a16="http://schemas.microsoft.com/office/drawing/2014/main" id="{21575A69-7F03-4AC9-BF2D-377728F7F2A4}"/>
+                <a16:creationId xmlns:a16="http://schemas.microsoft.com/office/drawing/2014/main" id="{4D596F42-3158-4804-BA9B-A2D84D5E747D}"/>
               </a:ext>
             </a:extLst>
           </p:cNvPr>
@@ -3794,7 +3794,7 @@
           <p:cNvPr id="39" name="">
             <a:extLst xmlns:a="http://schemas.openxmlformats.org/drawingml/2006/main">
               <a:ext uri="{FF2B5EF4-FFF2-40B4-BE49-F238E27FC236}">
-                <a16:creationId xmlns:a16="http://schemas.microsoft.com/office/drawing/2014/main" id="{73FFBDDB-EFC1-4C22-B4A6-EA85AD2CA9E7}"/>
+                <a16:creationId xmlns:a16="http://schemas.microsoft.com/office/drawing/2014/main" id="{EF9BC48C-101F-4FE7-AD64-ED4122F2564E}"/>
               </a:ext>
             </a:extLst>
           </p:cNvPr>
@@ -3851,7 +3851,7 @@
           <p:cNvPr id="40" name="">
             <a:extLst xmlns:a="http://schemas.openxmlformats.org/drawingml/2006/main">
               <a:ext uri="{FF2B5EF4-FFF2-40B4-BE49-F238E27FC236}">
-                <a16:creationId xmlns:a16="http://schemas.microsoft.com/office/drawing/2014/main" id="{27CCAF9A-5B6E-4400-94B8-979D90CF51E1}"/>
+                <a16:creationId xmlns:a16="http://schemas.microsoft.com/office/drawing/2014/main" id="{86B06C3E-025E-4E69-941C-9EC570A5AE92}"/>
               </a:ext>
             </a:extLst>
           </p:cNvPr>
@@ -3898,7 +3898,7 @@
                 <a:ea typeface="Malgun Gothic"/>
                 <a:cs typeface="Malgun Gothic"/>
               </a:rPr>
-              <a:t>보조 검증  |  pytest 179 passed  ·  중복 재조회 35/35</a:t>
+              <a:t>보조 검증  |  pytest 214 passed  ·  중복 재조회 35/35</a:t>
             </a:r>
           </a:p>
         </p:txBody>
@@ -3908,7 +3908,7 @@
           <p:cNvPr id="41" name="">
             <a:extLst xmlns:a="http://schemas.openxmlformats.org/drawingml/2006/main">
               <a:ext uri="{FF2B5EF4-FFF2-40B4-BE49-F238E27FC236}">
-                <a16:creationId xmlns:a16="http://schemas.microsoft.com/office/drawing/2014/main" id="{3BF94959-6C0C-427D-9573-58471F19B4F6}"/>
+                <a16:creationId xmlns:a16="http://schemas.microsoft.com/office/drawing/2014/main" id="{4B88229A-ACDA-40ED-BB93-A442F4606C46}"/>
               </a:ext>
             </a:extLst>
           </p:cNvPr>
@@ -3988,7 +3988,7 @@
           <p:cNvPr id="42" name="">
             <a:extLst xmlns:a="http://schemas.openxmlformats.org/drawingml/2006/main">
               <a:ext uri="{FF2B5EF4-FFF2-40B4-BE49-F238E27FC236}">
-                <a16:creationId xmlns:a16="http://schemas.microsoft.com/office/drawing/2014/main" id="{C199B579-025E-48A8-A581-FDF4F3B2E788}"/>
+                <a16:creationId xmlns:a16="http://schemas.microsoft.com/office/drawing/2014/main" id="{7D4E69B3-50BA-482C-9FB6-FD3F041E9963}"/>
               </a:ext>
             </a:extLst>
           </p:cNvPr>
@@ -4045,7 +4045,7 @@
           <p:cNvPr id="43" name="">
             <a:extLst xmlns:a="http://schemas.openxmlformats.org/drawingml/2006/main">
               <a:ext uri="{FF2B5EF4-FFF2-40B4-BE49-F238E27FC236}">
-                <a16:creationId xmlns:a16="http://schemas.microsoft.com/office/drawing/2014/main" id="{B556CB86-7EE0-4DC0-B78E-3710E8D94593}"/>
+                <a16:creationId xmlns:a16="http://schemas.microsoft.com/office/drawing/2014/main" id="{45277F2E-EFD0-43E7-852C-4F0E54869209}"/>
               </a:ext>
             </a:extLst>
           </p:cNvPr>
@@ -4077,7 +4077,7 @@
           <p:cNvPr id="44" name="">
             <a:extLst xmlns:a="http://schemas.openxmlformats.org/drawingml/2006/main">
               <a:ext uri="{FF2B5EF4-FFF2-40B4-BE49-F238E27FC236}">
-                <a16:creationId xmlns:a16="http://schemas.microsoft.com/office/drawing/2014/main" id="{917C1BD2-20D5-4145-AE3E-A2FB5216AC42}"/>
+                <a16:creationId xmlns:a16="http://schemas.microsoft.com/office/drawing/2014/main" id="{0DC63E33-E59A-411B-997B-F34F7F82CCB4}"/>
               </a:ext>
             </a:extLst>
           </p:cNvPr>
@@ -4132,7 +4132,7 @@
     </p:spTree>
     <p:extLst>
       <p:ext uri="{BB962C8B-B14F-4D97-AF65-F5344CB8AC3E}">
-        <p14:creationId xmlns:p14="http://schemas.microsoft.com/office/powerpoint/2010/main" val="302738593"/>
+        <p14:creationId xmlns:p14="http://schemas.microsoft.com/office/powerpoint/2010/main" val="352965319"/>
       </p:ext>
     </p:extLst>
   </p:cSld>
@@ -4163,7 +4163,7 @@
           <p:cNvPr id="56" name="">
             <a:extLst xmlns:a="http://schemas.openxmlformats.org/drawingml/2006/main">
               <a:ext uri="{FF2B5EF4-FFF2-40B4-BE49-F238E27FC236}">
-                <a16:creationId xmlns:a16="http://schemas.microsoft.com/office/drawing/2014/main" id="{318E0669-D38A-402E-B4C2-86D54FD051D1}"/>
+                <a16:creationId xmlns:a16="http://schemas.microsoft.com/office/drawing/2014/main" id="{C54BCE00-1C0F-46BA-B566-66D92F471129}"/>
               </a:ext>
             </a:extLst>
           </p:cNvPr>
@@ -4193,7 +4193,7 @@
           <p:cNvPr id="2" name="">
             <a:extLst xmlns:a="http://schemas.openxmlformats.org/drawingml/2006/main">
               <a:ext uri="{FF2B5EF4-FFF2-40B4-BE49-F238E27FC236}">
-                <a16:creationId xmlns:a16="http://schemas.microsoft.com/office/drawing/2014/main" id="{4BA2FBA5-3E51-4FE9-955A-D11235FDA992}"/>
+                <a16:creationId xmlns:a16="http://schemas.microsoft.com/office/drawing/2014/main" id="{1FB26A3D-8033-46A5-86AD-AE6C24771A11}"/>
               </a:ext>
             </a:extLst>
           </p:cNvPr>
@@ -4250,7 +4250,7 @@
           <p:cNvPr id="3" name="">
             <a:extLst xmlns:a="http://schemas.openxmlformats.org/drawingml/2006/main">
               <a:ext uri="{FF2B5EF4-FFF2-40B4-BE49-F238E27FC236}">
-                <a16:creationId xmlns:a16="http://schemas.microsoft.com/office/drawing/2014/main" id="{90AB2FA8-55E4-494F-B629-AA3E7232839F}"/>
+                <a16:creationId xmlns:a16="http://schemas.microsoft.com/office/drawing/2014/main" id="{D856C706-6BC1-4139-9A8A-01DA94C28182}"/>
               </a:ext>
             </a:extLst>
           </p:cNvPr>
@@ -4280,7 +4280,7 @@
           <p:cNvPr id="4" name="">
             <a:extLst xmlns:a="http://schemas.openxmlformats.org/drawingml/2006/main">
               <a:ext uri="{FF2B5EF4-FFF2-40B4-BE49-F238E27FC236}">
-                <a16:creationId xmlns:a16="http://schemas.microsoft.com/office/drawing/2014/main" id="{39CCF4ED-539F-4B72-8A48-30BD2CBC7576}"/>
+                <a16:creationId xmlns:a16="http://schemas.microsoft.com/office/drawing/2014/main" id="{3262191A-2759-4E8F-B570-F8A17281BB16}"/>
               </a:ext>
             </a:extLst>
           </p:cNvPr>
@@ -4337,7 +4337,7 @@
           <p:cNvPr id="5" name="">
             <a:extLst xmlns:a="http://schemas.openxmlformats.org/drawingml/2006/main">
               <a:ext uri="{FF2B5EF4-FFF2-40B4-BE49-F238E27FC236}">
-                <a16:creationId xmlns:a16="http://schemas.microsoft.com/office/drawing/2014/main" id="{743AFC7B-15FC-47CF-9AE4-5FF684FDA01C}"/>
+                <a16:creationId xmlns:a16="http://schemas.microsoft.com/office/drawing/2014/main" id="{D8BBD1E5-A40F-476A-87F7-16C67C99633E}"/>
               </a:ext>
             </a:extLst>
           </p:cNvPr>
@@ -4394,7 +4394,7 @@
           <p:cNvPr id="6" name="">
             <a:extLst xmlns:a="http://schemas.openxmlformats.org/drawingml/2006/main">
               <a:ext uri="{FF2B5EF4-FFF2-40B4-BE49-F238E27FC236}">
-                <a16:creationId xmlns:a16="http://schemas.microsoft.com/office/drawing/2014/main" id="{81F5BE21-20F8-48F5-BB12-313168B20BF5}"/>
+                <a16:creationId xmlns:a16="http://schemas.microsoft.com/office/drawing/2014/main" id="{AF5DADFA-346E-4394-8C5F-D64A6C02AE12}"/>
               </a:ext>
             </a:extLst>
           </p:cNvPr>
@@ -4428,7 +4428,7 @@
           <p:cNvPr id="7" name="">
             <a:extLst xmlns:a="http://schemas.openxmlformats.org/drawingml/2006/main">
               <a:ext uri="{FF2B5EF4-FFF2-40B4-BE49-F238E27FC236}">
-                <a16:creationId xmlns:a16="http://schemas.microsoft.com/office/drawing/2014/main" id="{07211CED-AD92-4C74-830B-01181ECD419F}"/>
+                <a16:creationId xmlns:a16="http://schemas.microsoft.com/office/drawing/2014/main" id="{9AEB5FB6-C8AB-48D7-844F-AAF33DAA385A}"/>
               </a:ext>
             </a:extLst>
           </p:cNvPr>
@@ -4460,7 +4460,7 @@
           <p:cNvPr id="8" name="">
             <a:extLst xmlns:a="http://schemas.openxmlformats.org/drawingml/2006/main">
               <a:ext uri="{FF2B5EF4-FFF2-40B4-BE49-F238E27FC236}">
-                <a16:creationId xmlns:a16="http://schemas.microsoft.com/office/drawing/2014/main" id="{6F702748-B69F-46F8-920A-CE39A8EBE107}"/>
+                <a16:creationId xmlns:a16="http://schemas.microsoft.com/office/drawing/2014/main" id="{01270EC1-0490-4DE6-9831-B88C6BAC97C1}"/>
               </a:ext>
             </a:extLst>
           </p:cNvPr>
@@ -4517,7 +4517,7 @@
           <p:cNvPr id="9" name="">
             <a:extLst xmlns:a="http://schemas.openxmlformats.org/drawingml/2006/main">
               <a:ext uri="{FF2B5EF4-FFF2-40B4-BE49-F238E27FC236}">
-                <a16:creationId xmlns:a16="http://schemas.microsoft.com/office/drawing/2014/main" id="{D8DC00B0-57F9-4DCE-B009-5EFBBB21911D}"/>
+                <a16:creationId xmlns:a16="http://schemas.microsoft.com/office/drawing/2014/main" id="{CA0F10BA-180B-4E08-A6B0-D214DC0B2891}"/>
               </a:ext>
             </a:extLst>
           </p:cNvPr>
@@ -4574,7 +4574,7 @@
           <p:cNvPr id="10" name="">
             <a:extLst xmlns:a="http://schemas.openxmlformats.org/drawingml/2006/main">
               <a:ext uri="{FF2B5EF4-FFF2-40B4-BE49-F238E27FC236}">
-                <a16:creationId xmlns:a16="http://schemas.microsoft.com/office/drawing/2014/main" id="{68C51C1F-5B42-4120-80BD-5CBCC6E0089A}"/>
+                <a16:creationId xmlns:a16="http://schemas.microsoft.com/office/drawing/2014/main" id="{AA084EEB-CAA3-4B42-A15F-F6E231B1F9BA}"/>
               </a:ext>
             </a:extLst>
           </p:cNvPr>
@@ -4631,7 +4631,7 @@
           <p:cNvPr id="11" name="">
             <a:extLst xmlns:a="http://schemas.openxmlformats.org/drawingml/2006/main">
               <a:ext uri="{FF2B5EF4-FFF2-40B4-BE49-F238E27FC236}">
-                <a16:creationId xmlns:a16="http://schemas.microsoft.com/office/drawing/2014/main" id="{44F1BDE0-A7A4-4BC3-BCC1-2553358F84F7}"/>
+                <a16:creationId xmlns:a16="http://schemas.microsoft.com/office/drawing/2014/main" id="{5D55987B-39B6-4029-A831-28BFFAFF0EAA}"/>
               </a:ext>
             </a:extLst>
           </p:cNvPr>
@@ -4661,7 +4661,7 @@
           <p:cNvPr id="12" name="">
             <a:extLst xmlns:a="http://schemas.openxmlformats.org/drawingml/2006/main">
               <a:ext uri="{FF2B5EF4-FFF2-40B4-BE49-F238E27FC236}">
-                <a16:creationId xmlns:a16="http://schemas.microsoft.com/office/drawing/2014/main" id="{4CFA9F30-C351-4468-8969-7B18DC1CEE88}"/>
+                <a16:creationId xmlns:a16="http://schemas.microsoft.com/office/drawing/2014/main" id="{B55B9E1A-5476-4639-9DE7-96C35576A2F9}"/>
               </a:ext>
             </a:extLst>
           </p:cNvPr>
@@ -4695,7 +4695,7 @@
           <p:cNvPr id="13" name="">
             <a:extLst xmlns:a="http://schemas.openxmlformats.org/drawingml/2006/main">
               <a:ext uri="{FF2B5EF4-FFF2-40B4-BE49-F238E27FC236}">
-                <a16:creationId xmlns:a16="http://schemas.microsoft.com/office/drawing/2014/main" id="{ECAE0F05-2DA2-452D-8756-0D2092233D7B}"/>
+                <a16:creationId xmlns:a16="http://schemas.microsoft.com/office/drawing/2014/main" id="{45834AB0-D07B-41CD-B9F2-D56C7F5037A3}"/>
               </a:ext>
             </a:extLst>
           </p:cNvPr>
@@ -4727,7 +4727,7 @@
           <p:cNvPr id="14" name="">
             <a:extLst xmlns:a="http://schemas.openxmlformats.org/drawingml/2006/main">
               <a:ext uri="{FF2B5EF4-FFF2-40B4-BE49-F238E27FC236}">
-                <a16:creationId xmlns:a16="http://schemas.microsoft.com/office/drawing/2014/main" id="{4C103511-C667-4C0B-A5BC-08F5450B0FAC}"/>
+                <a16:creationId xmlns:a16="http://schemas.microsoft.com/office/drawing/2014/main" id="{D67DB4CC-7208-40E8-AB9D-CA85A8084CAA}"/>
               </a:ext>
             </a:extLst>
           </p:cNvPr>
@@ -4784,7 +4784,7 @@
           <p:cNvPr id="15" name="">
             <a:extLst xmlns:a="http://schemas.openxmlformats.org/drawingml/2006/main">
               <a:ext uri="{FF2B5EF4-FFF2-40B4-BE49-F238E27FC236}">
-                <a16:creationId xmlns:a16="http://schemas.microsoft.com/office/drawing/2014/main" id="{964C3ED9-B129-4064-849F-9DC4533188EB}"/>
+                <a16:creationId xmlns:a16="http://schemas.microsoft.com/office/drawing/2014/main" id="{136FAE2F-C537-4FBF-86BB-B7B43AC84E05}"/>
               </a:ext>
             </a:extLst>
           </p:cNvPr>
@@ -4841,7 +4841,7 @@
           <p:cNvPr id="16" name="">
             <a:extLst xmlns:a="http://schemas.openxmlformats.org/drawingml/2006/main">
               <a:ext uri="{FF2B5EF4-FFF2-40B4-BE49-F238E27FC236}">
-                <a16:creationId xmlns:a16="http://schemas.microsoft.com/office/drawing/2014/main" id="{AE944B74-A9EB-42C5-9EFD-AB58CE9D1985}"/>
+                <a16:creationId xmlns:a16="http://schemas.microsoft.com/office/drawing/2014/main" id="{A6AB38D7-0863-4AFD-A4C8-6723DF064448}"/>
               </a:ext>
             </a:extLst>
           </p:cNvPr>
@@ -4898,7 +4898,7 @@
           <p:cNvPr id="17" name="">
             <a:extLst xmlns:a="http://schemas.openxmlformats.org/drawingml/2006/main">
               <a:ext uri="{FF2B5EF4-FFF2-40B4-BE49-F238E27FC236}">
-                <a16:creationId xmlns:a16="http://schemas.microsoft.com/office/drawing/2014/main" id="{EF8B65FB-06A3-4F8B-A4E5-A1593E6B11CB}"/>
+                <a16:creationId xmlns:a16="http://schemas.microsoft.com/office/drawing/2014/main" id="{385A7F39-20D8-4958-A91C-69CED28828D8}"/>
               </a:ext>
             </a:extLst>
           </p:cNvPr>
@@ -4928,7 +4928,7 @@
           <p:cNvPr id="18" name="">
             <a:extLst xmlns:a="http://schemas.openxmlformats.org/drawingml/2006/main">
               <a:ext uri="{FF2B5EF4-FFF2-40B4-BE49-F238E27FC236}">
-                <a16:creationId xmlns:a16="http://schemas.microsoft.com/office/drawing/2014/main" id="{067E09DA-AF87-43CD-B129-C1CB5D4368CD}"/>
+                <a16:creationId xmlns:a16="http://schemas.microsoft.com/office/drawing/2014/main" id="{896FE9AC-3450-46E7-8AFC-9FEC5FAB8397}"/>
               </a:ext>
             </a:extLst>
           </p:cNvPr>
@@ -4962,7 +4962,7 @@
           <p:cNvPr id="19" name="">
             <a:extLst xmlns:a="http://schemas.openxmlformats.org/drawingml/2006/main">
               <a:ext uri="{FF2B5EF4-FFF2-40B4-BE49-F238E27FC236}">
-                <a16:creationId xmlns:a16="http://schemas.microsoft.com/office/drawing/2014/main" id="{14E04519-2865-455D-B102-61F370D2D2C8}"/>
+                <a16:creationId xmlns:a16="http://schemas.microsoft.com/office/drawing/2014/main" id="{8FA33EEA-9390-4BA7-8B05-2BD0ABFC07A7}"/>
               </a:ext>
             </a:extLst>
           </p:cNvPr>
@@ -4994,7 +4994,7 @@
           <p:cNvPr id="20" name="">
             <a:extLst xmlns:a="http://schemas.openxmlformats.org/drawingml/2006/main">
               <a:ext uri="{FF2B5EF4-FFF2-40B4-BE49-F238E27FC236}">
-                <a16:creationId xmlns:a16="http://schemas.microsoft.com/office/drawing/2014/main" id="{F50E2F10-2E95-4695-8A20-C10287167865}"/>
+                <a16:creationId xmlns:a16="http://schemas.microsoft.com/office/drawing/2014/main" id="{A4350722-AC0C-4121-9FA8-FAE0ACAF3CF7}"/>
               </a:ext>
             </a:extLst>
           </p:cNvPr>
@@ -5051,7 +5051,7 @@
           <p:cNvPr id="21" name="">
             <a:extLst xmlns:a="http://schemas.openxmlformats.org/drawingml/2006/main">
               <a:ext uri="{FF2B5EF4-FFF2-40B4-BE49-F238E27FC236}">
-                <a16:creationId xmlns:a16="http://schemas.microsoft.com/office/drawing/2014/main" id="{05B09DA5-730F-44F1-9F33-59B6990A89FF}"/>
+                <a16:creationId xmlns:a16="http://schemas.microsoft.com/office/drawing/2014/main" id="{721526A4-9002-492B-97FB-65B6D03D4603}"/>
               </a:ext>
             </a:extLst>
           </p:cNvPr>
@@ -5108,7 +5108,7 @@
           <p:cNvPr id="22" name="">
             <a:extLst xmlns:a="http://schemas.openxmlformats.org/drawingml/2006/main">
               <a:ext uri="{FF2B5EF4-FFF2-40B4-BE49-F238E27FC236}">
-                <a16:creationId xmlns:a16="http://schemas.microsoft.com/office/drawing/2014/main" id="{8F9D6037-146F-4AD9-A78F-BAFE46DF0EDB}"/>
+                <a16:creationId xmlns:a16="http://schemas.microsoft.com/office/drawing/2014/main" id="{50090DEB-BFEC-43A6-9D41-E084BE42F853}"/>
               </a:ext>
             </a:extLst>
           </p:cNvPr>
@@ -5165,7 +5165,7 @@
           <p:cNvPr id="23" name="">
             <a:extLst xmlns:a="http://schemas.openxmlformats.org/drawingml/2006/main">
               <a:ext uri="{FF2B5EF4-FFF2-40B4-BE49-F238E27FC236}">
-                <a16:creationId xmlns:a16="http://schemas.microsoft.com/office/drawing/2014/main" id="{0ADA2A04-4A29-4814-9F1C-E4ADC4D2D7BD}"/>
+                <a16:creationId xmlns:a16="http://schemas.microsoft.com/office/drawing/2014/main" id="{E0629DE7-F42E-458B-8EA9-156882BADF3F}"/>
               </a:ext>
             </a:extLst>
           </p:cNvPr>
@@ -5195,7 +5195,7 @@
           <p:cNvPr id="24" name="">
             <a:extLst xmlns:a="http://schemas.openxmlformats.org/drawingml/2006/main">
               <a:ext uri="{FF2B5EF4-FFF2-40B4-BE49-F238E27FC236}">
-                <a16:creationId xmlns:a16="http://schemas.microsoft.com/office/drawing/2014/main" id="{2CD456EF-33AB-423E-A3F8-6072B182DAE5}"/>
+                <a16:creationId xmlns:a16="http://schemas.microsoft.com/office/drawing/2014/main" id="{09915B2A-E60C-4D21-AF70-A78A4E8D7B60}"/>
               </a:ext>
             </a:extLst>
           </p:cNvPr>
@@ -5229,7 +5229,7 @@
           <p:cNvPr id="25" name="">
             <a:extLst xmlns:a="http://schemas.openxmlformats.org/drawingml/2006/main">
               <a:ext uri="{FF2B5EF4-FFF2-40B4-BE49-F238E27FC236}">
-                <a16:creationId xmlns:a16="http://schemas.microsoft.com/office/drawing/2014/main" id="{5AD05741-1E70-4783-BB0D-772406FD5502}"/>
+                <a16:creationId xmlns:a16="http://schemas.microsoft.com/office/drawing/2014/main" id="{1A8ACAC1-8ADC-447E-8524-61E9611BD1AB}"/>
               </a:ext>
             </a:extLst>
           </p:cNvPr>
@@ -5261,7 +5261,7 @@
           <p:cNvPr id="26" name="">
             <a:extLst xmlns:a="http://schemas.openxmlformats.org/drawingml/2006/main">
               <a:ext uri="{FF2B5EF4-FFF2-40B4-BE49-F238E27FC236}">
-                <a16:creationId xmlns:a16="http://schemas.microsoft.com/office/drawing/2014/main" id="{56D857B6-F301-468F-AC69-0D9D209BF260}"/>
+                <a16:creationId xmlns:a16="http://schemas.microsoft.com/office/drawing/2014/main" id="{6C817142-B504-4613-9874-BAE617563FFF}"/>
               </a:ext>
             </a:extLst>
           </p:cNvPr>
@@ -5318,7 +5318,7 @@
           <p:cNvPr id="27" name="">
             <a:extLst xmlns:a="http://schemas.openxmlformats.org/drawingml/2006/main">
               <a:ext uri="{FF2B5EF4-FFF2-40B4-BE49-F238E27FC236}">
-                <a16:creationId xmlns:a16="http://schemas.microsoft.com/office/drawing/2014/main" id="{548A680E-7381-4D8E-87EC-2B4DFEDFFFE4}"/>
+                <a16:creationId xmlns:a16="http://schemas.microsoft.com/office/drawing/2014/main" id="{A30CE130-77F5-4912-9C9E-8AAE171C2188}"/>
               </a:ext>
             </a:extLst>
           </p:cNvPr>
@@ -5375,7 +5375,7 @@
           <p:cNvPr id="28" name="">
             <a:extLst xmlns:a="http://schemas.openxmlformats.org/drawingml/2006/main">
               <a:ext uri="{FF2B5EF4-FFF2-40B4-BE49-F238E27FC236}">
-                <a16:creationId xmlns:a16="http://schemas.microsoft.com/office/drawing/2014/main" id="{8E70BD24-7A95-40EA-B7B5-0E52167B2C7D}"/>
+                <a16:creationId xmlns:a16="http://schemas.microsoft.com/office/drawing/2014/main" id="{DB3634BF-F12C-47BB-94BD-969F3E5C8B8C}"/>
               </a:ext>
             </a:extLst>
           </p:cNvPr>
@@ -5432,7 +5432,7 @@
           <p:cNvPr id="29" name="">
             <a:extLst xmlns:a="http://schemas.openxmlformats.org/drawingml/2006/main">
               <a:ext uri="{FF2B5EF4-FFF2-40B4-BE49-F238E27FC236}">
-                <a16:creationId xmlns:a16="http://schemas.microsoft.com/office/drawing/2014/main" id="{E3C9C6C5-ABB1-40F1-B91F-75A12A6BD3DC}"/>
+                <a16:creationId xmlns:a16="http://schemas.microsoft.com/office/drawing/2014/main" id="{EE491FEC-78CE-486A-AF22-0F6670D0A70C}"/>
               </a:ext>
             </a:extLst>
           </p:cNvPr>
@@ -5462,7 +5462,7 @@
           <p:cNvPr id="30" name="">
             <a:extLst xmlns:a="http://schemas.openxmlformats.org/drawingml/2006/main">
               <a:ext uri="{FF2B5EF4-FFF2-40B4-BE49-F238E27FC236}">
-                <a16:creationId xmlns:a16="http://schemas.microsoft.com/office/drawing/2014/main" id="{8E2267C5-C956-411F-814B-8053B03115D9}"/>
+                <a16:creationId xmlns:a16="http://schemas.microsoft.com/office/drawing/2014/main" id="{557AA3BD-2DEF-4C4A-A862-3BBB54C9D229}"/>
               </a:ext>
             </a:extLst>
           </p:cNvPr>
@@ -5496,7 +5496,7 @@
           <p:cNvPr id="31" name="">
             <a:extLst xmlns:a="http://schemas.openxmlformats.org/drawingml/2006/main">
               <a:ext uri="{FF2B5EF4-FFF2-40B4-BE49-F238E27FC236}">
-                <a16:creationId xmlns:a16="http://schemas.microsoft.com/office/drawing/2014/main" id="{D0265A7F-D491-4327-BF7B-6C2709FB1F4A}"/>
+                <a16:creationId xmlns:a16="http://schemas.microsoft.com/office/drawing/2014/main" id="{42F1C0C9-28C4-419F-B640-0E60DB2C7F1C}"/>
               </a:ext>
             </a:extLst>
           </p:cNvPr>
@@ -5528,7 +5528,7 @@
           <p:cNvPr id="32" name="">
             <a:extLst xmlns:a="http://schemas.openxmlformats.org/drawingml/2006/main">
               <a:ext uri="{FF2B5EF4-FFF2-40B4-BE49-F238E27FC236}">
-                <a16:creationId xmlns:a16="http://schemas.microsoft.com/office/drawing/2014/main" id="{E8832A62-56B3-493A-8AD4-19EEE137F45C}"/>
+                <a16:creationId xmlns:a16="http://schemas.microsoft.com/office/drawing/2014/main" id="{505C77D9-6EA8-4DD6-B951-DB41C5149BB0}"/>
               </a:ext>
             </a:extLst>
           </p:cNvPr>
@@ -5585,7 +5585,7 @@
           <p:cNvPr id="33" name="">
             <a:extLst xmlns:a="http://schemas.openxmlformats.org/drawingml/2006/main">
               <a:ext uri="{FF2B5EF4-FFF2-40B4-BE49-F238E27FC236}">
-                <a16:creationId xmlns:a16="http://schemas.microsoft.com/office/drawing/2014/main" id="{B4F8EF55-9B76-481F-8B66-D9D45122CA76}"/>
+                <a16:creationId xmlns:a16="http://schemas.microsoft.com/office/drawing/2014/main" id="{5590A043-6375-4EBF-A3F3-E3D3D9E1FA49}"/>
               </a:ext>
             </a:extLst>
           </p:cNvPr>
@@ -5642,7 +5642,7 @@
           <p:cNvPr id="34" name="">
             <a:extLst xmlns:a="http://schemas.openxmlformats.org/drawingml/2006/main">
               <a:ext uri="{FF2B5EF4-FFF2-40B4-BE49-F238E27FC236}">
-                <a16:creationId xmlns:a16="http://schemas.microsoft.com/office/drawing/2014/main" id="{6CCD6E2E-87D3-4825-97F4-A12853FA54D6}"/>
+                <a16:creationId xmlns:a16="http://schemas.microsoft.com/office/drawing/2014/main" id="{53CE8DA6-6638-4B94-B1FD-079ED4AD0D52}"/>
               </a:ext>
             </a:extLst>
           </p:cNvPr>
@@ -5699,7 +5699,7 @@
           <p:cNvPr id="35" name="">
             <a:extLst xmlns:a="http://schemas.openxmlformats.org/drawingml/2006/main">
               <a:ext uri="{FF2B5EF4-FFF2-40B4-BE49-F238E27FC236}">
-                <a16:creationId xmlns:a16="http://schemas.microsoft.com/office/drawing/2014/main" id="{3AD379A4-002F-4AD1-88BA-DED370AAB623}"/>
+                <a16:creationId xmlns:a16="http://schemas.microsoft.com/office/drawing/2014/main" id="{F6064164-23C9-44C7-B640-1C6D2B1157BE}"/>
               </a:ext>
             </a:extLst>
           </p:cNvPr>
@@ -5729,7 +5729,7 @@
           <p:cNvPr id="36" name="">
             <a:extLst xmlns:a="http://schemas.openxmlformats.org/drawingml/2006/main">
               <a:ext uri="{FF2B5EF4-FFF2-40B4-BE49-F238E27FC236}">
-                <a16:creationId xmlns:a16="http://schemas.microsoft.com/office/drawing/2014/main" id="{3A43C2AE-B467-4E4B-B7B8-4975B18F810C}"/>
+                <a16:creationId xmlns:a16="http://schemas.microsoft.com/office/drawing/2014/main" id="{6EAFC55A-5071-453A-B400-7261430D1EED}"/>
               </a:ext>
             </a:extLst>
           </p:cNvPr>
@@ -5763,7 +5763,7 @@
           <p:cNvPr id="37" name="">
             <a:extLst xmlns:a="http://schemas.openxmlformats.org/drawingml/2006/main">
               <a:ext uri="{FF2B5EF4-FFF2-40B4-BE49-F238E27FC236}">
-                <a16:creationId xmlns:a16="http://schemas.microsoft.com/office/drawing/2014/main" id="{2E002304-1EDC-40C5-A0DE-703873E6256C}"/>
+                <a16:creationId xmlns:a16="http://schemas.microsoft.com/office/drawing/2014/main" id="{F40D1F67-7448-48F1-BFD6-06570E300B89}"/>
               </a:ext>
             </a:extLst>
           </p:cNvPr>
@@ -5795,7 +5795,7 @@
           <p:cNvPr id="38" name="">
             <a:extLst xmlns:a="http://schemas.openxmlformats.org/drawingml/2006/main">
               <a:ext uri="{FF2B5EF4-FFF2-40B4-BE49-F238E27FC236}">
-                <a16:creationId xmlns:a16="http://schemas.microsoft.com/office/drawing/2014/main" id="{4CA30F29-26B9-4908-91C5-F5E1AA6EBA53}"/>
+                <a16:creationId xmlns:a16="http://schemas.microsoft.com/office/drawing/2014/main" id="{FB712458-A63B-437D-AE49-D245D8C64F97}"/>
               </a:ext>
             </a:extLst>
           </p:cNvPr>
@@ -5852,7 +5852,7 @@
           <p:cNvPr id="39" name="">
             <a:extLst xmlns:a="http://schemas.openxmlformats.org/drawingml/2006/main">
               <a:ext uri="{FF2B5EF4-FFF2-40B4-BE49-F238E27FC236}">
-                <a16:creationId xmlns:a16="http://schemas.microsoft.com/office/drawing/2014/main" id="{E1B43935-9D44-4ACE-976C-391E5B09C221}"/>
+                <a16:creationId xmlns:a16="http://schemas.microsoft.com/office/drawing/2014/main" id="{EDA0F901-0AB3-4214-ABE9-0457C137BDBF}"/>
               </a:ext>
             </a:extLst>
           </p:cNvPr>
@@ -5909,7 +5909,7 @@
           <p:cNvPr id="40" name="">
             <a:extLst xmlns:a="http://schemas.openxmlformats.org/drawingml/2006/main">
               <a:ext uri="{FF2B5EF4-FFF2-40B4-BE49-F238E27FC236}">
-                <a16:creationId xmlns:a16="http://schemas.microsoft.com/office/drawing/2014/main" id="{0BAF0A6E-8C64-4EC3-B7C2-417374E2646D}"/>
+                <a16:creationId xmlns:a16="http://schemas.microsoft.com/office/drawing/2014/main" id="{FA517CE7-EB64-44BE-9ACD-2CB535E0C80E}"/>
               </a:ext>
             </a:extLst>
           </p:cNvPr>
@@ -5966,7 +5966,7 @@
           <p:cNvPr id="41" name="">
             <a:extLst xmlns:a="http://schemas.openxmlformats.org/drawingml/2006/main">
               <a:ext uri="{FF2B5EF4-FFF2-40B4-BE49-F238E27FC236}">
-                <a16:creationId xmlns:a16="http://schemas.microsoft.com/office/drawing/2014/main" id="{D8AC0ABA-3777-4639-A155-A0EBAED7AE62}"/>
+                <a16:creationId xmlns:a16="http://schemas.microsoft.com/office/drawing/2014/main" id="{7E6B29F5-4399-4058-BAC8-72B37F3DFD24}"/>
               </a:ext>
             </a:extLst>
           </p:cNvPr>
@@ -5998,7 +5998,7 @@
           <p:cNvPr id="42" name="">
             <a:extLst xmlns:a="http://schemas.openxmlformats.org/drawingml/2006/main">
               <a:ext uri="{FF2B5EF4-FFF2-40B4-BE49-F238E27FC236}">
-                <a16:creationId xmlns:a16="http://schemas.microsoft.com/office/drawing/2014/main" id="{B4936082-1A4A-4680-9FC9-8BCEA87143EE}"/>
+                <a16:creationId xmlns:a16="http://schemas.microsoft.com/office/drawing/2014/main" id="{46CD561A-87E7-4881-BC98-B398F457AD8D}"/>
               </a:ext>
             </a:extLst>
           </p:cNvPr>
@@ -6055,7 +6055,7 @@
           <p:cNvPr id="43" name="">
             <a:extLst xmlns:a="http://schemas.openxmlformats.org/drawingml/2006/main">
               <a:ext uri="{FF2B5EF4-FFF2-40B4-BE49-F238E27FC236}">
-                <a16:creationId xmlns:a16="http://schemas.microsoft.com/office/drawing/2014/main" id="{7FBAA86D-AEC0-484B-8543-3CDA8FC02BF1}"/>
+                <a16:creationId xmlns:a16="http://schemas.microsoft.com/office/drawing/2014/main" id="{D604298F-DF6F-4C53-BE37-32BF937EA788}"/>
               </a:ext>
             </a:extLst>
           </p:cNvPr>
@@ -6112,7 +6112,7 @@
           <p:cNvPr id="44" name="">
             <a:extLst xmlns:a="http://schemas.openxmlformats.org/drawingml/2006/main">
               <a:ext uri="{FF2B5EF4-FFF2-40B4-BE49-F238E27FC236}">
-                <a16:creationId xmlns:a16="http://schemas.microsoft.com/office/drawing/2014/main" id="{F41ECABA-0AD8-41D0-BB7F-31FD642F7B92}"/>
+                <a16:creationId xmlns:a16="http://schemas.microsoft.com/office/drawing/2014/main" id="{2BF517D5-D9DE-42B4-AD4A-3D3D311B48EF}"/>
               </a:ext>
             </a:extLst>
           </p:cNvPr>
@@ -6169,7 +6169,7 @@
           <p:cNvPr id="45" name="">
             <a:extLst xmlns:a="http://schemas.openxmlformats.org/drawingml/2006/main">
               <a:ext uri="{FF2B5EF4-FFF2-40B4-BE49-F238E27FC236}">
-                <a16:creationId xmlns:a16="http://schemas.microsoft.com/office/drawing/2014/main" id="{B2FF0ADC-B841-41BF-8967-F6A97A42C29B}"/>
+                <a16:creationId xmlns:a16="http://schemas.microsoft.com/office/drawing/2014/main" id="{839FB54A-A2E8-40A1-B5D0-4BCC3BB078C4}"/>
               </a:ext>
             </a:extLst>
           </p:cNvPr>
@@ -6226,7 +6226,7 @@
           <p:cNvPr id="46" name="">
             <a:extLst xmlns:a="http://schemas.openxmlformats.org/drawingml/2006/main">
               <a:ext uri="{FF2B5EF4-FFF2-40B4-BE49-F238E27FC236}">
-                <a16:creationId xmlns:a16="http://schemas.microsoft.com/office/drawing/2014/main" id="{DFA25735-3B43-485A-BBE3-D957AC54086C}"/>
+                <a16:creationId xmlns:a16="http://schemas.microsoft.com/office/drawing/2014/main" id="{DDD383B0-0982-4147-9B77-1D5BF2B70CDE}"/>
               </a:ext>
             </a:extLst>
           </p:cNvPr>
@@ -6283,7 +6283,7 @@
           <p:cNvPr id="47" name="">
             <a:extLst xmlns:a="http://schemas.openxmlformats.org/drawingml/2006/main">
               <a:ext uri="{FF2B5EF4-FFF2-40B4-BE49-F238E27FC236}">
-                <a16:creationId xmlns:a16="http://schemas.microsoft.com/office/drawing/2014/main" id="{D1970E87-0ABB-4BAB-A795-1D27F2773E42}"/>
+                <a16:creationId xmlns:a16="http://schemas.microsoft.com/office/drawing/2014/main" id="{A22D6975-F122-4418-8F1B-68CB500DF560}"/>
               </a:ext>
             </a:extLst>
           </p:cNvPr>
@@ -6340,7 +6340,7 @@
           <p:cNvPr id="48" name="">
             <a:extLst xmlns:a="http://schemas.openxmlformats.org/drawingml/2006/main">
               <a:ext uri="{FF2B5EF4-FFF2-40B4-BE49-F238E27FC236}">
-                <a16:creationId xmlns:a16="http://schemas.microsoft.com/office/drawing/2014/main" id="{272799D7-C7FE-43C1-AEE3-1B72A61E7CBF}"/>
+                <a16:creationId xmlns:a16="http://schemas.microsoft.com/office/drawing/2014/main" id="{26BED696-33D1-47B3-89DF-50431B560A0A}"/>
               </a:ext>
             </a:extLst>
           </p:cNvPr>
@@ -6397,7 +6397,7 @@
           <p:cNvPr id="49" name="">
             <a:extLst xmlns:a="http://schemas.openxmlformats.org/drawingml/2006/main">
               <a:ext uri="{FF2B5EF4-FFF2-40B4-BE49-F238E27FC236}">
-                <a16:creationId xmlns:a16="http://schemas.microsoft.com/office/drawing/2014/main" id="{908AC0DC-9240-44B5-81F4-F9771E978699}"/>
+                <a16:creationId xmlns:a16="http://schemas.microsoft.com/office/drawing/2014/main" id="{D7C03A36-5119-455C-8DE1-412F4497C9E7}"/>
               </a:ext>
             </a:extLst>
           </p:cNvPr>
@@ -6477,7 +6477,7 @@
           <p:cNvPr id="50" name="">
             <a:extLst xmlns:a="http://schemas.openxmlformats.org/drawingml/2006/main">
               <a:ext uri="{FF2B5EF4-FFF2-40B4-BE49-F238E27FC236}">
-                <a16:creationId xmlns:a16="http://schemas.microsoft.com/office/drawing/2014/main" id="{AD870773-FCCD-4626-BF7B-C621BC4BA533}"/>
+                <a16:creationId xmlns:a16="http://schemas.microsoft.com/office/drawing/2014/main" id="{4C730EFB-3D10-4865-82BE-23861229B3E7}"/>
               </a:ext>
             </a:extLst>
           </p:cNvPr>
@@ -6534,7 +6534,7 @@
           <p:cNvPr id="51" name="">
             <a:extLst xmlns:a="http://schemas.openxmlformats.org/drawingml/2006/main">
               <a:ext uri="{FF2B5EF4-FFF2-40B4-BE49-F238E27FC236}">
-                <a16:creationId xmlns:a16="http://schemas.microsoft.com/office/drawing/2014/main" id="{08DD966C-B091-472F-8AFA-34F2013A6C59}"/>
+                <a16:creationId xmlns:a16="http://schemas.microsoft.com/office/drawing/2014/main" id="{4B0293DD-0E49-4D19-A29A-694BCD519734}"/>
               </a:ext>
             </a:extLst>
           </p:cNvPr>
@@ -6614,7 +6614,7 @@
           <p:cNvPr id="52" name="">
             <a:extLst xmlns:a="http://schemas.openxmlformats.org/drawingml/2006/main">
               <a:ext uri="{FF2B5EF4-FFF2-40B4-BE49-F238E27FC236}">
-                <a16:creationId xmlns:a16="http://schemas.microsoft.com/office/drawing/2014/main" id="{74EB2997-03D6-4CB6-B6C0-9DDB3093AFBE}"/>
+                <a16:creationId xmlns:a16="http://schemas.microsoft.com/office/drawing/2014/main" id="{0E1904B7-6066-4EFA-BACC-F2FF26849AAB}"/>
               </a:ext>
             </a:extLst>
           </p:cNvPr>
@@ -6671,7 +6671,7 @@
           <p:cNvPr id="53" name="">
             <a:extLst xmlns:a="http://schemas.openxmlformats.org/drawingml/2006/main">
               <a:ext uri="{FF2B5EF4-FFF2-40B4-BE49-F238E27FC236}">
-                <a16:creationId xmlns:a16="http://schemas.microsoft.com/office/drawing/2014/main" id="{C7050CD6-D094-4BB9-84C0-F7AAE6ECDF83}"/>
+                <a16:creationId xmlns:a16="http://schemas.microsoft.com/office/drawing/2014/main" id="{6B7ACDC1-9A43-4DB6-9FE0-46826333945E}"/>
               </a:ext>
             </a:extLst>
           </p:cNvPr>
@@ -6751,7 +6751,7 @@
           <p:cNvPr id="54" name="">
             <a:extLst xmlns:a="http://schemas.openxmlformats.org/drawingml/2006/main">
               <a:ext uri="{FF2B5EF4-FFF2-40B4-BE49-F238E27FC236}">
-                <a16:creationId xmlns:a16="http://schemas.microsoft.com/office/drawing/2014/main" id="{A5A80BFC-0CD4-4FC2-B273-7B42FAFEFC80}"/>
+                <a16:creationId xmlns:a16="http://schemas.microsoft.com/office/drawing/2014/main" id="{48CB09C1-E5C1-4F4F-BF27-95743F9CCE8C}"/>
               </a:ext>
             </a:extLst>
           </p:cNvPr>
@@ -6783,7 +6783,7 @@
           <p:cNvPr id="55" name="">
             <a:extLst xmlns:a="http://schemas.openxmlformats.org/drawingml/2006/main">
               <a:ext uri="{FF2B5EF4-FFF2-40B4-BE49-F238E27FC236}">
-                <a16:creationId xmlns:a16="http://schemas.microsoft.com/office/drawing/2014/main" id="{905DE995-D2BE-45E1-B5E3-FE29D309B5AC}"/>
+                <a16:creationId xmlns:a16="http://schemas.microsoft.com/office/drawing/2014/main" id="{EB306481-6171-4FB0-A7C3-4AE05C7DA477}"/>
               </a:ext>
             </a:extLst>
           </p:cNvPr>
@@ -6838,7 +6838,7 @@
     </p:spTree>
     <p:extLst>
       <p:ext uri="{BB962C8B-B14F-4D97-AF65-F5344CB8AC3E}">
-        <p14:creationId xmlns:p14="http://schemas.microsoft.com/office/powerpoint/2010/main" val="504423062"/>
+        <p14:creationId xmlns:p14="http://schemas.microsoft.com/office/powerpoint/2010/main" val="288603465"/>
       </p:ext>
     </p:extLst>
   </p:cSld>
@@ -6869,7 +6869,7 @@
           <p:cNvPr id="41" name="">
             <a:extLst xmlns:a="http://schemas.openxmlformats.org/drawingml/2006/main">
               <a:ext uri="{FF2B5EF4-FFF2-40B4-BE49-F238E27FC236}">
-                <a16:creationId xmlns:a16="http://schemas.microsoft.com/office/drawing/2014/main" id="{3815459B-CF57-4251-A826-8CAEEEF15819}"/>
+                <a16:creationId xmlns:a16="http://schemas.microsoft.com/office/drawing/2014/main" id="{91FF1F08-F008-4785-9B55-6FAD6AC6D840}"/>
               </a:ext>
             </a:extLst>
           </p:cNvPr>
@@ -6899,7 +6899,7 @@
           <p:cNvPr id="2" name="">
             <a:extLst xmlns:a="http://schemas.openxmlformats.org/drawingml/2006/main">
               <a:ext uri="{FF2B5EF4-FFF2-40B4-BE49-F238E27FC236}">
-                <a16:creationId xmlns:a16="http://schemas.microsoft.com/office/drawing/2014/main" id="{7E5E45AB-98C8-496D-AC92-4F0C172816E1}"/>
+                <a16:creationId xmlns:a16="http://schemas.microsoft.com/office/drawing/2014/main" id="{606FA963-A8D8-4F71-8B2E-F55DB82437A1}"/>
               </a:ext>
             </a:extLst>
           </p:cNvPr>
@@ -6956,7 +6956,7 @@
           <p:cNvPr id="3" name="">
             <a:extLst xmlns:a="http://schemas.openxmlformats.org/drawingml/2006/main">
               <a:ext uri="{FF2B5EF4-FFF2-40B4-BE49-F238E27FC236}">
-                <a16:creationId xmlns:a16="http://schemas.microsoft.com/office/drawing/2014/main" id="{E19DFBD1-E4D9-42E0-9857-CA0DE2473B29}"/>
+                <a16:creationId xmlns:a16="http://schemas.microsoft.com/office/drawing/2014/main" id="{19CCA6BF-76C6-4AE8-8F69-BCF50D948CEC}"/>
               </a:ext>
             </a:extLst>
           </p:cNvPr>
@@ -6986,7 +6986,7 @@
           <p:cNvPr id="4" name="">
             <a:extLst xmlns:a="http://schemas.openxmlformats.org/drawingml/2006/main">
               <a:ext uri="{FF2B5EF4-FFF2-40B4-BE49-F238E27FC236}">
-                <a16:creationId xmlns:a16="http://schemas.microsoft.com/office/drawing/2014/main" id="{6C211A11-1DAF-4D2F-B2CB-731F648D970D}"/>
+                <a16:creationId xmlns:a16="http://schemas.microsoft.com/office/drawing/2014/main" id="{C1671335-9E4B-4137-835C-163381B0BA5E}"/>
               </a:ext>
             </a:extLst>
           </p:cNvPr>
@@ -7043,7 +7043,7 @@
           <p:cNvPr id="5" name="">
             <a:extLst xmlns:a="http://schemas.openxmlformats.org/drawingml/2006/main">
               <a:ext uri="{FF2B5EF4-FFF2-40B4-BE49-F238E27FC236}">
-                <a16:creationId xmlns:a16="http://schemas.microsoft.com/office/drawing/2014/main" id="{EB04A272-E146-4221-B3EE-B3143B5EF6A6}"/>
+                <a16:creationId xmlns:a16="http://schemas.microsoft.com/office/drawing/2014/main" id="{2F69188F-1FD1-48DD-9944-FC3A70F6534B}"/>
               </a:ext>
             </a:extLst>
           </p:cNvPr>
@@ -7100,7 +7100,7 @@
           <p:cNvPr id="6" name="">
             <a:extLst xmlns:a="http://schemas.openxmlformats.org/drawingml/2006/main">
               <a:ext uri="{FF2B5EF4-FFF2-40B4-BE49-F238E27FC236}">
-                <a16:creationId xmlns:a16="http://schemas.microsoft.com/office/drawing/2014/main" id="{CB4FDFCC-5ED9-42F6-B255-0E61FFA6A8AC}"/>
+                <a16:creationId xmlns:a16="http://schemas.microsoft.com/office/drawing/2014/main" id="{C7D567CC-257A-4BDD-98AB-E01ABA3B4B01}"/>
               </a:ext>
             </a:extLst>
           </p:cNvPr>
@@ -7157,7 +7157,7 @@
           <p:cNvPr id="7" name="">
             <a:extLst xmlns:a="http://schemas.openxmlformats.org/drawingml/2006/main">
               <a:ext uri="{FF2B5EF4-FFF2-40B4-BE49-F238E27FC236}">
-                <a16:creationId xmlns:a16="http://schemas.microsoft.com/office/drawing/2014/main" id="{6563DA24-94FE-47BF-B4D6-94C7BA8E2D53}"/>
+                <a16:creationId xmlns:a16="http://schemas.microsoft.com/office/drawing/2014/main" id="{3B117E09-F23C-46E8-A705-7136AF37F2BD}"/>
               </a:ext>
             </a:extLst>
           </p:cNvPr>
@@ -7187,7 +7187,7 @@
           <p:cNvPr id="8" name="">
             <a:extLst xmlns:a="http://schemas.openxmlformats.org/drawingml/2006/main">
               <a:ext uri="{FF2B5EF4-FFF2-40B4-BE49-F238E27FC236}">
-                <a16:creationId xmlns:a16="http://schemas.microsoft.com/office/drawing/2014/main" id="{EEC3D371-22CA-463B-8072-E891EF6087F6}"/>
+                <a16:creationId xmlns:a16="http://schemas.microsoft.com/office/drawing/2014/main" id="{A1AAC4F0-ED51-4DD2-BC1F-C23E6C52CB51}"/>
               </a:ext>
             </a:extLst>
           </p:cNvPr>
@@ -7244,7 +7244,7 @@
           <p:cNvPr id="9" name="">
             <a:extLst xmlns:a="http://schemas.openxmlformats.org/drawingml/2006/main">
               <a:ext uri="{FF2B5EF4-FFF2-40B4-BE49-F238E27FC236}">
-                <a16:creationId xmlns:a16="http://schemas.microsoft.com/office/drawing/2014/main" id="{C242A742-5936-4794-AEEC-947BB3782114}"/>
+                <a16:creationId xmlns:a16="http://schemas.microsoft.com/office/drawing/2014/main" id="{F175105E-4B59-49DF-9023-9D6E6C552682}"/>
               </a:ext>
             </a:extLst>
           </p:cNvPr>
@@ -7276,7 +7276,7 @@
           <p:cNvPr id="10" name="">
             <a:extLst xmlns:a="http://schemas.openxmlformats.org/drawingml/2006/main">
               <a:ext uri="{FF2B5EF4-FFF2-40B4-BE49-F238E27FC236}">
-                <a16:creationId xmlns:a16="http://schemas.microsoft.com/office/drawing/2014/main" id="{3B91C987-03D1-4FD6-BFD9-CF8895CF4C64}"/>
+                <a16:creationId xmlns:a16="http://schemas.microsoft.com/office/drawing/2014/main" id="{6BDC9029-3799-4DF6-B88A-BAE0BB242FB3}"/>
               </a:ext>
             </a:extLst>
           </p:cNvPr>
@@ -7333,7 +7333,7 @@
           <p:cNvPr id="11" name="">
             <a:extLst xmlns:a="http://schemas.openxmlformats.org/drawingml/2006/main">
               <a:ext uri="{FF2B5EF4-FFF2-40B4-BE49-F238E27FC236}">
-                <a16:creationId xmlns:a16="http://schemas.microsoft.com/office/drawing/2014/main" id="{F4D1EE15-1593-473A-90B3-82D52BDA4C9B}"/>
+                <a16:creationId xmlns:a16="http://schemas.microsoft.com/office/drawing/2014/main" id="{FA0D3BDA-641E-43F4-9C80-B182D4999732}"/>
               </a:ext>
             </a:extLst>
           </p:cNvPr>
@@ -7390,7 +7390,7 @@
           <p:cNvPr id="12" name="">
             <a:extLst xmlns:a="http://schemas.openxmlformats.org/drawingml/2006/main">
               <a:ext uri="{FF2B5EF4-FFF2-40B4-BE49-F238E27FC236}">
-                <a16:creationId xmlns:a16="http://schemas.microsoft.com/office/drawing/2014/main" id="{4E469951-2307-4094-BEA3-C595CE6D31F7}"/>
+                <a16:creationId xmlns:a16="http://schemas.microsoft.com/office/drawing/2014/main" id="{E517D86C-B5F0-49D6-8EFA-D955781E7C0B}"/>
               </a:ext>
             </a:extLst>
           </p:cNvPr>
@@ -7447,7 +7447,7 @@
           <p:cNvPr id="13" name="">
             <a:extLst xmlns:a="http://schemas.openxmlformats.org/drawingml/2006/main">
               <a:ext uri="{FF2B5EF4-FFF2-40B4-BE49-F238E27FC236}">
-                <a16:creationId xmlns:a16="http://schemas.microsoft.com/office/drawing/2014/main" id="{DA45FEA8-DF9D-41D9-80DD-B81B7EFF57BF}"/>
+                <a16:creationId xmlns:a16="http://schemas.microsoft.com/office/drawing/2014/main" id="{5F46BEC4-8B57-498B-9284-5CA8F9D9B326}"/>
               </a:ext>
             </a:extLst>
           </p:cNvPr>
@@ -7479,7 +7479,7 @@
           <p:cNvPr id="14" name="">
             <a:extLst xmlns:a="http://schemas.openxmlformats.org/drawingml/2006/main">
               <a:ext uri="{FF2B5EF4-FFF2-40B4-BE49-F238E27FC236}">
-                <a16:creationId xmlns:a16="http://schemas.microsoft.com/office/drawing/2014/main" id="{F7DB1C6E-3144-4B38-A0A4-33264FF29A7A}"/>
+                <a16:creationId xmlns:a16="http://schemas.microsoft.com/office/drawing/2014/main" id="{720E859E-54D7-4672-B7BA-CB3803C2D1E2}"/>
               </a:ext>
             </a:extLst>
           </p:cNvPr>
@@ -7536,7 +7536,7 @@
           <p:cNvPr id="15" name="">
             <a:extLst xmlns:a="http://schemas.openxmlformats.org/drawingml/2006/main">
               <a:ext uri="{FF2B5EF4-FFF2-40B4-BE49-F238E27FC236}">
-                <a16:creationId xmlns:a16="http://schemas.microsoft.com/office/drawing/2014/main" id="{8932742E-491D-4482-B921-C17A74DB0866}"/>
+                <a16:creationId xmlns:a16="http://schemas.microsoft.com/office/drawing/2014/main" id="{8BE11C9A-1772-4E80-8CB0-767EFA342EC7}"/>
               </a:ext>
             </a:extLst>
           </p:cNvPr>
@@ -7593,7 +7593,7 @@
           <p:cNvPr id="16" name="">
             <a:extLst xmlns:a="http://schemas.openxmlformats.org/drawingml/2006/main">
               <a:ext uri="{FF2B5EF4-FFF2-40B4-BE49-F238E27FC236}">
-                <a16:creationId xmlns:a16="http://schemas.microsoft.com/office/drawing/2014/main" id="{09E65209-ABB2-4A20-9810-408949539F54}"/>
+                <a16:creationId xmlns:a16="http://schemas.microsoft.com/office/drawing/2014/main" id="{9CFC009E-47C6-40F5-80C7-584D1D137162}"/>
               </a:ext>
             </a:extLst>
           </p:cNvPr>
@@ -7650,7 +7650,7 @@
           <p:cNvPr id="17" name="">
             <a:extLst xmlns:a="http://schemas.openxmlformats.org/drawingml/2006/main">
               <a:ext uri="{FF2B5EF4-FFF2-40B4-BE49-F238E27FC236}">
-                <a16:creationId xmlns:a16="http://schemas.microsoft.com/office/drawing/2014/main" id="{2913204F-D0B5-44BC-8BED-D99F65680A18}"/>
+                <a16:creationId xmlns:a16="http://schemas.microsoft.com/office/drawing/2014/main" id="{89D8904B-A5EC-435E-BE38-ECA294CF0F40}"/>
               </a:ext>
             </a:extLst>
           </p:cNvPr>
@@ -7682,7 +7682,7 @@
           <p:cNvPr id="18" name="">
             <a:extLst xmlns:a="http://schemas.openxmlformats.org/drawingml/2006/main">
               <a:ext uri="{FF2B5EF4-FFF2-40B4-BE49-F238E27FC236}">
-                <a16:creationId xmlns:a16="http://schemas.microsoft.com/office/drawing/2014/main" id="{A7E69037-B54F-48E9-91B6-4DCFDE272938}"/>
+                <a16:creationId xmlns:a16="http://schemas.microsoft.com/office/drawing/2014/main" id="{8A5C992A-696E-4D57-8A13-CA04A35EBEB9}"/>
               </a:ext>
             </a:extLst>
           </p:cNvPr>
@@ -7739,7 +7739,7 @@
           <p:cNvPr id="19" name="">
             <a:extLst xmlns:a="http://schemas.openxmlformats.org/drawingml/2006/main">
               <a:ext uri="{FF2B5EF4-FFF2-40B4-BE49-F238E27FC236}">
-                <a16:creationId xmlns:a16="http://schemas.microsoft.com/office/drawing/2014/main" id="{3D04F266-764D-470F-BB4C-2276891EA03A}"/>
+                <a16:creationId xmlns:a16="http://schemas.microsoft.com/office/drawing/2014/main" id="{E857F763-1E66-4BB5-BAF6-37277BE8F0F6}"/>
               </a:ext>
             </a:extLst>
           </p:cNvPr>
@@ -7796,7 +7796,7 @@
           <p:cNvPr id="20" name="">
             <a:extLst xmlns:a="http://schemas.openxmlformats.org/drawingml/2006/main">
               <a:ext uri="{FF2B5EF4-FFF2-40B4-BE49-F238E27FC236}">
-                <a16:creationId xmlns:a16="http://schemas.microsoft.com/office/drawing/2014/main" id="{26B981ED-C597-4841-BDFD-ADAC23CF3CAA}"/>
+                <a16:creationId xmlns:a16="http://schemas.microsoft.com/office/drawing/2014/main" id="{B9897190-FC2D-45A9-B0CF-B9F3EDAE6A1F}"/>
               </a:ext>
             </a:extLst>
           </p:cNvPr>
@@ -7853,7 +7853,7 @@
           <p:cNvPr id="21" name="">
             <a:extLst xmlns:a="http://schemas.openxmlformats.org/drawingml/2006/main">
               <a:ext uri="{FF2B5EF4-FFF2-40B4-BE49-F238E27FC236}">
-                <a16:creationId xmlns:a16="http://schemas.microsoft.com/office/drawing/2014/main" id="{C0879241-C278-4831-8C0E-D1D1DB76830B}"/>
+                <a16:creationId xmlns:a16="http://schemas.microsoft.com/office/drawing/2014/main" id="{6E25ABDC-9769-41F5-83E9-95DFC7BAB01D}"/>
               </a:ext>
             </a:extLst>
           </p:cNvPr>
@@ -7885,7 +7885,7 @@
           <p:cNvPr id="22" name="">
             <a:extLst xmlns:a="http://schemas.openxmlformats.org/drawingml/2006/main">
               <a:ext uri="{FF2B5EF4-FFF2-40B4-BE49-F238E27FC236}">
-                <a16:creationId xmlns:a16="http://schemas.microsoft.com/office/drawing/2014/main" id="{5E26CB9D-D464-4CFD-BE02-5F98652C2067}"/>
+                <a16:creationId xmlns:a16="http://schemas.microsoft.com/office/drawing/2014/main" id="{BE540E16-7220-4A50-9E55-5A1BFF01FC02}"/>
               </a:ext>
             </a:extLst>
           </p:cNvPr>
@@ -7942,7 +7942,7 @@
           <p:cNvPr id="23" name="">
             <a:extLst xmlns:a="http://schemas.openxmlformats.org/drawingml/2006/main">
               <a:ext uri="{FF2B5EF4-FFF2-40B4-BE49-F238E27FC236}">
-                <a16:creationId xmlns:a16="http://schemas.microsoft.com/office/drawing/2014/main" id="{E3B1B416-5F06-4766-B162-FFC9FAA96581}"/>
+                <a16:creationId xmlns:a16="http://schemas.microsoft.com/office/drawing/2014/main" id="{7052203D-D54C-46DE-AB50-8D655AFEC589}"/>
               </a:ext>
             </a:extLst>
           </p:cNvPr>
@@ -7999,7 +7999,7 @@
           <p:cNvPr id="24" name="">
             <a:extLst xmlns:a="http://schemas.openxmlformats.org/drawingml/2006/main">
               <a:ext uri="{FF2B5EF4-FFF2-40B4-BE49-F238E27FC236}">
-                <a16:creationId xmlns:a16="http://schemas.microsoft.com/office/drawing/2014/main" id="{54AB7B83-5D85-418D-9B61-B8B672AB4D71}"/>
+                <a16:creationId xmlns:a16="http://schemas.microsoft.com/office/drawing/2014/main" id="{52000C6D-3881-420A-8E8E-435D53B18DD9}"/>
               </a:ext>
             </a:extLst>
           </p:cNvPr>
@@ -8056,7 +8056,7 @@
           <p:cNvPr id="25" name="">
             <a:extLst xmlns:a="http://schemas.openxmlformats.org/drawingml/2006/main">
               <a:ext uri="{FF2B5EF4-FFF2-40B4-BE49-F238E27FC236}">
-                <a16:creationId xmlns:a16="http://schemas.microsoft.com/office/drawing/2014/main" id="{3873D89A-91D8-42C0-81F5-9119CEAF9CE7}"/>
+                <a16:creationId xmlns:a16="http://schemas.microsoft.com/office/drawing/2014/main" id="{338A4892-644C-469E-A98C-6D5592CE37A3}"/>
               </a:ext>
             </a:extLst>
           </p:cNvPr>
@@ -8088,7 +8088,7 @@
           <p:cNvPr id="26" name="">
             <a:extLst xmlns:a="http://schemas.openxmlformats.org/drawingml/2006/main">
               <a:ext uri="{FF2B5EF4-FFF2-40B4-BE49-F238E27FC236}">
-                <a16:creationId xmlns:a16="http://schemas.microsoft.com/office/drawing/2014/main" id="{1A70DDB9-D5BC-4256-93BE-44F029BCD5C7}"/>
+                <a16:creationId xmlns:a16="http://schemas.microsoft.com/office/drawing/2014/main" id="{8731F650-4C87-4FEB-8A6B-040D798B42DE}"/>
               </a:ext>
             </a:extLst>
           </p:cNvPr>
@@ -8145,7 +8145,7 @@
           <p:cNvPr id="27" name="">
             <a:extLst xmlns:a="http://schemas.openxmlformats.org/drawingml/2006/main">
               <a:ext uri="{FF2B5EF4-FFF2-40B4-BE49-F238E27FC236}">
-                <a16:creationId xmlns:a16="http://schemas.microsoft.com/office/drawing/2014/main" id="{3D2E539C-4071-4924-9667-F2C65210C5A7}"/>
+                <a16:creationId xmlns:a16="http://schemas.microsoft.com/office/drawing/2014/main" id="{8ED966BF-A260-4CC0-8847-468796354179}"/>
               </a:ext>
             </a:extLst>
           </p:cNvPr>
@@ -8202,7 +8202,7 @@
           <p:cNvPr id="28" name="">
             <a:extLst xmlns:a="http://schemas.openxmlformats.org/drawingml/2006/main">
               <a:ext uri="{FF2B5EF4-FFF2-40B4-BE49-F238E27FC236}">
-                <a16:creationId xmlns:a16="http://schemas.microsoft.com/office/drawing/2014/main" id="{C69BEECF-A08C-4B73-A69C-9EB0D992B3E7}"/>
+                <a16:creationId xmlns:a16="http://schemas.microsoft.com/office/drawing/2014/main" id="{683F9B4B-C6ED-44D9-ACFA-E0E3A33C5FE9}"/>
               </a:ext>
             </a:extLst>
           </p:cNvPr>
@@ -8259,7 +8259,7 @@
           <p:cNvPr id="29" name="">
             <a:extLst xmlns:a="http://schemas.openxmlformats.org/drawingml/2006/main">
               <a:ext uri="{FF2B5EF4-FFF2-40B4-BE49-F238E27FC236}">
-                <a16:creationId xmlns:a16="http://schemas.microsoft.com/office/drawing/2014/main" id="{150CF921-9C7A-4EFE-904E-2D0B5533898A}"/>
+                <a16:creationId xmlns:a16="http://schemas.microsoft.com/office/drawing/2014/main" id="{8286CE71-9D51-4EC7-BE7A-3D505887CD29}"/>
               </a:ext>
             </a:extLst>
           </p:cNvPr>
@@ -8316,7 +8316,7 @@
           <p:cNvPr id="30" name="">
             <a:extLst xmlns:a="http://schemas.openxmlformats.org/drawingml/2006/main">
               <a:ext uri="{FF2B5EF4-FFF2-40B4-BE49-F238E27FC236}">
-                <a16:creationId xmlns:a16="http://schemas.microsoft.com/office/drawing/2014/main" id="{21C628B7-80B9-4881-8ED5-1C5811DA8323}"/>
+                <a16:creationId xmlns:a16="http://schemas.microsoft.com/office/drawing/2014/main" id="{442C8948-B011-444C-B456-1FEFE699EC28}"/>
               </a:ext>
             </a:extLst>
           </p:cNvPr>
@@ -8373,7 +8373,7 @@
           <p:cNvPr id="31" name="">
             <a:extLst xmlns:a="http://schemas.openxmlformats.org/drawingml/2006/main">
               <a:ext uri="{FF2B5EF4-FFF2-40B4-BE49-F238E27FC236}">
-                <a16:creationId xmlns:a16="http://schemas.microsoft.com/office/drawing/2014/main" id="{A20390C4-7041-4DAC-8F54-CC6097EB08F8}"/>
+                <a16:creationId xmlns:a16="http://schemas.microsoft.com/office/drawing/2014/main" id="{391C62A5-E354-44F1-84BC-8F1EF742A7FA}"/>
               </a:ext>
             </a:extLst>
           </p:cNvPr>
@@ -8430,7 +8430,7 @@
           <p:cNvPr id="32" name="">
             <a:extLst xmlns:a="http://schemas.openxmlformats.org/drawingml/2006/main">
               <a:ext uri="{FF2B5EF4-FFF2-40B4-BE49-F238E27FC236}">
-                <a16:creationId xmlns:a16="http://schemas.microsoft.com/office/drawing/2014/main" id="{758F6AFF-1DE0-4020-A25D-45731B4E005B}"/>
+                <a16:creationId xmlns:a16="http://schemas.microsoft.com/office/drawing/2014/main" id="{5314AD38-A63C-42AE-B8E0-563C1B378178}"/>
               </a:ext>
             </a:extLst>
           </p:cNvPr>
@@ -8487,7 +8487,7 @@
           <p:cNvPr id="33" name="">
             <a:extLst xmlns:a="http://schemas.openxmlformats.org/drawingml/2006/main">
               <a:ext uri="{FF2B5EF4-FFF2-40B4-BE49-F238E27FC236}">
-                <a16:creationId xmlns:a16="http://schemas.microsoft.com/office/drawing/2014/main" id="{34B7A09B-A697-415A-8EDA-DEAB8B108C77}"/>
+                <a16:creationId xmlns:a16="http://schemas.microsoft.com/office/drawing/2014/main" id="{E7337F21-BB32-41D1-9AE2-9A0B22611083}"/>
               </a:ext>
             </a:extLst>
           </p:cNvPr>
@@ -8544,7 +8544,7 @@
           <p:cNvPr id="34" name="">
             <a:extLst xmlns:a="http://schemas.openxmlformats.org/drawingml/2006/main">
               <a:ext uri="{FF2B5EF4-FFF2-40B4-BE49-F238E27FC236}">
-                <a16:creationId xmlns:a16="http://schemas.microsoft.com/office/drawing/2014/main" id="{27D945B6-91D0-4D6F-8DAF-33E05F52BF69}"/>
+                <a16:creationId xmlns:a16="http://schemas.microsoft.com/office/drawing/2014/main" id="{223D0D2D-A380-4E8B-A8C9-7A9E48599A6A}"/>
               </a:ext>
             </a:extLst>
           </p:cNvPr>
@@ -8601,7 +8601,7 @@
           <p:cNvPr id="35" name="">
             <a:extLst xmlns:a="http://schemas.openxmlformats.org/drawingml/2006/main">
               <a:ext uri="{FF2B5EF4-FFF2-40B4-BE49-F238E27FC236}">
-                <a16:creationId xmlns:a16="http://schemas.microsoft.com/office/drawing/2014/main" id="{56D2897B-6F21-4537-A4B5-F6B38D0CB8E2}"/>
+                <a16:creationId xmlns:a16="http://schemas.microsoft.com/office/drawing/2014/main" id="{77A3F1EA-135E-4D4B-A97A-36F76DFCB0A6}"/>
               </a:ext>
             </a:extLst>
           </p:cNvPr>
@@ -8658,7 +8658,7 @@
           <p:cNvPr id="36" name="">
             <a:extLst xmlns:a="http://schemas.openxmlformats.org/drawingml/2006/main">
               <a:ext uri="{FF2B5EF4-FFF2-40B4-BE49-F238E27FC236}">
-                <a16:creationId xmlns:a16="http://schemas.microsoft.com/office/drawing/2014/main" id="{3006ABBE-AD8F-494D-8B86-01D4BDEA2A75}"/>
+                <a16:creationId xmlns:a16="http://schemas.microsoft.com/office/drawing/2014/main" id="{6A3A51C0-934F-41F9-8AE9-2DD280C9EEAA}"/>
               </a:ext>
             </a:extLst>
           </p:cNvPr>
@@ -8705,7 +8705,7 @@
                 <a:ea typeface="Malgun Gothic"/>
                 <a:cs typeface="Malgun Gothic"/>
               </a:rPr>
-              <a:t>그 1건</a:t>
+              <a:t>실제 Gmail 재현</a:t>
             </a:r>
           </a:p>
         </p:txBody>
@@ -8715,7 +8715,7 @@
           <p:cNvPr id="37" name="">
             <a:extLst xmlns:a="http://schemas.openxmlformats.org/drawingml/2006/main">
               <a:ext uri="{FF2B5EF4-FFF2-40B4-BE49-F238E27FC236}">
-                <a16:creationId xmlns:a16="http://schemas.microsoft.com/office/drawing/2014/main" id="{7CDA2142-BA61-412C-BAFA-42F668878E24}"/>
+                <a16:creationId xmlns:a16="http://schemas.microsoft.com/office/drawing/2014/main" id="{554A3D6F-62DF-4209-89E0-910D018548CF}"/>
               </a:ext>
             </a:extLst>
           </p:cNvPr>
@@ -8762,7 +8762,7 @@
                 <a:ea typeface="Malgun Gothic"/>
                 <a:cs typeface="Malgun Gothic"/>
               </a:rPr>
-              <a:t>Off는 한쪽에 자동 연결</a:t>
+              <a:t>새 메일 3통 발송</a:t>
             </a:r>
           </a:p>
         </p:txBody>
@@ -8772,7 +8772,7 @@
           <p:cNvPr id="38" name="">
             <a:extLst xmlns:a="http://schemas.openxmlformats.org/drawingml/2006/main">
               <a:ext uri="{FF2B5EF4-FFF2-40B4-BE49-F238E27FC236}">
-                <a16:creationId xmlns:a16="http://schemas.microsoft.com/office/drawing/2014/main" id="{3F1A8D21-314C-49C2-AC43-5A14FB2E4356}"/>
+                <a16:creationId xmlns:a16="http://schemas.microsoft.com/office/drawing/2014/main" id="{171F130A-1057-42C8-B1B6-8882CFCC7D0A}"/>
               </a:ext>
             </a:extLst>
           </p:cNvPr>
@@ -8819,7 +8819,7 @@
                 <a:ea typeface="Malgun Gothic"/>
                 <a:cs typeface="Malgun Gothic"/>
               </a:rPr>
-              <a:t>On은 지지도 0.55 대 0.45로 사용자 확인</a:t>
+              <a:t>같은 경로로 ASK_USER 확인</a:t>
             </a:r>
           </a:p>
         </p:txBody>
@@ -8829,7 +8829,7 @@
           <p:cNvPr id="39" name="">
             <a:extLst xmlns:a="http://schemas.openxmlformats.org/drawingml/2006/main">
               <a:ext uri="{FF2B5EF4-FFF2-40B4-BE49-F238E27FC236}">
-                <a16:creationId xmlns:a16="http://schemas.microsoft.com/office/drawing/2014/main" id="{1374DD00-8278-4682-8CA2-9AF108C58CAA}"/>
+                <a16:creationId xmlns:a16="http://schemas.microsoft.com/office/drawing/2014/main" id="{E01A1273-AC1F-401A-9118-3C0F8A957B73}"/>
               </a:ext>
             </a:extLst>
           </p:cNvPr>
@@ -8886,7 +8886,7 @@
           <p:cNvPr id="40" name="">
             <a:extLst xmlns:a="http://schemas.openxmlformats.org/drawingml/2006/main">
               <a:ext uri="{FF2B5EF4-FFF2-40B4-BE49-F238E27FC236}">
-                <a16:creationId xmlns:a16="http://schemas.microsoft.com/office/drawing/2014/main" id="{D6491A56-D12B-4C06-A52A-57642505DF23}"/>
+                <a16:creationId xmlns:a16="http://schemas.microsoft.com/office/drawing/2014/main" id="{65F0A6AE-85D0-4CF8-BFFB-9A58B36214DC}"/>
               </a:ext>
             </a:extLst>
           </p:cNvPr>
@@ -8941,7 +8941,7 @@
     </p:spTree>
     <p:extLst>
       <p:ext uri="{BB962C8B-B14F-4D97-AF65-F5344CB8AC3E}">
-        <p14:creationId xmlns:p14="http://schemas.microsoft.com/office/powerpoint/2010/main" val="1254836365"/>
+        <p14:creationId xmlns:p14="http://schemas.microsoft.com/office/powerpoint/2010/main" val="272195111"/>
       </p:ext>
     </p:extLst>
   </p:cSld>

</xml_diff>

<commit_message>
fix: the deterministic path shows the same difference, so lead with it
06 said the Mock path could not separate the two similar tasks and that the
difference was only visible on LIVE. It is visible on Mock, and that is the
stronger result: Mock calls no LLM, so it has no run-to-run variance, and the
deliberation suite splits 4/4 with the flag on against 3/4 with it off. The
failing case and the failure mode are the same ones LIVE reproduces — DLB-02
choosing LINK_TO_TASK where ASK_USER was expected.

That means the DLB-02 difference is a property of the judgement structure, not
of which way the model happened to fall on a given call, and the documents, the
deck and the evidence now say so.

Co-Authored-By: Claude Opus 5 <noreply@anthropic.com>
</commit_message>
<xml_diff>
--- a/Docs/PRESENTATION/2. 최종/09285_백준현_AI_Master_최종발표자료_v8.pptx
+++ b/Docs/PRESENTATION/2. 최종/09285_백준현_AI_Master_최종발표자료_v8.pptx
@@ -2,16 +2,16 @@
 <file path=ppt/presentation.xml><?xml version="1.0" encoding="utf-8"?>
 <p:presentation xmlns:p="http://schemas.openxmlformats.org/presentationml/2006/main">
   <p:sldMasterIdLst>
-    <p:sldMasterId xmlns:r="http://schemas.openxmlformats.org/officeDocument/2006/relationships" id="2147483648" r:id="R7453c52429e54dc4"/>
+    <p:sldMasterId xmlns:r="http://schemas.openxmlformats.org/officeDocument/2006/relationships" id="2147483648" r:id="R1ece40f1d70b483a"/>
   </p:sldMasterIdLst>
   <p:notesMasterIdLst>
-    <p:notesMasterId xmlns:r="http://schemas.openxmlformats.org/officeDocument/2006/relationships" r:id="Rd40260ce55ed45a5"/>
+    <p:notesMasterId xmlns:r="http://schemas.openxmlformats.org/officeDocument/2006/relationships" r:id="Rb637b666397a4b4e"/>
   </p:notesMasterIdLst>
   <p:sldIdLst>
-    <p:sldId xmlns:r="http://schemas.openxmlformats.org/officeDocument/2006/relationships" id="256" r:id="R38fbd7bdb0c04fc0"/>
-    <p:sldId xmlns:r="http://schemas.openxmlformats.org/officeDocument/2006/relationships" id="257" r:id="R18f2afb0e63a4d58"/>
-    <p:sldId xmlns:r="http://schemas.openxmlformats.org/officeDocument/2006/relationships" id="258" r:id="Rd88722b38483464f"/>
-    <p:sldId xmlns:r="http://schemas.openxmlformats.org/officeDocument/2006/relationships" id="259" r:id="Re926dc090984455d"/>
+    <p:sldId xmlns:r="http://schemas.openxmlformats.org/officeDocument/2006/relationships" id="256" r:id="Radb904423e0e4fda"/>
+    <p:sldId xmlns:r="http://schemas.openxmlformats.org/officeDocument/2006/relationships" id="257" r:id="R539e3f979d3c4465"/>
+    <p:sldId xmlns:r="http://schemas.openxmlformats.org/officeDocument/2006/relationships" id="258" r:id="R71416bab2b55442f"/>
+    <p:sldId xmlns:r="http://schemas.openxmlformats.org/officeDocument/2006/relationships" id="259" r:id="Rd1193541fd2045ed"/>
   </p:sldIdLst>
   <p:sldSz cx="12192000" cy="6858000"/>
   <p:notesSz cx="6858000" cy="9144000"/>
@@ -800,7 +800,7 @@
           </a:p>
           <a:p xmlns:a="http://schemas.openxmlformats.org/drawingml/2006/main">
             <a:r>
-              <a:t>효과는 같은 코드에서 기능만 껐다 켜서 측정했습니다. 기존 열다섯 개 Case는 양쪽이 똑같이 15/15, Action 28/28이고 소요시간만 약 삼십 퍼센트 늘었습니다. 숙고가 실제 발동하는 전용 네 개 Case는 출력이 회차마다 달라져서 각 설정을 세 번씩 돌렸습니다. 통과 수는 켠 쪽이 삼, 사, 삼이고 끈 쪽이 삼, 이, 삼입니다. 그래서 한 회차 숫자를 결론으로 쓰지 않았습니다. 세 번 모두 재현되는 차이는 한 건입니다. 요청자가 같고 대상 시스템만 다른 유사 업무가 둘 있을 때, 단일 결론 경로는 세 번 모두 둘 중 하나에 그대로 연결했고, 두 단계 경로는 세 번 모두 사용자 확인으로 닫았습니다. 제가 개선했다고 말하는 범위는 이 한 건입니다.</a:t>
+              <a:t>효과는 같은 코드에서 기능만 껐다 켜서 측정했습니다. 기존 열다섯 개 Case는 양쪽이 똑같이 15/15, Action 28/28이고 소요시간만 약 삼십 퍼센트 늘었습니다. 숙고가 실제 발동하는 전용 네 개 Case는 엘엘엠 출력이 회차마다 달라져서 각 설정을 세 번씩 돌렸습니다. 통과 수는 켠 쪽이 삼, 사, 삼이고 끈 쪽이 삼, 이, 삼이라 한 회차 숫자를 결론으로 쓰지 않았습니다. 대신 엘엘엠을 호출하지 않는 결정론적 경로에서도 같은 비교를 했고, 거기서는 켠 쪽 사 대 사, 끈 쪽 삼 대 사로 갈립니다. 실패하는 케이스와 실패하는 방식까지 같습니다. 요청자가 같고 대상 시스템만 다른 유사 업무가 둘 있을 때, 단일 결론 경로는 둘 중 하나에 그대로 연결하고, 두 단계 경로는 사용자 확인으로 닫습니다. 회차 변동이 없는 경로에서 재현되니까, 이 차이는 모델 출력 운이 아니라 판단 구조의 차이라고 말할 수 있습니다. 제가 개선했다고 말하는 범위는 이 한 건입니다.</a:t>
             </a:r>
           </a:p>
           <a:p xmlns:a="http://schemas.openxmlformats.org/drawingml/2006/main">
@@ -933,7 +933,7 @@
   </p:cSld>
   <p:clrMap bg1="lt1" tx1="dk1" bg2="lt2" tx2="dk2" accent1="accent1" accent2="accent2" accent3="accent3" accent4="accent4" accent5="accent5" accent6="accent6" hlink="hlink" folHlink="folHlink"/>
   <p:sldLayoutIdLst>
-    <p:sldLayoutId xmlns:r="http://schemas.openxmlformats.org/officeDocument/2006/relationships" id="2147483649" r:id="Re3415ed155eb4162"/>
+    <p:sldLayoutId xmlns:r="http://schemas.openxmlformats.org/officeDocument/2006/relationships" id="2147483649" r:id="Rad53b6b2db6f42f4"/>
   </p:sldLayoutIdLst>
   <p:txStyles>
     <p:titleStyle>
@@ -1484,7 +1484,7 @@
           <p:cNvPr id="9" name="">
             <a:extLst xmlns:a="http://schemas.openxmlformats.org/drawingml/2006/main">
               <a:ext uri="{FF2B5EF4-FFF2-40B4-BE49-F238E27FC236}">
-                <a16:creationId xmlns:a16="http://schemas.microsoft.com/office/drawing/2014/main" id="{11EA757A-CDC1-494D-B4D1-AA18D6F5C488}"/>
+                <a16:creationId xmlns:a16="http://schemas.microsoft.com/office/drawing/2014/main" id="{E308FBDF-CB90-4C74-A050-65DFE4AA3341}"/>
               </a:ext>
             </a:extLst>
           </p:cNvPr>
@@ -1514,7 +1514,7 @@
           <p:cNvPr id="2" name="">
             <a:extLst xmlns:a="http://schemas.openxmlformats.org/drawingml/2006/main">
               <a:ext uri="{FF2B5EF4-FFF2-40B4-BE49-F238E27FC236}">
-                <a16:creationId xmlns:a16="http://schemas.microsoft.com/office/drawing/2014/main" id="{4BB15AA1-AE7C-42F1-B4E9-A29C3C452659}"/>
+                <a16:creationId xmlns:a16="http://schemas.microsoft.com/office/drawing/2014/main" id="{87081F9D-49E2-4F5C-93BC-674C95876C69}"/>
               </a:ext>
             </a:extLst>
           </p:cNvPr>
@@ -1571,7 +1571,7 @@
           <p:cNvPr id="3" name="">
             <a:extLst xmlns:a="http://schemas.openxmlformats.org/drawingml/2006/main">
               <a:ext uri="{FF2B5EF4-FFF2-40B4-BE49-F238E27FC236}">
-                <a16:creationId xmlns:a16="http://schemas.microsoft.com/office/drawing/2014/main" id="{6775212E-1F47-455E-B73C-7F2DBA7E9D33}"/>
+                <a16:creationId xmlns:a16="http://schemas.microsoft.com/office/drawing/2014/main" id="{D2249088-3FB9-453D-A96A-8B9FD1867BEE}"/>
               </a:ext>
             </a:extLst>
           </p:cNvPr>
@@ -1628,7 +1628,7 @@
           <p:cNvPr id="4" name="">
             <a:extLst xmlns:a="http://schemas.openxmlformats.org/drawingml/2006/main">
               <a:ext uri="{FF2B5EF4-FFF2-40B4-BE49-F238E27FC236}">
-                <a16:creationId xmlns:a16="http://schemas.microsoft.com/office/drawing/2014/main" id="{9B933E85-09EF-4F4E-8D64-B37F61C935F5}"/>
+                <a16:creationId xmlns:a16="http://schemas.microsoft.com/office/drawing/2014/main" id="{2579C8FA-C882-4FA7-8DA2-A75738F1EB42}"/>
               </a:ext>
             </a:extLst>
           </p:cNvPr>
@@ -1685,7 +1685,7 @@
           <p:cNvPr id="5" name="">
             <a:extLst xmlns:a="http://schemas.openxmlformats.org/drawingml/2006/main">
               <a:ext uri="{FF2B5EF4-FFF2-40B4-BE49-F238E27FC236}">
-                <a16:creationId xmlns:a16="http://schemas.microsoft.com/office/drawing/2014/main" id="{BB35C80E-B5F5-4DC1-85A0-DA9098FE8EB5}"/>
+                <a16:creationId xmlns:a16="http://schemas.microsoft.com/office/drawing/2014/main" id="{906B8096-0987-4489-8E8F-51DAE484DD12}"/>
               </a:ext>
             </a:extLst>
           </p:cNvPr>
@@ -1715,7 +1715,7 @@
           <p:cNvPr id="6" name="">
             <a:extLst xmlns:a="http://schemas.openxmlformats.org/drawingml/2006/main">
               <a:ext uri="{FF2B5EF4-FFF2-40B4-BE49-F238E27FC236}">
-                <a16:creationId xmlns:a16="http://schemas.microsoft.com/office/drawing/2014/main" id="{A2279CDB-C511-42B8-B863-D90B3A5B418E}"/>
+                <a16:creationId xmlns:a16="http://schemas.microsoft.com/office/drawing/2014/main" id="{190D4A90-DDD6-435D-9DC3-C5CCD2DE32AD}"/>
               </a:ext>
             </a:extLst>
           </p:cNvPr>
@@ -1772,7 +1772,7 @@
           <p:cNvPr id="7" name="">
             <a:extLst xmlns:a="http://schemas.openxmlformats.org/drawingml/2006/main">
               <a:ext uri="{FF2B5EF4-FFF2-40B4-BE49-F238E27FC236}">
-                <a16:creationId xmlns:a16="http://schemas.microsoft.com/office/drawing/2014/main" id="{F7392FF6-7F77-4683-9161-A8BE5B96257F}"/>
+                <a16:creationId xmlns:a16="http://schemas.microsoft.com/office/drawing/2014/main" id="{28DCA238-10DF-4B8C-87C8-83B298081805}"/>
               </a:ext>
             </a:extLst>
           </p:cNvPr>
@@ -1829,7 +1829,7 @@
           <p:cNvPr id="8" name="">
             <a:extLst xmlns:a="http://schemas.openxmlformats.org/drawingml/2006/main">
               <a:ext uri="{FF2B5EF4-FFF2-40B4-BE49-F238E27FC236}">
-                <a16:creationId xmlns:a16="http://schemas.microsoft.com/office/drawing/2014/main" id="{D3AC7868-6CC4-49C4-A6A5-F9CB0FB7EF34}"/>
+                <a16:creationId xmlns:a16="http://schemas.microsoft.com/office/drawing/2014/main" id="{9DA3E97B-1730-49D9-B798-C1B74A73C9FD}"/>
               </a:ext>
             </a:extLst>
           </p:cNvPr>
@@ -1884,7 +1884,7 @@
     </p:spTree>
     <p:extLst>
       <p:ext uri="{BB962C8B-B14F-4D97-AF65-F5344CB8AC3E}">
-        <p14:creationId xmlns:p14="http://schemas.microsoft.com/office/powerpoint/2010/main" val="1467505580"/>
+        <p14:creationId xmlns:p14="http://schemas.microsoft.com/office/powerpoint/2010/main" val="2013341118"/>
       </p:ext>
     </p:extLst>
   </p:cSld>
@@ -1915,7 +1915,7 @@
           <p:cNvPr id="45" name="">
             <a:extLst xmlns:a="http://schemas.openxmlformats.org/drawingml/2006/main">
               <a:ext uri="{FF2B5EF4-FFF2-40B4-BE49-F238E27FC236}">
-                <a16:creationId xmlns:a16="http://schemas.microsoft.com/office/drawing/2014/main" id="{117E10D1-AF8C-40F5-9A51-AC6FF99273FD}"/>
+                <a16:creationId xmlns:a16="http://schemas.microsoft.com/office/drawing/2014/main" id="{4665648A-0A3A-43CB-A6E6-A8C0B16EAE31}"/>
               </a:ext>
             </a:extLst>
           </p:cNvPr>
@@ -1945,7 +1945,7 @@
           <p:cNvPr id="2" name="">
             <a:extLst xmlns:a="http://schemas.openxmlformats.org/drawingml/2006/main">
               <a:ext uri="{FF2B5EF4-FFF2-40B4-BE49-F238E27FC236}">
-                <a16:creationId xmlns:a16="http://schemas.microsoft.com/office/drawing/2014/main" id="{1A4B81EA-56D4-4A3A-94C1-772B372E9610}"/>
+                <a16:creationId xmlns:a16="http://schemas.microsoft.com/office/drawing/2014/main" id="{8EE26F1D-D996-434F-9F61-9D40CD1AF171}"/>
               </a:ext>
             </a:extLst>
           </p:cNvPr>
@@ -2002,7 +2002,7 @@
           <p:cNvPr id="3" name="">
             <a:extLst xmlns:a="http://schemas.openxmlformats.org/drawingml/2006/main">
               <a:ext uri="{FF2B5EF4-FFF2-40B4-BE49-F238E27FC236}">
-                <a16:creationId xmlns:a16="http://schemas.microsoft.com/office/drawing/2014/main" id="{B274C2E7-B8F2-49BC-A460-E1803EB1A3B8}"/>
+                <a16:creationId xmlns:a16="http://schemas.microsoft.com/office/drawing/2014/main" id="{8D61DFF0-039F-4B07-8A9B-4631F38F5D9D}"/>
               </a:ext>
             </a:extLst>
           </p:cNvPr>
@@ -2032,7 +2032,7 @@
           <p:cNvPr id="4" name="">
             <a:extLst xmlns:a="http://schemas.openxmlformats.org/drawingml/2006/main">
               <a:ext uri="{FF2B5EF4-FFF2-40B4-BE49-F238E27FC236}">
-                <a16:creationId xmlns:a16="http://schemas.microsoft.com/office/drawing/2014/main" id="{79D713CE-A7DA-4637-B4D3-B39535BD5EB3}"/>
+                <a16:creationId xmlns:a16="http://schemas.microsoft.com/office/drawing/2014/main" id="{ADAFCC95-49B7-4884-9188-33DEC65BC4E3}"/>
               </a:ext>
             </a:extLst>
           </p:cNvPr>
@@ -2089,7 +2089,7 @@
           <p:cNvPr id="5" name="">
             <a:extLst xmlns:a="http://schemas.openxmlformats.org/drawingml/2006/main">
               <a:ext uri="{FF2B5EF4-FFF2-40B4-BE49-F238E27FC236}">
-                <a16:creationId xmlns:a16="http://schemas.microsoft.com/office/drawing/2014/main" id="{31BB9726-23B4-4F88-9325-457326FEF18E}"/>
+                <a16:creationId xmlns:a16="http://schemas.microsoft.com/office/drawing/2014/main" id="{B2376A46-4701-4DAF-9372-6C9303C8FC7F}"/>
               </a:ext>
             </a:extLst>
           </p:cNvPr>
@@ -2146,7 +2146,7 @@
           <p:cNvPr id="6" name="">
             <a:extLst xmlns:a="http://schemas.openxmlformats.org/drawingml/2006/main">
               <a:ext uri="{FF2B5EF4-FFF2-40B4-BE49-F238E27FC236}">
-                <a16:creationId xmlns:a16="http://schemas.microsoft.com/office/drawing/2014/main" id="{8AE2D544-9C30-4407-87D3-427E9ABC4911}"/>
+                <a16:creationId xmlns:a16="http://schemas.microsoft.com/office/drawing/2014/main" id="{F685CFB3-3673-4257-A896-98E6FE573CC6}"/>
               </a:ext>
             </a:extLst>
           </p:cNvPr>
@@ -2203,7 +2203,7 @@
           <p:cNvPr id="7" name="">
             <a:extLst xmlns:a="http://schemas.openxmlformats.org/drawingml/2006/main">
               <a:ext uri="{FF2B5EF4-FFF2-40B4-BE49-F238E27FC236}">
-                <a16:creationId xmlns:a16="http://schemas.microsoft.com/office/drawing/2014/main" id="{9F53F407-0872-434D-B40C-271CEA20DC9F}"/>
+                <a16:creationId xmlns:a16="http://schemas.microsoft.com/office/drawing/2014/main" id="{820718F0-206B-4B89-AFAB-4E8361EC7D82}"/>
               </a:ext>
             </a:extLst>
           </p:cNvPr>
@@ -2237,7 +2237,7 @@
           <p:cNvPr id="8" name="">
             <a:extLst xmlns:a="http://schemas.openxmlformats.org/drawingml/2006/main">
               <a:ext uri="{FF2B5EF4-FFF2-40B4-BE49-F238E27FC236}">
-                <a16:creationId xmlns:a16="http://schemas.microsoft.com/office/drawing/2014/main" id="{0B660285-C6BD-455C-9672-4F2284831144}"/>
+                <a16:creationId xmlns:a16="http://schemas.microsoft.com/office/drawing/2014/main" id="{EA8CEBC2-1097-40DF-9B22-2BD6908CFA43}"/>
               </a:ext>
             </a:extLst>
           </p:cNvPr>
@@ -2269,7 +2269,7 @@
           <p:cNvPr id="9" name="">
             <a:extLst xmlns:a="http://schemas.openxmlformats.org/drawingml/2006/main">
               <a:ext uri="{FF2B5EF4-FFF2-40B4-BE49-F238E27FC236}">
-                <a16:creationId xmlns:a16="http://schemas.microsoft.com/office/drawing/2014/main" id="{51C770F2-7A4D-4ED2-B9A5-879956B7F29A}"/>
+                <a16:creationId xmlns:a16="http://schemas.microsoft.com/office/drawing/2014/main" id="{FD41680D-2E22-4704-ADC3-85B61DC933DD}"/>
               </a:ext>
             </a:extLst>
           </p:cNvPr>
@@ -2326,7 +2326,7 @@
           <p:cNvPr id="10" name="">
             <a:extLst xmlns:a="http://schemas.openxmlformats.org/drawingml/2006/main">
               <a:ext uri="{FF2B5EF4-FFF2-40B4-BE49-F238E27FC236}">
-                <a16:creationId xmlns:a16="http://schemas.microsoft.com/office/drawing/2014/main" id="{AB317620-ABCB-4FF4-97E0-69C7EB54B421}"/>
+                <a16:creationId xmlns:a16="http://schemas.microsoft.com/office/drawing/2014/main" id="{71126D52-349A-4747-8E0E-52DD316D8179}"/>
               </a:ext>
             </a:extLst>
           </p:cNvPr>
@@ -2406,7 +2406,7 @@
           <p:cNvPr id="11" name="">
             <a:extLst xmlns:a="http://schemas.openxmlformats.org/drawingml/2006/main">
               <a:ext uri="{FF2B5EF4-FFF2-40B4-BE49-F238E27FC236}">
-                <a16:creationId xmlns:a16="http://schemas.microsoft.com/office/drawing/2014/main" id="{777F9C93-73B4-4012-BE7E-DEF1CDE3A498}"/>
+                <a16:creationId xmlns:a16="http://schemas.microsoft.com/office/drawing/2014/main" id="{C2BEDEDA-ABAF-40AC-A1D4-8BE36D3F604B}"/>
               </a:ext>
             </a:extLst>
           </p:cNvPr>
@@ -2436,7 +2436,7 @@
           <p:cNvPr id="12" name="">
             <a:extLst xmlns:a="http://schemas.openxmlformats.org/drawingml/2006/main">
               <a:ext uri="{FF2B5EF4-FFF2-40B4-BE49-F238E27FC236}">
-                <a16:creationId xmlns:a16="http://schemas.microsoft.com/office/drawing/2014/main" id="{8BF5C83D-5DA6-437A-A191-5CB04038FACB}"/>
+                <a16:creationId xmlns:a16="http://schemas.microsoft.com/office/drawing/2014/main" id="{409E19D9-BE16-49F6-AE44-8917E8ED8818}"/>
               </a:ext>
             </a:extLst>
           </p:cNvPr>
@@ -2470,7 +2470,7 @@
           <p:cNvPr id="13" name="">
             <a:extLst xmlns:a="http://schemas.openxmlformats.org/drawingml/2006/main">
               <a:ext uri="{FF2B5EF4-FFF2-40B4-BE49-F238E27FC236}">
-                <a16:creationId xmlns:a16="http://schemas.microsoft.com/office/drawing/2014/main" id="{99B1019A-4B60-4D0C-BA6C-25F566176F8D}"/>
+                <a16:creationId xmlns:a16="http://schemas.microsoft.com/office/drawing/2014/main" id="{26974091-ADEB-44C1-B0EA-332BB073142A}"/>
               </a:ext>
             </a:extLst>
           </p:cNvPr>
@@ -2502,7 +2502,7 @@
           <p:cNvPr id="14" name="">
             <a:extLst xmlns:a="http://schemas.openxmlformats.org/drawingml/2006/main">
               <a:ext uri="{FF2B5EF4-FFF2-40B4-BE49-F238E27FC236}">
-                <a16:creationId xmlns:a16="http://schemas.microsoft.com/office/drawing/2014/main" id="{5B9F6CF6-7DA6-4036-9D65-1C811331F9EC}"/>
+                <a16:creationId xmlns:a16="http://schemas.microsoft.com/office/drawing/2014/main" id="{E662049C-7208-4C2B-B0CC-ACE58F32B74A}"/>
               </a:ext>
             </a:extLst>
           </p:cNvPr>
@@ -2559,7 +2559,7 @@
           <p:cNvPr id="15" name="">
             <a:extLst xmlns:a="http://schemas.openxmlformats.org/drawingml/2006/main">
               <a:ext uri="{FF2B5EF4-FFF2-40B4-BE49-F238E27FC236}">
-                <a16:creationId xmlns:a16="http://schemas.microsoft.com/office/drawing/2014/main" id="{44FFFB10-BEAF-4558-A3DC-7E136B819172}"/>
+                <a16:creationId xmlns:a16="http://schemas.microsoft.com/office/drawing/2014/main" id="{2A12CC0C-86EA-4FF2-B50B-2841A38FB4ED}"/>
               </a:ext>
             </a:extLst>
           </p:cNvPr>
@@ -2639,7 +2639,7 @@
           <p:cNvPr id="16" name="">
             <a:extLst xmlns:a="http://schemas.openxmlformats.org/drawingml/2006/main">
               <a:ext uri="{FF2B5EF4-FFF2-40B4-BE49-F238E27FC236}">
-                <a16:creationId xmlns:a16="http://schemas.microsoft.com/office/drawing/2014/main" id="{18613988-FAE9-4785-A391-8A59CE564126}"/>
+                <a16:creationId xmlns:a16="http://schemas.microsoft.com/office/drawing/2014/main" id="{DEE09F92-1825-4A1F-936E-B4788F4E7D74}"/>
               </a:ext>
             </a:extLst>
           </p:cNvPr>
@@ -2669,7 +2669,7 @@
           <p:cNvPr id="17" name="">
             <a:extLst xmlns:a="http://schemas.openxmlformats.org/drawingml/2006/main">
               <a:ext uri="{FF2B5EF4-FFF2-40B4-BE49-F238E27FC236}">
-                <a16:creationId xmlns:a16="http://schemas.microsoft.com/office/drawing/2014/main" id="{7C5A8CEE-FEA6-417F-8D42-4341D2AF3281}"/>
+                <a16:creationId xmlns:a16="http://schemas.microsoft.com/office/drawing/2014/main" id="{AAD612AC-1547-4EA5-A167-2D93CCFCE3B9}"/>
               </a:ext>
             </a:extLst>
           </p:cNvPr>
@@ -2703,7 +2703,7 @@
           <p:cNvPr id="18" name="">
             <a:extLst xmlns:a="http://schemas.openxmlformats.org/drawingml/2006/main">
               <a:ext uri="{FF2B5EF4-FFF2-40B4-BE49-F238E27FC236}">
-                <a16:creationId xmlns:a16="http://schemas.microsoft.com/office/drawing/2014/main" id="{C670EE29-0089-47D8-B91E-C697578E960E}"/>
+                <a16:creationId xmlns:a16="http://schemas.microsoft.com/office/drawing/2014/main" id="{1E45ABEA-0E6B-4595-A768-88F00FE2EB75}"/>
               </a:ext>
             </a:extLst>
           </p:cNvPr>
@@ -2735,7 +2735,7 @@
           <p:cNvPr id="19" name="">
             <a:extLst xmlns:a="http://schemas.openxmlformats.org/drawingml/2006/main">
               <a:ext uri="{FF2B5EF4-FFF2-40B4-BE49-F238E27FC236}">
-                <a16:creationId xmlns:a16="http://schemas.microsoft.com/office/drawing/2014/main" id="{40AAA02B-E7D9-45D4-8E9E-D178C06BC742}"/>
+                <a16:creationId xmlns:a16="http://schemas.microsoft.com/office/drawing/2014/main" id="{F215C771-4185-4C84-B85F-D2A17669A13B}"/>
               </a:ext>
             </a:extLst>
           </p:cNvPr>
@@ -2792,7 +2792,7 @@
           <p:cNvPr id="20" name="">
             <a:extLst xmlns:a="http://schemas.openxmlformats.org/drawingml/2006/main">
               <a:ext uri="{FF2B5EF4-FFF2-40B4-BE49-F238E27FC236}">
-                <a16:creationId xmlns:a16="http://schemas.microsoft.com/office/drawing/2014/main" id="{EACE8C90-2C22-41C1-AF44-D5C8029A0132}"/>
+                <a16:creationId xmlns:a16="http://schemas.microsoft.com/office/drawing/2014/main" id="{F9F58620-8099-448D-B39C-124CCA6CF8A3}"/>
               </a:ext>
             </a:extLst>
           </p:cNvPr>
@@ -2872,7 +2872,7 @@
           <p:cNvPr id="21" name="">
             <a:extLst xmlns:a="http://schemas.openxmlformats.org/drawingml/2006/main">
               <a:ext uri="{FF2B5EF4-FFF2-40B4-BE49-F238E27FC236}">
-                <a16:creationId xmlns:a16="http://schemas.microsoft.com/office/drawing/2014/main" id="{F0A78457-CD3E-4CF8-BD6D-C3EDCC513A1C}"/>
+                <a16:creationId xmlns:a16="http://schemas.microsoft.com/office/drawing/2014/main" id="{B74180D5-9B56-4077-8BC5-17CF3F1033DC}"/>
               </a:ext>
             </a:extLst>
           </p:cNvPr>
@@ -2902,7 +2902,7 @@
           <p:cNvPr id="22" name="">
             <a:extLst xmlns:a="http://schemas.openxmlformats.org/drawingml/2006/main">
               <a:ext uri="{FF2B5EF4-FFF2-40B4-BE49-F238E27FC236}">
-                <a16:creationId xmlns:a16="http://schemas.microsoft.com/office/drawing/2014/main" id="{59439C8A-CED7-4515-86C1-6E80DFD2BDB0}"/>
+                <a16:creationId xmlns:a16="http://schemas.microsoft.com/office/drawing/2014/main" id="{83FEC0BF-7C1B-4230-BCFC-76D4183CCC53}"/>
               </a:ext>
             </a:extLst>
           </p:cNvPr>
@@ -2936,7 +2936,7 @@
           <p:cNvPr id="23" name="">
             <a:extLst xmlns:a="http://schemas.openxmlformats.org/drawingml/2006/main">
               <a:ext uri="{FF2B5EF4-FFF2-40B4-BE49-F238E27FC236}">
-                <a16:creationId xmlns:a16="http://schemas.microsoft.com/office/drawing/2014/main" id="{90881BFA-B046-4B37-B420-105E7584752F}"/>
+                <a16:creationId xmlns:a16="http://schemas.microsoft.com/office/drawing/2014/main" id="{392FD129-823A-4827-AA53-B9B3FBF80E40}"/>
               </a:ext>
             </a:extLst>
           </p:cNvPr>
@@ -2968,7 +2968,7 @@
           <p:cNvPr id="24" name="">
             <a:extLst xmlns:a="http://schemas.openxmlformats.org/drawingml/2006/main">
               <a:ext uri="{FF2B5EF4-FFF2-40B4-BE49-F238E27FC236}">
-                <a16:creationId xmlns:a16="http://schemas.microsoft.com/office/drawing/2014/main" id="{8A38CF9D-49B1-4ECA-A288-67ABD2ABD2F0}"/>
+                <a16:creationId xmlns:a16="http://schemas.microsoft.com/office/drawing/2014/main" id="{2A91466B-7244-4229-AAC6-B3A0C0DAEAFE}"/>
               </a:ext>
             </a:extLst>
           </p:cNvPr>
@@ -3025,7 +3025,7 @@
           <p:cNvPr id="25" name="">
             <a:extLst xmlns:a="http://schemas.openxmlformats.org/drawingml/2006/main">
               <a:ext uri="{FF2B5EF4-FFF2-40B4-BE49-F238E27FC236}">
-                <a16:creationId xmlns:a16="http://schemas.microsoft.com/office/drawing/2014/main" id="{6FAEEF1A-2F81-4493-8CD1-FAF56367DD20}"/>
+                <a16:creationId xmlns:a16="http://schemas.microsoft.com/office/drawing/2014/main" id="{8303B191-89CE-4F7B-9324-C372B77EF26B}"/>
               </a:ext>
             </a:extLst>
           </p:cNvPr>
@@ -3105,7 +3105,7 @@
           <p:cNvPr id="26" name="">
             <a:extLst xmlns:a="http://schemas.openxmlformats.org/drawingml/2006/main">
               <a:ext uri="{FF2B5EF4-FFF2-40B4-BE49-F238E27FC236}">
-                <a16:creationId xmlns:a16="http://schemas.microsoft.com/office/drawing/2014/main" id="{F4C56C02-0636-41FD-B9A0-13EDA4C103E0}"/>
+                <a16:creationId xmlns:a16="http://schemas.microsoft.com/office/drawing/2014/main" id="{8B199CC9-4449-4114-8B13-3DB2BEB47CD4}"/>
               </a:ext>
             </a:extLst>
           </p:cNvPr>
@@ -3135,7 +3135,7 @@
           <p:cNvPr id="27" name="">
             <a:extLst xmlns:a="http://schemas.openxmlformats.org/drawingml/2006/main">
               <a:ext uri="{FF2B5EF4-FFF2-40B4-BE49-F238E27FC236}">
-                <a16:creationId xmlns:a16="http://schemas.microsoft.com/office/drawing/2014/main" id="{C5F0469A-8C71-42DA-8713-E7891DB45ECD}"/>
+                <a16:creationId xmlns:a16="http://schemas.microsoft.com/office/drawing/2014/main" id="{11CC317B-73F2-426A-85D5-0191FB9678E0}"/>
               </a:ext>
             </a:extLst>
           </p:cNvPr>
@@ -3169,7 +3169,7 @@
           <p:cNvPr id="28" name="">
             <a:extLst xmlns:a="http://schemas.openxmlformats.org/drawingml/2006/main">
               <a:ext uri="{FF2B5EF4-FFF2-40B4-BE49-F238E27FC236}">
-                <a16:creationId xmlns:a16="http://schemas.microsoft.com/office/drawing/2014/main" id="{74549072-D117-4046-AC16-F0295D2547CF}"/>
+                <a16:creationId xmlns:a16="http://schemas.microsoft.com/office/drawing/2014/main" id="{3565D1EC-9B22-4C2D-BB98-B32B786096CD}"/>
               </a:ext>
             </a:extLst>
           </p:cNvPr>
@@ -3201,7 +3201,7 @@
           <p:cNvPr id="29" name="">
             <a:extLst xmlns:a="http://schemas.openxmlformats.org/drawingml/2006/main">
               <a:ext uri="{FF2B5EF4-FFF2-40B4-BE49-F238E27FC236}">
-                <a16:creationId xmlns:a16="http://schemas.microsoft.com/office/drawing/2014/main" id="{B5DE38AE-707B-415D-95D3-61E205311E45}"/>
+                <a16:creationId xmlns:a16="http://schemas.microsoft.com/office/drawing/2014/main" id="{7007FADF-52B6-42DC-8F52-C6D21A4428F5}"/>
               </a:ext>
             </a:extLst>
           </p:cNvPr>
@@ -3258,7 +3258,7 @@
           <p:cNvPr id="30" name="">
             <a:extLst xmlns:a="http://schemas.openxmlformats.org/drawingml/2006/main">
               <a:ext uri="{FF2B5EF4-FFF2-40B4-BE49-F238E27FC236}">
-                <a16:creationId xmlns:a16="http://schemas.microsoft.com/office/drawing/2014/main" id="{96ED35ED-2C7C-4B26-AEAD-276C34FEF6A8}"/>
+                <a16:creationId xmlns:a16="http://schemas.microsoft.com/office/drawing/2014/main" id="{2322E08A-0951-48B1-97E5-CF8D26AB7ECF}"/>
               </a:ext>
             </a:extLst>
           </p:cNvPr>
@@ -3338,7 +3338,7 @@
           <p:cNvPr id="31" name="">
             <a:extLst xmlns:a="http://schemas.openxmlformats.org/drawingml/2006/main">
               <a:ext uri="{FF2B5EF4-FFF2-40B4-BE49-F238E27FC236}">
-                <a16:creationId xmlns:a16="http://schemas.microsoft.com/office/drawing/2014/main" id="{A9CD70F1-AF71-4CEB-BBF2-57B354D42347}"/>
+                <a16:creationId xmlns:a16="http://schemas.microsoft.com/office/drawing/2014/main" id="{060B5122-F250-4ABA-9634-465488A80892}"/>
               </a:ext>
             </a:extLst>
           </p:cNvPr>
@@ -3395,7 +3395,7 @@
           <p:cNvPr id="32" name="">
             <a:extLst xmlns:a="http://schemas.openxmlformats.org/drawingml/2006/main">
               <a:ext uri="{FF2B5EF4-FFF2-40B4-BE49-F238E27FC236}">
-                <a16:creationId xmlns:a16="http://schemas.microsoft.com/office/drawing/2014/main" id="{78125356-45EA-4FBB-84DE-ECBD84DFB073}"/>
+                <a16:creationId xmlns:a16="http://schemas.microsoft.com/office/drawing/2014/main" id="{F579F758-578E-4B81-9CAF-1F963786CDE5}"/>
               </a:ext>
             </a:extLst>
           </p:cNvPr>
@@ -3452,7 +3452,7 @@
           <p:cNvPr id="33" name="">
             <a:extLst xmlns:a="http://schemas.openxmlformats.org/drawingml/2006/main">
               <a:ext uri="{FF2B5EF4-FFF2-40B4-BE49-F238E27FC236}">
-                <a16:creationId xmlns:a16="http://schemas.microsoft.com/office/drawing/2014/main" id="{EF98A646-17FD-4098-BC8D-1D7A39BEDFED}"/>
+                <a16:creationId xmlns:a16="http://schemas.microsoft.com/office/drawing/2014/main" id="{B8D655D8-69BA-42F3-937B-8B97C90EEC71}"/>
               </a:ext>
             </a:extLst>
           </p:cNvPr>
@@ -3509,7 +3509,7 @@
           <p:cNvPr id="34" name="">
             <a:extLst xmlns:a="http://schemas.openxmlformats.org/drawingml/2006/main">
               <a:ext uri="{FF2B5EF4-FFF2-40B4-BE49-F238E27FC236}">
-                <a16:creationId xmlns:a16="http://schemas.microsoft.com/office/drawing/2014/main" id="{B6B523FB-0B81-4528-A38C-692B325CB3A8}"/>
+                <a16:creationId xmlns:a16="http://schemas.microsoft.com/office/drawing/2014/main" id="{62BAC110-5F0A-42B4-8087-F43F3682D09C}"/>
               </a:ext>
             </a:extLst>
           </p:cNvPr>
@@ -3566,7 +3566,7 @@
           <p:cNvPr id="35" name="">
             <a:extLst xmlns:a="http://schemas.openxmlformats.org/drawingml/2006/main">
               <a:ext uri="{FF2B5EF4-FFF2-40B4-BE49-F238E27FC236}">
-                <a16:creationId xmlns:a16="http://schemas.microsoft.com/office/drawing/2014/main" id="{75F48F34-8A25-401A-B22B-14A7496F9720}"/>
+                <a16:creationId xmlns:a16="http://schemas.microsoft.com/office/drawing/2014/main" id="{018C6078-A6A5-46E1-988E-A83CE4C09F19}"/>
               </a:ext>
             </a:extLst>
           </p:cNvPr>
@@ -3623,7 +3623,7 @@
           <p:cNvPr id="36" name="">
             <a:extLst xmlns:a="http://schemas.openxmlformats.org/drawingml/2006/main">
               <a:ext uri="{FF2B5EF4-FFF2-40B4-BE49-F238E27FC236}">
-                <a16:creationId xmlns:a16="http://schemas.microsoft.com/office/drawing/2014/main" id="{B7C09CC2-3A85-4FF1-8C57-E65F7BDC120B}"/>
+                <a16:creationId xmlns:a16="http://schemas.microsoft.com/office/drawing/2014/main" id="{71C5ADBE-96F7-472C-A116-E2CA165ADAB8}"/>
               </a:ext>
             </a:extLst>
           </p:cNvPr>
@@ -3680,7 +3680,7 @@
           <p:cNvPr id="37" name="">
             <a:extLst xmlns:a="http://schemas.openxmlformats.org/drawingml/2006/main">
               <a:ext uri="{FF2B5EF4-FFF2-40B4-BE49-F238E27FC236}">
-                <a16:creationId xmlns:a16="http://schemas.microsoft.com/office/drawing/2014/main" id="{41583FBD-2154-4639-AC52-378F5E646A48}"/>
+                <a16:creationId xmlns:a16="http://schemas.microsoft.com/office/drawing/2014/main" id="{346799FE-A17E-4D92-97C3-C6823B91DCF6}"/>
               </a:ext>
             </a:extLst>
           </p:cNvPr>
@@ -3737,7 +3737,7 @@
           <p:cNvPr id="38" name="">
             <a:extLst xmlns:a="http://schemas.openxmlformats.org/drawingml/2006/main">
               <a:ext uri="{FF2B5EF4-FFF2-40B4-BE49-F238E27FC236}">
-                <a16:creationId xmlns:a16="http://schemas.microsoft.com/office/drawing/2014/main" id="{76A0DEE8-ACFE-462E-A881-14278630F057}"/>
+                <a16:creationId xmlns:a16="http://schemas.microsoft.com/office/drawing/2014/main" id="{E9798D19-81A2-48A0-B9BC-71D4EB41F32E}"/>
               </a:ext>
             </a:extLst>
           </p:cNvPr>
@@ -3794,7 +3794,7 @@
           <p:cNvPr id="39" name="">
             <a:extLst xmlns:a="http://schemas.openxmlformats.org/drawingml/2006/main">
               <a:ext uri="{FF2B5EF4-FFF2-40B4-BE49-F238E27FC236}">
-                <a16:creationId xmlns:a16="http://schemas.microsoft.com/office/drawing/2014/main" id="{85E03942-7D96-49D1-9C55-8A30B65F6CE9}"/>
+                <a16:creationId xmlns:a16="http://schemas.microsoft.com/office/drawing/2014/main" id="{6D3A3038-6040-4353-B666-03949FF14679}"/>
               </a:ext>
             </a:extLst>
           </p:cNvPr>
@@ -3851,7 +3851,7 @@
           <p:cNvPr id="40" name="">
             <a:extLst xmlns:a="http://schemas.openxmlformats.org/drawingml/2006/main">
               <a:ext uri="{FF2B5EF4-FFF2-40B4-BE49-F238E27FC236}">
-                <a16:creationId xmlns:a16="http://schemas.microsoft.com/office/drawing/2014/main" id="{7F4F8D09-B71F-4F5B-B0E3-57FA3D81C7C7}"/>
+                <a16:creationId xmlns:a16="http://schemas.microsoft.com/office/drawing/2014/main" id="{12DE2C93-5A10-4BB5-8453-7F76EACED356}"/>
               </a:ext>
             </a:extLst>
           </p:cNvPr>
@@ -3908,7 +3908,7 @@
           <p:cNvPr id="41" name="">
             <a:extLst xmlns:a="http://schemas.openxmlformats.org/drawingml/2006/main">
               <a:ext uri="{FF2B5EF4-FFF2-40B4-BE49-F238E27FC236}">
-                <a16:creationId xmlns:a16="http://schemas.microsoft.com/office/drawing/2014/main" id="{13ADC870-A1E6-4082-97EE-E9D08D2136F9}"/>
+                <a16:creationId xmlns:a16="http://schemas.microsoft.com/office/drawing/2014/main" id="{FD40E817-7F82-44CC-933A-F8B845649DE4}"/>
               </a:ext>
             </a:extLst>
           </p:cNvPr>
@@ -3988,7 +3988,7 @@
           <p:cNvPr id="42" name="">
             <a:extLst xmlns:a="http://schemas.openxmlformats.org/drawingml/2006/main">
               <a:ext uri="{FF2B5EF4-FFF2-40B4-BE49-F238E27FC236}">
-                <a16:creationId xmlns:a16="http://schemas.microsoft.com/office/drawing/2014/main" id="{27831340-0C22-4886-B68B-56ECC3C7CDBF}"/>
+                <a16:creationId xmlns:a16="http://schemas.microsoft.com/office/drawing/2014/main" id="{8AA1CD72-0528-4B96-9849-289F0A9B87D2}"/>
               </a:ext>
             </a:extLst>
           </p:cNvPr>
@@ -4045,7 +4045,7 @@
           <p:cNvPr id="43" name="">
             <a:extLst xmlns:a="http://schemas.openxmlformats.org/drawingml/2006/main">
               <a:ext uri="{FF2B5EF4-FFF2-40B4-BE49-F238E27FC236}">
-                <a16:creationId xmlns:a16="http://schemas.microsoft.com/office/drawing/2014/main" id="{1C8B260D-65FC-4930-88E8-E767781979B1}"/>
+                <a16:creationId xmlns:a16="http://schemas.microsoft.com/office/drawing/2014/main" id="{3A6C1783-22E9-499F-B74C-77321786EB96}"/>
               </a:ext>
             </a:extLst>
           </p:cNvPr>
@@ -4077,7 +4077,7 @@
           <p:cNvPr id="44" name="">
             <a:extLst xmlns:a="http://schemas.openxmlformats.org/drawingml/2006/main">
               <a:ext uri="{FF2B5EF4-FFF2-40B4-BE49-F238E27FC236}">
-                <a16:creationId xmlns:a16="http://schemas.microsoft.com/office/drawing/2014/main" id="{A67722E8-9543-4BBA-B123-FC10E035C9C2}"/>
+                <a16:creationId xmlns:a16="http://schemas.microsoft.com/office/drawing/2014/main" id="{D0B28E90-7F11-4687-89E2-37BD648D2AFB}"/>
               </a:ext>
             </a:extLst>
           </p:cNvPr>
@@ -4132,7 +4132,7 @@
     </p:spTree>
     <p:extLst>
       <p:ext uri="{BB962C8B-B14F-4D97-AF65-F5344CB8AC3E}">
-        <p14:creationId xmlns:p14="http://schemas.microsoft.com/office/powerpoint/2010/main" val="678091102"/>
+        <p14:creationId xmlns:p14="http://schemas.microsoft.com/office/powerpoint/2010/main" val="415490476"/>
       </p:ext>
     </p:extLst>
   </p:cSld>
@@ -4163,7 +4163,7 @@
           <p:cNvPr id="56" name="">
             <a:extLst xmlns:a="http://schemas.openxmlformats.org/drawingml/2006/main">
               <a:ext uri="{FF2B5EF4-FFF2-40B4-BE49-F238E27FC236}">
-                <a16:creationId xmlns:a16="http://schemas.microsoft.com/office/drawing/2014/main" id="{E3D10723-A624-4903-8E65-840F65D5D688}"/>
+                <a16:creationId xmlns:a16="http://schemas.microsoft.com/office/drawing/2014/main" id="{1AD91FE7-EF32-418A-A2E8-5FCBB3414644}"/>
               </a:ext>
             </a:extLst>
           </p:cNvPr>
@@ -4193,7 +4193,7 @@
           <p:cNvPr id="2" name="">
             <a:extLst xmlns:a="http://schemas.openxmlformats.org/drawingml/2006/main">
               <a:ext uri="{FF2B5EF4-FFF2-40B4-BE49-F238E27FC236}">
-                <a16:creationId xmlns:a16="http://schemas.microsoft.com/office/drawing/2014/main" id="{62DC4879-57BF-435B-9DE4-CBCF52CF4384}"/>
+                <a16:creationId xmlns:a16="http://schemas.microsoft.com/office/drawing/2014/main" id="{99D3EB75-0BBD-42FE-919A-778EC453F181}"/>
               </a:ext>
             </a:extLst>
           </p:cNvPr>
@@ -4250,7 +4250,7 @@
           <p:cNvPr id="3" name="">
             <a:extLst xmlns:a="http://schemas.openxmlformats.org/drawingml/2006/main">
               <a:ext uri="{FF2B5EF4-FFF2-40B4-BE49-F238E27FC236}">
-                <a16:creationId xmlns:a16="http://schemas.microsoft.com/office/drawing/2014/main" id="{31B26076-1C16-463D-87B9-A239207E8B52}"/>
+                <a16:creationId xmlns:a16="http://schemas.microsoft.com/office/drawing/2014/main" id="{410F4260-5016-4717-97EF-68A4CBB0926C}"/>
               </a:ext>
             </a:extLst>
           </p:cNvPr>
@@ -4280,7 +4280,7 @@
           <p:cNvPr id="4" name="">
             <a:extLst xmlns:a="http://schemas.openxmlformats.org/drawingml/2006/main">
               <a:ext uri="{FF2B5EF4-FFF2-40B4-BE49-F238E27FC236}">
-                <a16:creationId xmlns:a16="http://schemas.microsoft.com/office/drawing/2014/main" id="{598A0E73-BC1F-467F-B91B-CD2CCD4C122B}"/>
+                <a16:creationId xmlns:a16="http://schemas.microsoft.com/office/drawing/2014/main" id="{ACE49670-8C2A-4D24-AA4F-219DCD9CCC7A}"/>
               </a:ext>
             </a:extLst>
           </p:cNvPr>
@@ -4337,7 +4337,7 @@
           <p:cNvPr id="5" name="">
             <a:extLst xmlns:a="http://schemas.openxmlformats.org/drawingml/2006/main">
               <a:ext uri="{FF2B5EF4-FFF2-40B4-BE49-F238E27FC236}">
-                <a16:creationId xmlns:a16="http://schemas.microsoft.com/office/drawing/2014/main" id="{226321E6-4768-4ED7-ABF0-5D76A1B287C6}"/>
+                <a16:creationId xmlns:a16="http://schemas.microsoft.com/office/drawing/2014/main" id="{DFE3ECB1-4BD0-4EE8-96BA-1EB3DF80A2AD}"/>
               </a:ext>
             </a:extLst>
           </p:cNvPr>
@@ -4394,7 +4394,7 @@
           <p:cNvPr id="6" name="">
             <a:extLst xmlns:a="http://schemas.openxmlformats.org/drawingml/2006/main">
               <a:ext uri="{FF2B5EF4-FFF2-40B4-BE49-F238E27FC236}">
-                <a16:creationId xmlns:a16="http://schemas.microsoft.com/office/drawing/2014/main" id="{8958EE09-E51A-48C0-BC7D-1814282435BE}"/>
+                <a16:creationId xmlns:a16="http://schemas.microsoft.com/office/drawing/2014/main" id="{F96FFF4D-2149-4022-AF5F-5D3150C4C03F}"/>
               </a:ext>
             </a:extLst>
           </p:cNvPr>
@@ -4428,7 +4428,7 @@
           <p:cNvPr id="7" name="">
             <a:extLst xmlns:a="http://schemas.openxmlformats.org/drawingml/2006/main">
               <a:ext uri="{FF2B5EF4-FFF2-40B4-BE49-F238E27FC236}">
-                <a16:creationId xmlns:a16="http://schemas.microsoft.com/office/drawing/2014/main" id="{58229896-5F06-4723-8A1A-7CF931A2531D}"/>
+                <a16:creationId xmlns:a16="http://schemas.microsoft.com/office/drawing/2014/main" id="{ED7B7561-9CE0-4C0B-8B83-507382B18D0E}"/>
               </a:ext>
             </a:extLst>
           </p:cNvPr>
@@ -4460,7 +4460,7 @@
           <p:cNvPr id="8" name="">
             <a:extLst xmlns:a="http://schemas.openxmlformats.org/drawingml/2006/main">
               <a:ext uri="{FF2B5EF4-FFF2-40B4-BE49-F238E27FC236}">
-                <a16:creationId xmlns:a16="http://schemas.microsoft.com/office/drawing/2014/main" id="{D93BCC9E-D5FD-4369-8D77-3F8C6FC4E7A4}"/>
+                <a16:creationId xmlns:a16="http://schemas.microsoft.com/office/drawing/2014/main" id="{A506BF6D-E165-4D29-B261-484740E37F7C}"/>
               </a:ext>
             </a:extLst>
           </p:cNvPr>
@@ -4517,7 +4517,7 @@
           <p:cNvPr id="9" name="">
             <a:extLst xmlns:a="http://schemas.openxmlformats.org/drawingml/2006/main">
               <a:ext uri="{FF2B5EF4-FFF2-40B4-BE49-F238E27FC236}">
-                <a16:creationId xmlns:a16="http://schemas.microsoft.com/office/drawing/2014/main" id="{55B3486F-DDBD-4D0F-82A6-1A0ECF100617}"/>
+                <a16:creationId xmlns:a16="http://schemas.microsoft.com/office/drawing/2014/main" id="{04588564-F41A-486F-8B6F-5C85D483E695}"/>
               </a:ext>
             </a:extLst>
           </p:cNvPr>
@@ -4574,7 +4574,7 @@
           <p:cNvPr id="10" name="">
             <a:extLst xmlns:a="http://schemas.openxmlformats.org/drawingml/2006/main">
               <a:ext uri="{FF2B5EF4-FFF2-40B4-BE49-F238E27FC236}">
-                <a16:creationId xmlns:a16="http://schemas.microsoft.com/office/drawing/2014/main" id="{3C466D01-ACDA-4C68-B430-AE5D22081F5F}"/>
+                <a16:creationId xmlns:a16="http://schemas.microsoft.com/office/drawing/2014/main" id="{442C8AF0-5D9F-4780-B2DE-6A1DA386E275}"/>
               </a:ext>
             </a:extLst>
           </p:cNvPr>
@@ -4631,7 +4631,7 @@
           <p:cNvPr id="11" name="">
             <a:extLst xmlns:a="http://schemas.openxmlformats.org/drawingml/2006/main">
               <a:ext uri="{FF2B5EF4-FFF2-40B4-BE49-F238E27FC236}">
-                <a16:creationId xmlns:a16="http://schemas.microsoft.com/office/drawing/2014/main" id="{8ACE0320-D522-4D96-B337-F0EACE555068}"/>
+                <a16:creationId xmlns:a16="http://schemas.microsoft.com/office/drawing/2014/main" id="{7D245A55-E438-4799-8BEB-DAC6EA57121D}"/>
               </a:ext>
             </a:extLst>
           </p:cNvPr>
@@ -4661,7 +4661,7 @@
           <p:cNvPr id="12" name="">
             <a:extLst xmlns:a="http://schemas.openxmlformats.org/drawingml/2006/main">
               <a:ext uri="{FF2B5EF4-FFF2-40B4-BE49-F238E27FC236}">
-                <a16:creationId xmlns:a16="http://schemas.microsoft.com/office/drawing/2014/main" id="{B09EA37C-2ACB-40F4-B012-06F39672B5F0}"/>
+                <a16:creationId xmlns:a16="http://schemas.microsoft.com/office/drawing/2014/main" id="{265102B3-7670-41E4-B3ED-A1C19D1ECCA0}"/>
               </a:ext>
             </a:extLst>
           </p:cNvPr>
@@ -4695,7 +4695,7 @@
           <p:cNvPr id="13" name="">
             <a:extLst xmlns:a="http://schemas.openxmlformats.org/drawingml/2006/main">
               <a:ext uri="{FF2B5EF4-FFF2-40B4-BE49-F238E27FC236}">
-                <a16:creationId xmlns:a16="http://schemas.microsoft.com/office/drawing/2014/main" id="{AF994664-FDF7-4C3A-A388-6F650B39DCFE}"/>
+                <a16:creationId xmlns:a16="http://schemas.microsoft.com/office/drawing/2014/main" id="{9CAF3F38-2844-4A26-A191-C49016607D87}"/>
               </a:ext>
             </a:extLst>
           </p:cNvPr>
@@ -4727,7 +4727,7 @@
           <p:cNvPr id="14" name="">
             <a:extLst xmlns:a="http://schemas.openxmlformats.org/drawingml/2006/main">
               <a:ext uri="{FF2B5EF4-FFF2-40B4-BE49-F238E27FC236}">
-                <a16:creationId xmlns:a16="http://schemas.microsoft.com/office/drawing/2014/main" id="{35B8913D-6762-4B2F-917E-C92643CA9A52}"/>
+                <a16:creationId xmlns:a16="http://schemas.microsoft.com/office/drawing/2014/main" id="{33A6E3F9-CE80-4C68-9DDB-EC642FF86FB7}"/>
               </a:ext>
             </a:extLst>
           </p:cNvPr>
@@ -4784,7 +4784,7 @@
           <p:cNvPr id="15" name="">
             <a:extLst xmlns:a="http://schemas.openxmlformats.org/drawingml/2006/main">
               <a:ext uri="{FF2B5EF4-FFF2-40B4-BE49-F238E27FC236}">
-                <a16:creationId xmlns:a16="http://schemas.microsoft.com/office/drawing/2014/main" id="{6C639567-8A47-4DBD-9B6B-53CB30D285D2}"/>
+                <a16:creationId xmlns:a16="http://schemas.microsoft.com/office/drawing/2014/main" id="{BAFD1C05-AF39-4E84-9B2C-6A4055746E11}"/>
               </a:ext>
             </a:extLst>
           </p:cNvPr>
@@ -4841,7 +4841,7 @@
           <p:cNvPr id="16" name="">
             <a:extLst xmlns:a="http://schemas.openxmlformats.org/drawingml/2006/main">
               <a:ext uri="{FF2B5EF4-FFF2-40B4-BE49-F238E27FC236}">
-                <a16:creationId xmlns:a16="http://schemas.microsoft.com/office/drawing/2014/main" id="{2BF4F288-7586-4FED-9608-D467D4EB9E66}"/>
+                <a16:creationId xmlns:a16="http://schemas.microsoft.com/office/drawing/2014/main" id="{C632164B-6DE0-429D-B1E9-D6848D184CC3}"/>
               </a:ext>
             </a:extLst>
           </p:cNvPr>
@@ -4898,7 +4898,7 @@
           <p:cNvPr id="17" name="">
             <a:extLst xmlns:a="http://schemas.openxmlformats.org/drawingml/2006/main">
               <a:ext uri="{FF2B5EF4-FFF2-40B4-BE49-F238E27FC236}">
-                <a16:creationId xmlns:a16="http://schemas.microsoft.com/office/drawing/2014/main" id="{C26C8E7E-5051-4FE0-A941-D39B59586C40}"/>
+                <a16:creationId xmlns:a16="http://schemas.microsoft.com/office/drawing/2014/main" id="{A4D7141F-6DE8-4F8B-82B0-E28DDC7F2D82}"/>
               </a:ext>
             </a:extLst>
           </p:cNvPr>
@@ -4928,7 +4928,7 @@
           <p:cNvPr id="18" name="">
             <a:extLst xmlns:a="http://schemas.openxmlformats.org/drawingml/2006/main">
               <a:ext uri="{FF2B5EF4-FFF2-40B4-BE49-F238E27FC236}">
-                <a16:creationId xmlns:a16="http://schemas.microsoft.com/office/drawing/2014/main" id="{E231873B-FADD-4CDD-9A48-384D8529340B}"/>
+                <a16:creationId xmlns:a16="http://schemas.microsoft.com/office/drawing/2014/main" id="{E360EE42-52AB-4F11-9336-38A19D902C3B}"/>
               </a:ext>
             </a:extLst>
           </p:cNvPr>
@@ -4962,7 +4962,7 @@
           <p:cNvPr id="19" name="">
             <a:extLst xmlns:a="http://schemas.openxmlformats.org/drawingml/2006/main">
               <a:ext uri="{FF2B5EF4-FFF2-40B4-BE49-F238E27FC236}">
-                <a16:creationId xmlns:a16="http://schemas.microsoft.com/office/drawing/2014/main" id="{526BE33E-A5A2-4F61-B1F5-AA321E23570E}"/>
+                <a16:creationId xmlns:a16="http://schemas.microsoft.com/office/drawing/2014/main" id="{679AED27-5B11-47AC-8EF6-D7548C82426A}"/>
               </a:ext>
             </a:extLst>
           </p:cNvPr>
@@ -4994,7 +4994,7 @@
           <p:cNvPr id="20" name="">
             <a:extLst xmlns:a="http://schemas.openxmlformats.org/drawingml/2006/main">
               <a:ext uri="{FF2B5EF4-FFF2-40B4-BE49-F238E27FC236}">
-                <a16:creationId xmlns:a16="http://schemas.microsoft.com/office/drawing/2014/main" id="{D62B1BDC-ACE7-4B12-9968-AA39607C9B1E}"/>
+                <a16:creationId xmlns:a16="http://schemas.microsoft.com/office/drawing/2014/main" id="{69ED7E3F-D508-4D90-B3EF-FCE9E4671259}"/>
               </a:ext>
             </a:extLst>
           </p:cNvPr>
@@ -5051,7 +5051,7 @@
           <p:cNvPr id="21" name="">
             <a:extLst xmlns:a="http://schemas.openxmlformats.org/drawingml/2006/main">
               <a:ext uri="{FF2B5EF4-FFF2-40B4-BE49-F238E27FC236}">
-                <a16:creationId xmlns:a16="http://schemas.microsoft.com/office/drawing/2014/main" id="{BAED3878-0B6F-492F-8597-221BC8B3F352}"/>
+                <a16:creationId xmlns:a16="http://schemas.microsoft.com/office/drawing/2014/main" id="{1463E557-BD6A-4EB1-BD9B-75BF46AB45C1}"/>
               </a:ext>
             </a:extLst>
           </p:cNvPr>
@@ -5108,7 +5108,7 @@
           <p:cNvPr id="22" name="">
             <a:extLst xmlns:a="http://schemas.openxmlformats.org/drawingml/2006/main">
               <a:ext uri="{FF2B5EF4-FFF2-40B4-BE49-F238E27FC236}">
-                <a16:creationId xmlns:a16="http://schemas.microsoft.com/office/drawing/2014/main" id="{8D6C473C-6601-4C1F-9B56-D65F26B70E5C}"/>
+                <a16:creationId xmlns:a16="http://schemas.microsoft.com/office/drawing/2014/main" id="{121EF560-5C57-4BB6-A04F-47E84A81074F}"/>
               </a:ext>
             </a:extLst>
           </p:cNvPr>
@@ -5165,7 +5165,7 @@
           <p:cNvPr id="23" name="">
             <a:extLst xmlns:a="http://schemas.openxmlformats.org/drawingml/2006/main">
               <a:ext uri="{FF2B5EF4-FFF2-40B4-BE49-F238E27FC236}">
-                <a16:creationId xmlns:a16="http://schemas.microsoft.com/office/drawing/2014/main" id="{612B226D-62B3-46A7-ADBE-31DCD13AE0EA}"/>
+                <a16:creationId xmlns:a16="http://schemas.microsoft.com/office/drawing/2014/main" id="{33D947E3-78D0-44C9-B1EB-0C261C235426}"/>
               </a:ext>
             </a:extLst>
           </p:cNvPr>
@@ -5195,7 +5195,7 @@
           <p:cNvPr id="24" name="">
             <a:extLst xmlns:a="http://schemas.openxmlformats.org/drawingml/2006/main">
               <a:ext uri="{FF2B5EF4-FFF2-40B4-BE49-F238E27FC236}">
-                <a16:creationId xmlns:a16="http://schemas.microsoft.com/office/drawing/2014/main" id="{B4380685-92BB-4EA1-95E0-1DD5AC156BB3}"/>
+                <a16:creationId xmlns:a16="http://schemas.microsoft.com/office/drawing/2014/main" id="{90A8DE5A-FCE2-4D32-8B95-5A7718D6A09F}"/>
               </a:ext>
             </a:extLst>
           </p:cNvPr>
@@ -5229,7 +5229,7 @@
           <p:cNvPr id="25" name="">
             <a:extLst xmlns:a="http://schemas.openxmlformats.org/drawingml/2006/main">
               <a:ext uri="{FF2B5EF4-FFF2-40B4-BE49-F238E27FC236}">
-                <a16:creationId xmlns:a16="http://schemas.microsoft.com/office/drawing/2014/main" id="{BC5C885F-72E7-44F3-A742-7FD5DB90391C}"/>
+                <a16:creationId xmlns:a16="http://schemas.microsoft.com/office/drawing/2014/main" id="{2426524D-FE1B-4129-A1A7-1ED1C2D9B127}"/>
               </a:ext>
             </a:extLst>
           </p:cNvPr>
@@ -5261,7 +5261,7 @@
           <p:cNvPr id="26" name="">
             <a:extLst xmlns:a="http://schemas.openxmlformats.org/drawingml/2006/main">
               <a:ext uri="{FF2B5EF4-FFF2-40B4-BE49-F238E27FC236}">
-                <a16:creationId xmlns:a16="http://schemas.microsoft.com/office/drawing/2014/main" id="{BC94BAB0-6010-4C2F-972C-95161498134C}"/>
+                <a16:creationId xmlns:a16="http://schemas.microsoft.com/office/drawing/2014/main" id="{8C43C6BD-223F-4740-BB58-E7021D6B6225}"/>
               </a:ext>
             </a:extLst>
           </p:cNvPr>
@@ -5318,7 +5318,7 @@
           <p:cNvPr id="27" name="">
             <a:extLst xmlns:a="http://schemas.openxmlformats.org/drawingml/2006/main">
               <a:ext uri="{FF2B5EF4-FFF2-40B4-BE49-F238E27FC236}">
-                <a16:creationId xmlns:a16="http://schemas.microsoft.com/office/drawing/2014/main" id="{50A3C85F-A793-481A-970C-5B9C07223501}"/>
+                <a16:creationId xmlns:a16="http://schemas.microsoft.com/office/drawing/2014/main" id="{EAD89A89-5840-4425-AA4A-31BEFD6B5C06}"/>
               </a:ext>
             </a:extLst>
           </p:cNvPr>
@@ -5375,7 +5375,7 @@
           <p:cNvPr id="28" name="">
             <a:extLst xmlns:a="http://schemas.openxmlformats.org/drawingml/2006/main">
               <a:ext uri="{FF2B5EF4-FFF2-40B4-BE49-F238E27FC236}">
-                <a16:creationId xmlns:a16="http://schemas.microsoft.com/office/drawing/2014/main" id="{AAD68C50-F435-4252-BAC8-659B0223C17A}"/>
+                <a16:creationId xmlns:a16="http://schemas.microsoft.com/office/drawing/2014/main" id="{28502A63-9547-4045-BD15-9F714913B440}"/>
               </a:ext>
             </a:extLst>
           </p:cNvPr>
@@ -5432,7 +5432,7 @@
           <p:cNvPr id="29" name="">
             <a:extLst xmlns:a="http://schemas.openxmlformats.org/drawingml/2006/main">
               <a:ext uri="{FF2B5EF4-FFF2-40B4-BE49-F238E27FC236}">
-                <a16:creationId xmlns:a16="http://schemas.microsoft.com/office/drawing/2014/main" id="{4FEC1028-4F2A-4C1A-9CD7-3D6736455A3F}"/>
+                <a16:creationId xmlns:a16="http://schemas.microsoft.com/office/drawing/2014/main" id="{0211B042-6348-4B5B-9BDA-52FA54F26D9D}"/>
               </a:ext>
             </a:extLst>
           </p:cNvPr>
@@ -5462,7 +5462,7 @@
           <p:cNvPr id="30" name="">
             <a:extLst xmlns:a="http://schemas.openxmlformats.org/drawingml/2006/main">
               <a:ext uri="{FF2B5EF4-FFF2-40B4-BE49-F238E27FC236}">
-                <a16:creationId xmlns:a16="http://schemas.microsoft.com/office/drawing/2014/main" id="{6812D253-CA01-4C2A-842D-695EDA16FAA6}"/>
+                <a16:creationId xmlns:a16="http://schemas.microsoft.com/office/drawing/2014/main" id="{E97379DB-686E-4D70-9F23-7E52447FAA4B}"/>
               </a:ext>
             </a:extLst>
           </p:cNvPr>
@@ -5496,7 +5496,7 @@
           <p:cNvPr id="31" name="">
             <a:extLst xmlns:a="http://schemas.openxmlformats.org/drawingml/2006/main">
               <a:ext uri="{FF2B5EF4-FFF2-40B4-BE49-F238E27FC236}">
-                <a16:creationId xmlns:a16="http://schemas.microsoft.com/office/drawing/2014/main" id="{D62D44F3-D60D-4ACA-82D3-E748E22F186F}"/>
+                <a16:creationId xmlns:a16="http://schemas.microsoft.com/office/drawing/2014/main" id="{A5D2F7CA-A381-4645-875A-05F17E2A239A}"/>
               </a:ext>
             </a:extLst>
           </p:cNvPr>
@@ -5528,7 +5528,7 @@
           <p:cNvPr id="32" name="">
             <a:extLst xmlns:a="http://schemas.openxmlformats.org/drawingml/2006/main">
               <a:ext uri="{FF2B5EF4-FFF2-40B4-BE49-F238E27FC236}">
-                <a16:creationId xmlns:a16="http://schemas.microsoft.com/office/drawing/2014/main" id="{DC58FA19-DC56-477A-8869-34651E80A20C}"/>
+                <a16:creationId xmlns:a16="http://schemas.microsoft.com/office/drawing/2014/main" id="{80949E8A-BF7D-44E6-8179-3725CCE98E8C}"/>
               </a:ext>
             </a:extLst>
           </p:cNvPr>
@@ -5585,7 +5585,7 @@
           <p:cNvPr id="33" name="">
             <a:extLst xmlns:a="http://schemas.openxmlformats.org/drawingml/2006/main">
               <a:ext uri="{FF2B5EF4-FFF2-40B4-BE49-F238E27FC236}">
-                <a16:creationId xmlns:a16="http://schemas.microsoft.com/office/drawing/2014/main" id="{6E5AF0CE-770B-4F9F-83D4-53751B840803}"/>
+                <a16:creationId xmlns:a16="http://schemas.microsoft.com/office/drawing/2014/main" id="{92A2769A-DEE8-420C-BE4C-5EABB1855DC8}"/>
               </a:ext>
             </a:extLst>
           </p:cNvPr>
@@ -5642,7 +5642,7 @@
           <p:cNvPr id="34" name="">
             <a:extLst xmlns:a="http://schemas.openxmlformats.org/drawingml/2006/main">
               <a:ext uri="{FF2B5EF4-FFF2-40B4-BE49-F238E27FC236}">
-                <a16:creationId xmlns:a16="http://schemas.microsoft.com/office/drawing/2014/main" id="{F828A7A2-F8DF-46C0-AA1F-40BF172DA69C}"/>
+                <a16:creationId xmlns:a16="http://schemas.microsoft.com/office/drawing/2014/main" id="{421E01A2-F4E5-409F-B17E-0C5DE6C925E1}"/>
               </a:ext>
             </a:extLst>
           </p:cNvPr>
@@ -5699,7 +5699,7 @@
           <p:cNvPr id="35" name="">
             <a:extLst xmlns:a="http://schemas.openxmlformats.org/drawingml/2006/main">
               <a:ext uri="{FF2B5EF4-FFF2-40B4-BE49-F238E27FC236}">
-                <a16:creationId xmlns:a16="http://schemas.microsoft.com/office/drawing/2014/main" id="{9D03FF3B-30FA-45B3-8075-508D71BA030A}"/>
+                <a16:creationId xmlns:a16="http://schemas.microsoft.com/office/drawing/2014/main" id="{8BC0DB6E-D1CE-4E7E-A260-203EE1088B74}"/>
               </a:ext>
             </a:extLst>
           </p:cNvPr>
@@ -5729,7 +5729,7 @@
           <p:cNvPr id="36" name="">
             <a:extLst xmlns:a="http://schemas.openxmlformats.org/drawingml/2006/main">
               <a:ext uri="{FF2B5EF4-FFF2-40B4-BE49-F238E27FC236}">
-                <a16:creationId xmlns:a16="http://schemas.microsoft.com/office/drawing/2014/main" id="{C25E4C7B-F1E2-4C80-8256-21BCD6F182E5}"/>
+                <a16:creationId xmlns:a16="http://schemas.microsoft.com/office/drawing/2014/main" id="{5029D390-3442-43E9-9D4F-9FB5F49A1504}"/>
               </a:ext>
             </a:extLst>
           </p:cNvPr>
@@ -5763,7 +5763,7 @@
           <p:cNvPr id="37" name="">
             <a:extLst xmlns:a="http://schemas.openxmlformats.org/drawingml/2006/main">
               <a:ext uri="{FF2B5EF4-FFF2-40B4-BE49-F238E27FC236}">
-                <a16:creationId xmlns:a16="http://schemas.microsoft.com/office/drawing/2014/main" id="{935FEFBE-1DAA-4DF5-A0E2-9310DD9B9667}"/>
+                <a16:creationId xmlns:a16="http://schemas.microsoft.com/office/drawing/2014/main" id="{00AD73CD-78C9-4866-A7F1-380D4AF95364}"/>
               </a:ext>
             </a:extLst>
           </p:cNvPr>
@@ -5795,7 +5795,7 @@
           <p:cNvPr id="38" name="">
             <a:extLst xmlns:a="http://schemas.openxmlformats.org/drawingml/2006/main">
               <a:ext uri="{FF2B5EF4-FFF2-40B4-BE49-F238E27FC236}">
-                <a16:creationId xmlns:a16="http://schemas.microsoft.com/office/drawing/2014/main" id="{EA98122E-41DA-4921-9F43-FFA0263B5279}"/>
+                <a16:creationId xmlns:a16="http://schemas.microsoft.com/office/drawing/2014/main" id="{DE8374FD-80F5-4628-AFA5-F5EA5591184E}"/>
               </a:ext>
             </a:extLst>
           </p:cNvPr>
@@ -5852,7 +5852,7 @@
           <p:cNvPr id="39" name="">
             <a:extLst xmlns:a="http://schemas.openxmlformats.org/drawingml/2006/main">
               <a:ext uri="{FF2B5EF4-FFF2-40B4-BE49-F238E27FC236}">
-                <a16:creationId xmlns:a16="http://schemas.microsoft.com/office/drawing/2014/main" id="{74750590-FAFC-45E8-8130-4BB3DE9A6CEB}"/>
+                <a16:creationId xmlns:a16="http://schemas.microsoft.com/office/drawing/2014/main" id="{D0D84C4A-9083-41C7-A834-DBA0191C102A}"/>
               </a:ext>
             </a:extLst>
           </p:cNvPr>
@@ -5909,7 +5909,7 @@
           <p:cNvPr id="40" name="">
             <a:extLst xmlns:a="http://schemas.openxmlformats.org/drawingml/2006/main">
               <a:ext uri="{FF2B5EF4-FFF2-40B4-BE49-F238E27FC236}">
-                <a16:creationId xmlns:a16="http://schemas.microsoft.com/office/drawing/2014/main" id="{C8AA26CD-1561-4137-B2F8-96F52340C63C}"/>
+                <a16:creationId xmlns:a16="http://schemas.microsoft.com/office/drawing/2014/main" id="{A8313BC8-05E1-41F2-9E30-9162CA3C2865}"/>
               </a:ext>
             </a:extLst>
           </p:cNvPr>
@@ -5966,7 +5966,7 @@
           <p:cNvPr id="41" name="">
             <a:extLst xmlns:a="http://schemas.openxmlformats.org/drawingml/2006/main">
               <a:ext uri="{FF2B5EF4-FFF2-40B4-BE49-F238E27FC236}">
-                <a16:creationId xmlns:a16="http://schemas.microsoft.com/office/drawing/2014/main" id="{10C88B33-8EAE-4229-ACD4-29A819EBA082}"/>
+                <a16:creationId xmlns:a16="http://schemas.microsoft.com/office/drawing/2014/main" id="{ADE64A8A-A701-445D-848A-0A79998CD738}"/>
               </a:ext>
             </a:extLst>
           </p:cNvPr>
@@ -5998,7 +5998,7 @@
           <p:cNvPr id="42" name="">
             <a:extLst xmlns:a="http://schemas.openxmlformats.org/drawingml/2006/main">
               <a:ext uri="{FF2B5EF4-FFF2-40B4-BE49-F238E27FC236}">
-                <a16:creationId xmlns:a16="http://schemas.microsoft.com/office/drawing/2014/main" id="{E9A0A87D-5A32-4343-86FC-D468F0C6C21A}"/>
+                <a16:creationId xmlns:a16="http://schemas.microsoft.com/office/drawing/2014/main" id="{2D46D78B-1053-4931-9899-E2CA4EF9B82E}"/>
               </a:ext>
             </a:extLst>
           </p:cNvPr>
@@ -6055,7 +6055,7 @@
           <p:cNvPr id="43" name="">
             <a:extLst xmlns:a="http://schemas.openxmlformats.org/drawingml/2006/main">
               <a:ext uri="{FF2B5EF4-FFF2-40B4-BE49-F238E27FC236}">
-                <a16:creationId xmlns:a16="http://schemas.microsoft.com/office/drawing/2014/main" id="{075A0B91-BA13-44E0-9C59-879A4E8FF2CF}"/>
+                <a16:creationId xmlns:a16="http://schemas.microsoft.com/office/drawing/2014/main" id="{05BB4C13-EA32-4A5E-9A54-FD334E85156C}"/>
               </a:ext>
             </a:extLst>
           </p:cNvPr>
@@ -6112,7 +6112,7 @@
           <p:cNvPr id="44" name="">
             <a:extLst xmlns:a="http://schemas.openxmlformats.org/drawingml/2006/main">
               <a:ext uri="{FF2B5EF4-FFF2-40B4-BE49-F238E27FC236}">
-                <a16:creationId xmlns:a16="http://schemas.microsoft.com/office/drawing/2014/main" id="{AE215257-E8C6-4828-8285-2F72323810C6}"/>
+                <a16:creationId xmlns:a16="http://schemas.microsoft.com/office/drawing/2014/main" id="{57FA32F3-7231-4FB9-800D-E04EFF6265E1}"/>
               </a:ext>
             </a:extLst>
           </p:cNvPr>
@@ -6169,7 +6169,7 @@
           <p:cNvPr id="45" name="">
             <a:extLst xmlns:a="http://schemas.openxmlformats.org/drawingml/2006/main">
               <a:ext uri="{FF2B5EF4-FFF2-40B4-BE49-F238E27FC236}">
-                <a16:creationId xmlns:a16="http://schemas.microsoft.com/office/drawing/2014/main" id="{8C83AAA6-F7B4-4F72-B190-75801E628C87}"/>
+                <a16:creationId xmlns:a16="http://schemas.microsoft.com/office/drawing/2014/main" id="{9F7D048B-1F41-4135-A16A-FA0F76B46900}"/>
               </a:ext>
             </a:extLst>
           </p:cNvPr>
@@ -6226,7 +6226,7 @@
           <p:cNvPr id="46" name="">
             <a:extLst xmlns:a="http://schemas.openxmlformats.org/drawingml/2006/main">
               <a:ext uri="{FF2B5EF4-FFF2-40B4-BE49-F238E27FC236}">
-                <a16:creationId xmlns:a16="http://schemas.microsoft.com/office/drawing/2014/main" id="{F678E5CC-DDB2-4691-8167-51AE6C48F8E5}"/>
+                <a16:creationId xmlns:a16="http://schemas.microsoft.com/office/drawing/2014/main" id="{5C8C2394-73D4-4943-9123-1D845D738062}"/>
               </a:ext>
             </a:extLst>
           </p:cNvPr>
@@ -6283,7 +6283,7 @@
           <p:cNvPr id="47" name="">
             <a:extLst xmlns:a="http://schemas.openxmlformats.org/drawingml/2006/main">
               <a:ext uri="{FF2B5EF4-FFF2-40B4-BE49-F238E27FC236}">
-                <a16:creationId xmlns:a16="http://schemas.microsoft.com/office/drawing/2014/main" id="{926FCD29-63CD-46C5-937D-4C892697FA27}"/>
+                <a16:creationId xmlns:a16="http://schemas.microsoft.com/office/drawing/2014/main" id="{59EF5007-47FF-40CB-9B61-49D7733FAF86}"/>
               </a:ext>
             </a:extLst>
           </p:cNvPr>
@@ -6340,7 +6340,7 @@
           <p:cNvPr id="48" name="">
             <a:extLst xmlns:a="http://schemas.openxmlformats.org/drawingml/2006/main">
               <a:ext uri="{FF2B5EF4-FFF2-40B4-BE49-F238E27FC236}">
-                <a16:creationId xmlns:a16="http://schemas.microsoft.com/office/drawing/2014/main" id="{8D48BCE8-3DEE-42DD-BF5C-6E48C61BF442}"/>
+                <a16:creationId xmlns:a16="http://schemas.microsoft.com/office/drawing/2014/main" id="{8D75A6D8-CCEE-4C9B-AA75-220E5C00AF13}"/>
               </a:ext>
             </a:extLst>
           </p:cNvPr>
@@ -6397,7 +6397,7 @@
           <p:cNvPr id="49" name="">
             <a:extLst xmlns:a="http://schemas.openxmlformats.org/drawingml/2006/main">
               <a:ext uri="{FF2B5EF4-FFF2-40B4-BE49-F238E27FC236}">
-                <a16:creationId xmlns:a16="http://schemas.microsoft.com/office/drawing/2014/main" id="{FF1E7BD1-99B3-4057-8313-3060B5963D05}"/>
+                <a16:creationId xmlns:a16="http://schemas.microsoft.com/office/drawing/2014/main" id="{719CF8BB-C159-4844-8A43-27AC06BA8A9C}"/>
               </a:ext>
             </a:extLst>
           </p:cNvPr>
@@ -6477,7 +6477,7 @@
           <p:cNvPr id="50" name="">
             <a:extLst xmlns:a="http://schemas.openxmlformats.org/drawingml/2006/main">
               <a:ext uri="{FF2B5EF4-FFF2-40B4-BE49-F238E27FC236}">
-                <a16:creationId xmlns:a16="http://schemas.microsoft.com/office/drawing/2014/main" id="{472D1117-0D17-4503-B852-BD6388BE1E76}"/>
+                <a16:creationId xmlns:a16="http://schemas.microsoft.com/office/drawing/2014/main" id="{8C5F4715-41D5-49DC-9698-CFB7BB1D7559}"/>
               </a:ext>
             </a:extLst>
           </p:cNvPr>
@@ -6534,7 +6534,7 @@
           <p:cNvPr id="51" name="">
             <a:extLst xmlns:a="http://schemas.openxmlformats.org/drawingml/2006/main">
               <a:ext uri="{FF2B5EF4-FFF2-40B4-BE49-F238E27FC236}">
-                <a16:creationId xmlns:a16="http://schemas.microsoft.com/office/drawing/2014/main" id="{276721D9-5DC2-4C45-9FB9-33B17E473BBE}"/>
+                <a16:creationId xmlns:a16="http://schemas.microsoft.com/office/drawing/2014/main" id="{01D04882-BE31-4D06-B6CD-682D173BD007}"/>
               </a:ext>
             </a:extLst>
           </p:cNvPr>
@@ -6614,7 +6614,7 @@
           <p:cNvPr id="52" name="">
             <a:extLst xmlns:a="http://schemas.openxmlformats.org/drawingml/2006/main">
               <a:ext uri="{FF2B5EF4-FFF2-40B4-BE49-F238E27FC236}">
-                <a16:creationId xmlns:a16="http://schemas.microsoft.com/office/drawing/2014/main" id="{C265B8ED-8D31-47D4-B475-BF6C2D090A80}"/>
+                <a16:creationId xmlns:a16="http://schemas.microsoft.com/office/drawing/2014/main" id="{59435158-6513-4D82-998C-44CC0902E933}"/>
               </a:ext>
             </a:extLst>
           </p:cNvPr>
@@ -6671,7 +6671,7 @@
           <p:cNvPr id="53" name="">
             <a:extLst xmlns:a="http://schemas.openxmlformats.org/drawingml/2006/main">
               <a:ext uri="{FF2B5EF4-FFF2-40B4-BE49-F238E27FC236}">
-                <a16:creationId xmlns:a16="http://schemas.microsoft.com/office/drawing/2014/main" id="{9816FBB1-CDAD-49C1-B875-980DCAA186AD}"/>
+                <a16:creationId xmlns:a16="http://schemas.microsoft.com/office/drawing/2014/main" id="{6A08E36F-968F-4E2A-8E8E-AB62B2C8CD51}"/>
               </a:ext>
             </a:extLst>
           </p:cNvPr>
@@ -6751,7 +6751,7 @@
           <p:cNvPr id="54" name="">
             <a:extLst xmlns:a="http://schemas.openxmlformats.org/drawingml/2006/main">
               <a:ext uri="{FF2B5EF4-FFF2-40B4-BE49-F238E27FC236}">
-                <a16:creationId xmlns:a16="http://schemas.microsoft.com/office/drawing/2014/main" id="{C0E0350A-C17C-4632-916F-4046490FBEF8}"/>
+                <a16:creationId xmlns:a16="http://schemas.microsoft.com/office/drawing/2014/main" id="{A32F5C0B-10A7-4A26-A7F5-5DBADA5FCF58}"/>
               </a:ext>
             </a:extLst>
           </p:cNvPr>
@@ -6783,7 +6783,7 @@
           <p:cNvPr id="55" name="">
             <a:extLst xmlns:a="http://schemas.openxmlformats.org/drawingml/2006/main">
               <a:ext uri="{FF2B5EF4-FFF2-40B4-BE49-F238E27FC236}">
-                <a16:creationId xmlns:a16="http://schemas.microsoft.com/office/drawing/2014/main" id="{75422F59-704F-4766-B111-9F6F4C0CA65B}"/>
+                <a16:creationId xmlns:a16="http://schemas.microsoft.com/office/drawing/2014/main" id="{FB3945F6-0316-4229-9989-B08A7542E096}"/>
               </a:ext>
             </a:extLst>
           </p:cNvPr>
@@ -6838,7 +6838,7 @@
     </p:spTree>
     <p:extLst>
       <p:ext uri="{BB962C8B-B14F-4D97-AF65-F5344CB8AC3E}">
-        <p14:creationId xmlns:p14="http://schemas.microsoft.com/office/powerpoint/2010/main" val="127154672"/>
+        <p14:creationId xmlns:p14="http://schemas.microsoft.com/office/powerpoint/2010/main" val="1916282405"/>
       </p:ext>
     </p:extLst>
   </p:cSld>
@@ -6869,7 +6869,7 @@
           <p:cNvPr id="41" name="">
             <a:extLst xmlns:a="http://schemas.openxmlformats.org/drawingml/2006/main">
               <a:ext uri="{FF2B5EF4-FFF2-40B4-BE49-F238E27FC236}">
-                <a16:creationId xmlns:a16="http://schemas.microsoft.com/office/drawing/2014/main" id="{A301C061-E2C7-4E2F-91DF-7DE8B5B0F300}"/>
+                <a16:creationId xmlns:a16="http://schemas.microsoft.com/office/drawing/2014/main" id="{53F0DA39-4062-4506-8278-7A9DB4CB8D4D}"/>
               </a:ext>
             </a:extLst>
           </p:cNvPr>
@@ -6899,7 +6899,7 @@
           <p:cNvPr id="2" name="">
             <a:extLst xmlns:a="http://schemas.openxmlformats.org/drawingml/2006/main">
               <a:ext uri="{FF2B5EF4-FFF2-40B4-BE49-F238E27FC236}">
-                <a16:creationId xmlns:a16="http://schemas.microsoft.com/office/drawing/2014/main" id="{CC719CD3-A7A4-475D-8AF9-DA1FB83BC1D1}"/>
+                <a16:creationId xmlns:a16="http://schemas.microsoft.com/office/drawing/2014/main" id="{A0893489-5231-4E40-AAD2-A6F1601E544C}"/>
               </a:ext>
             </a:extLst>
           </p:cNvPr>
@@ -6956,7 +6956,7 @@
           <p:cNvPr id="3" name="">
             <a:extLst xmlns:a="http://schemas.openxmlformats.org/drawingml/2006/main">
               <a:ext uri="{FF2B5EF4-FFF2-40B4-BE49-F238E27FC236}">
-                <a16:creationId xmlns:a16="http://schemas.microsoft.com/office/drawing/2014/main" id="{AF93F2E7-5809-40D6-BB3F-9E209E40E3CD}"/>
+                <a16:creationId xmlns:a16="http://schemas.microsoft.com/office/drawing/2014/main" id="{B2CB651B-5C51-4D89-8986-487E0AB08681}"/>
               </a:ext>
             </a:extLst>
           </p:cNvPr>
@@ -6986,7 +6986,7 @@
           <p:cNvPr id="4" name="">
             <a:extLst xmlns:a="http://schemas.openxmlformats.org/drawingml/2006/main">
               <a:ext uri="{FF2B5EF4-FFF2-40B4-BE49-F238E27FC236}">
-                <a16:creationId xmlns:a16="http://schemas.microsoft.com/office/drawing/2014/main" id="{788ED17C-4663-4667-BB9D-B36D42EAC077}"/>
+                <a16:creationId xmlns:a16="http://schemas.microsoft.com/office/drawing/2014/main" id="{28E65DB9-A9A4-4ACF-BA2A-6B80565E5ED6}"/>
               </a:ext>
             </a:extLst>
           </p:cNvPr>
@@ -7043,7 +7043,7 @@
           <p:cNvPr id="5" name="">
             <a:extLst xmlns:a="http://schemas.openxmlformats.org/drawingml/2006/main">
               <a:ext uri="{FF2B5EF4-FFF2-40B4-BE49-F238E27FC236}">
-                <a16:creationId xmlns:a16="http://schemas.microsoft.com/office/drawing/2014/main" id="{8802B30B-12E0-461A-BCE3-B9620C672F11}"/>
+                <a16:creationId xmlns:a16="http://schemas.microsoft.com/office/drawing/2014/main" id="{D4C4E12C-8861-42D4-A1A2-A8A6DE256291}"/>
               </a:ext>
             </a:extLst>
           </p:cNvPr>
@@ -7100,7 +7100,7 @@
           <p:cNvPr id="6" name="">
             <a:extLst xmlns:a="http://schemas.openxmlformats.org/drawingml/2006/main">
               <a:ext uri="{FF2B5EF4-FFF2-40B4-BE49-F238E27FC236}">
-                <a16:creationId xmlns:a16="http://schemas.microsoft.com/office/drawing/2014/main" id="{F4C86D2C-BE11-47A6-B899-C5CC7D7E6843}"/>
+                <a16:creationId xmlns:a16="http://schemas.microsoft.com/office/drawing/2014/main" id="{974335FC-5CF9-44AC-9F1C-B9D7D84DAF42}"/>
               </a:ext>
             </a:extLst>
           </p:cNvPr>
@@ -7157,7 +7157,7 @@
           <p:cNvPr id="7" name="">
             <a:extLst xmlns:a="http://schemas.openxmlformats.org/drawingml/2006/main">
               <a:ext uri="{FF2B5EF4-FFF2-40B4-BE49-F238E27FC236}">
-                <a16:creationId xmlns:a16="http://schemas.microsoft.com/office/drawing/2014/main" id="{16791E65-0057-486F-8D7C-69535072473F}"/>
+                <a16:creationId xmlns:a16="http://schemas.microsoft.com/office/drawing/2014/main" id="{1BD62BE5-8B14-4A87-B023-A77362CFB56E}"/>
               </a:ext>
             </a:extLst>
           </p:cNvPr>
@@ -7187,7 +7187,7 @@
           <p:cNvPr id="8" name="">
             <a:extLst xmlns:a="http://schemas.openxmlformats.org/drawingml/2006/main">
               <a:ext uri="{FF2B5EF4-FFF2-40B4-BE49-F238E27FC236}">
-                <a16:creationId xmlns:a16="http://schemas.microsoft.com/office/drawing/2014/main" id="{677082B3-FCF0-4940-B461-AAA0E615996F}"/>
+                <a16:creationId xmlns:a16="http://schemas.microsoft.com/office/drawing/2014/main" id="{E0981505-75F3-4EC3-884A-F782DB36E4A7}"/>
               </a:ext>
             </a:extLst>
           </p:cNvPr>
@@ -7244,7 +7244,7 @@
           <p:cNvPr id="9" name="">
             <a:extLst xmlns:a="http://schemas.openxmlformats.org/drawingml/2006/main">
               <a:ext uri="{FF2B5EF4-FFF2-40B4-BE49-F238E27FC236}">
-                <a16:creationId xmlns:a16="http://schemas.microsoft.com/office/drawing/2014/main" id="{FE505008-2468-44D0-AAFF-5229649E1FEE}"/>
+                <a16:creationId xmlns:a16="http://schemas.microsoft.com/office/drawing/2014/main" id="{29F6E746-1675-4C4D-892B-3C33310BFCF6}"/>
               </a:ext>
             </a:extLst>
           </p:cNvPr>
@@ -7276,7 +7276,7 @@
           <p:cNvPr id="10" name="">
             <a:extLst xmlns:a="http://schemas.openxmlformats.org/drawingml/2006/main">
               <a:ext uri="{FF2B5EF4-FFF2-40B4-BE49-F238E27FC236}">
-                <a16:creationId xmlns:a16="http://schemas.microsoft.com/office/drawing/2014/main" id="{848BC55C-796D-4115-A2EC-3270E237D7A3}"/>
+                <a16:creationId xmlns:a16="http://schemas.microsoft.com/office/drawing/2014/main" id="{E3583C17-6A4A-4204-9292-F1ED7C9A1E13}"/>
               </a:ext>
             </a:extLst>
           </p:cNvPr>
@@ -7333,7 +7333,7 @@
           <p:cNvPr id="11" name="">
             <a:extLst xmlns:a="http://schemas.openxmlformats.org/drawingml/2006/main">
               <a:ext uri="{FF2B5EF4-FFF2-40B4-BE49-F238E27FC236}">
-                <a16:creationId xmlns:a16="http://schemas.microsoft.com/office/drawing/2014/main" id="{592009E0-71CD-4CAA-9618-8CE24EBC3BFA}"/>
+                <a16:creationId xmlns:a16="http://schemas.microsoft.com/office/drawing/2014/main" id="{CC3A49EA-1B4C-4924-AFD6-6B58427D1437}"/>
               </a:ext>
             </a:extLst>
           </p:cNvPr>
@@ -7390,7 +7390,7 @@
           <p:cNvPr id="12" name="">
             <a:extLst xmlns:a="http://schemas.openxmlformats.org/drawingml/2006/main">
               <a:ext uri="{FF2B5EF4-FFF2-40B4-BE49-F238E27FC236}">
-                <a16:creationId xmlns:a16="http://schemas.microsoft.com/office/drawing/2014/main" id="{A8B80D8B-DDE7-4BE0-8B1C-634789B0F368}"/>
+                <a16:creationId xmlns:a16="http://schemas.microsoft.com/office/drawing/2014/main" id="{412BB334-3634-414A-A56D-56347D717BB8}"/>
               </a:ext>
             </a:extLst>
           </p:cNvPr>
@@ -7447,7 +7447,7 @@
           <p:cNvPr id="13" name="">
             <a:extLst xmlns:a="http://schemas.openxmlformats.org/drawingml/2006/main">
               <a:ext uri="{FF2B5EF4-FFF2-40B4-BE49-F238E27FC236}">
-                <a16:creationId xmlns:a16="http://schemas.microsoft.com/office/drawing/2014/main" id="{374B067E-0696-4AE6-A303-AC54133642CB}"/>
+                <a16:creationId xmlns:a16="http://schemas.microsoft.com/office/drawing/2014/main" id="{9BF51E4B-DC79-4807-A420-50A560969355}"/>
               </a:ext>
             </a:extLst>
           </p:cNvPr>
@@ -7479,7 +7479,7 @@
           <p:cNvPr id="14" name="">
             <a:extLst xmlns:a="http://schemas.openxmlformats.org/drawingml/2006/main">
               <a:ext uri="{FF2B5EF4-FFF2-40B4-BE49-F238E27FC236}">
-                <a16:creationId xmlns:a16="http://schemas.microsoft.com/office/drawing/2014/main" id="{58AEF8F1-43C1-44A4-BA32-3150C8B62F2A}"/>
+                <a16:creationId xmlns:a16="http://schemas.microsoft.com/office/drawing/2014/main" id="{3F31325F-8A0D-4746-84B2-C74B0B899C13}"/>
               </a:ext>
             </a:extLst>
           </p:cNvPr>
@@ -7536,7 +7536,7 @@
           <p:cNvPr id="15" name="">
             <a:extLst xmlns:a="http://schemas.openxmlformats.org/drawingml/2006/main">
               <a:ext uri="{FF2B5EF4-FFF2-40B4-BE49-F238E27FC236}">
-                <a16:creationId xmlns:a16="http://schemas.microsoft.com/office/drawing/2014/main" id="{9E3665AD-27A9-4867-86E7-784F9BCB6B3F}"/>
+                <a16:creationId xmlns:a16="http://schemas.microsoft.com/office/drawing/2014/main" id="{1C87BEB8-28F8-415F-89CD-866D5A34D14E}"/>
               </a:ext>
             </a:extLst>
           </p:cNvPr>
@@ -7593,7 +7593,7 @@
           <p:cNvPr id="16" name="">
             <a:extLst xmlns:a="http://schemas.openxmlformats.org/drawingml/2006/main">
               <a:ext uri="{FF2B5EF4-FFF2-40B4-BE49-F238E27FC236}">
-                <a16:creationId xmlns:a16="http://schemas.microsoft.com/office/drawing/2014/main" id="{FC3489C7-8409-4594-8BB0-2261D2E73CAA}"/>
+                <a16:creationId xmlns:a16="http://schemas.microsoft.com/office/drawing/2014/main" id="{6B6E24CD-4A7D-46A7-A47E-FCB5D198C080}"/>
               </a:ext>
             </a:extLst>
           </p:cNvPr>
@@ -7650,7 +7650,7 @@
           <p:cNvPr id="17" name="">
             <a:extLst xmlns:a="http://schemas.openxmlformats.org/drawingml/2006/main">
               <a:ext uri="{FF2B5EF4-FFF2-40B4-BE49-F238E27FC236}">
-                <a16:creationId xmlns:a16="http://schemas.microsoft.com/office/drawing/2014/main" id="{97E57877-BA7A-4BDC-85B5-0FAB0B31FC6A}"/>
+                <a16:creationId xmlns:a16="http://schemas.microsoft.com/office/drawing/2014/main" id="{1AD26595-0721-46CA-B31F-94867456190F}"/>
               </a:ext>
             </a:extLst>
           </p:cNvPr>
@@ -7682,7 +7682,7 @@
           <p:cNvPr id="18" name="">
             <a:extLst xmlns:a="http://schemas.openxmlformats.org/drawingml/2006/main">
               <a:ext uri="{FF2B5EF4-FFF2-40B4-BE49-F238E27FC236}">
-                <a16:creationId xmlns:a16="http://schemas.microsoft.com/office/drawing/2014/main" id="{A1A64E4D-14F5-4439-A060-FFFE11876E68}"/>
+                <a16:creationId xmlns:a16="http://schemas.microsoft.com/office/drawing/2014/main" id="{948B91C4-95ED-4AA0-883D-DF318F44EE34}"/>
               </a:ext>
             </a:extLst>
           </p:cNvPr>
@@ -7739,7 +7739,7 @@
           <p:cNvPr id="19" name="">
             <a:extLst xmlns:a="http://schemas.openxmlformats.org/drawingml/2006/main">
               <a:ext uri="{FF2B5EF4-FFF2-40B4-BE49-F238E27FC236}">
-                <a16:creationId xmlns:a16="http://schemas.microsoft.com/office/drawing/2014/main" id="{A86C5249-FF49-414E-AB88-A5089576F41C}"/>
+                <a16:creationId xmlns:a16="http://schemas.microsoft.com/office/drawing/2014/main" id="{915DCEFB-DFA1-4BD6-8162-008A13A8DA03}"/>
               </a:ext>
             </a:extLst>
           </p:cNvPr>
@@ -7796,7 +7796,7 @@
           <p:cNvPr id="20" name="">
             <a:extLst xmlns:a="http://schemas.openxmlformats.org/drawingml/2006/main">
               <a:ext uri="{FF2B5EF4-FFF2-40B4-BE49-F238E27FC236}">
-                <a16:creationId xmlns:a16="http://schemas.microsoft.com/office/drawing/2014/main" id="{692C6ABC-3489-4A8A-9BD1-23A6A6BCC361}"/>
+                <a16:creationId xmlns:a16="http://schemas.microsoft.com/office/drawing/2014/main" id="{5C61FB92-4CC3-47DB-A783-9400DE819D9E}"/>
               </a:ext>
             </a:extLst>
           </p:cNvPr>
@@ -7853,7 +7853,7 @@
           <p:cNvPr id="21" name="">
             <a:extLst xmlns:a="http://schemas.openxmlformats.org/drawingml/2006/main">
               <a:ext uri="{FF2B5EF4-FFF2-40B4-BE49-F238E27FC236}">
-                <a16:creationId xmlns:a16="http://schemas.microsoft.com/office/drawing/2014/main" id="{F63F78F3-CA3F-4336-81D0-5313E6D21820}"/>
+                <a16:creationId xmlns:a16="http://schemas.microsoft.com/office/drawing/2014/main" id="{4002DC70-EC58-4ED7-891C-F69F852CD3E0}"/>
               </a:ext>
             </a:extLst>
           </p:cNvPr>
@@ -7885,7 +7885,7 @@
           <p:cNvPr id="22" name="">
             <a:extLst xmlns:a="http://schemas.openxmlformats.org/drawingml/2006/main">
               <a:ext uri="{FF2B5EF4-FFF2-40B4-BE49-F238E27FC236}">
-                <a16:creationId xmlns:a16="http://schemas.microsoft.com/office/drawing/2014/main" id="{B7D4DF2B-F6DC-4FEE-97E1-00F44F4B353A}"/>
+                <a16:creationId xmlns:a16="http://schemas.microsoft.com/office/drawing/2014/main" id="{E6AE5C65-250E-43CD-9510-AA63FE840A08}"/>
               </a:ext>
             </a:extLst>
           </p:cNvPr>
@@ -7942,7 +7942,7 @@
           <p:cNvPr id="23" name="">
             <a:extLst xmlns:a="http://schemas.openxmlformats.org/drawingml/2006/main">
               <a:ext uri="{FF2B5EF4-FFF2-40B4-BE49-F238E27FC236}">
-                <a16:creationId xmlns:a16="http://schemas.microsoft.com/office/drawing/2014/main" id="{F2484456-6CBA-478B-8BDB-EB657FF62A6F}"/>
+                <a16:creationId xmlns:a16="http://schemas.microsoft.com/office/drawing/2014/main" id="{33DDF17E-0E6D-4138-ACD9-F4F13056C907}"/>
               </a:ext>
             </a:extLst>
           </p:cNvPr>
@@ -7999,7 +7999,7 @@
           <p:cNvPr id="24" name="">
             <a:extLst xmlns:a="http://schemas.openxmlformats.org/drawingml/2006/main">
               <a:ext uri="{FF2B5EF4-FFF2-40B4-BE49-F238E27FC236}">
-                <a16:creationId xmlns:a16="http://schemas.microsoft.com/office/drawing/2014/main" id="{883D878B-A455-46E8-8251-C3F79377C547}"/>
+                <a16:creationId xmlns:a16="http://schemas.microsoft.com/office/drawing/2014/main" id="{E02F5B02-0C62-436A-B532-C960ADEC1934}"/>
               </a:ext>
             </a:extLst>
           </p:cNvPr>
@@ -8056,7 +8056,7 @@
           <p:cNvPr id="25" name="">
             <a:extLst xmlns:a="http://schemas.openxmlformats.org/drawingml/2006/main">
               <a:ext uri="{FF2B5EF4-FFF2-40B4-BE49-F238E27FC236}">
-                <a16:creationId xmlns:a16="http://schemas.microsoft.com/office/drawing/2014/main" id="{EAAD8A0C-9C6D-4F6F-A898-292FA541E1D6}"/>
+                <a16:creationId xmlns:a16="http://schemas.microsoft.com/office/drawing/2014/main" id="{BA12364B-E371-41CC-87B2-B288444DD025}"/>
               </a:ext>
             </a:extLst>
           </p:cNvPr>
@@ -8088,7 +8088,7 @@
           <p:cNvPr id="26" name="">
             <a:extLst xmlns:a="http://schemas.openxmlformats.org/drawingml/2006/main">
               <a:ext uri="{FF2B5EF4-FFF2-40B4-BE49-F238E27FC236}">
-                <a16:creationId xmlns:a16="http://schemas.microsoft.com/office/drawing/2014/main" id="{D58C1E84-8531-4EF9-8E50-467391B6892B}"/>
+                <a16:creationId xmlns:a16="http://schemas.microsoft.com/office/drawing/2014/main" id="{814ED507-AA0B-467E-B31F-05FC4B78619F}"/>
               </a:ext>
             </a:extLst>
           </p:cNvPr>
@@ -8145,7 +8145,7 @@
           <p:cNvPr id="27" name="">
             <a:extLst xmlns:a="http://schemas.openxmlformats.org/drawingml/2006/main">
               <a:ext uri="{FF2B5EF4-FFF2-40B4-BE49-F238E27FC236}">
-                <a16:creationId xmlns:a16="http://schemas.microsoft.com/office/drawing/2014/main" id="{042BECFC-CE50-4008-8A19-30F788604D84}"/>
+                <a16:creationId xmlns:a16="http://schemas.microsoft.com/office/drawing/2014/main" id="{DD8CF72A-3E64-4547-89E1-FB7D99FC9B90}"/>
               </a:ext>
             </a:extLst>
           </p:cNvPr>
@@ -8202,7 +8202,7 @@
           <p:cNvPr id="28" name="">
             <a:extLst xmlns:a="http://schemas.openxmlformats.org/drawingml/2006/main">
               <a:ext uri="{FF2B5EF4-FFF2-40B4-BE49-F238E27FC236}">
-                <a16:creationId xmlns:a16="http://schemas.microsoft.com/office/drawing/2014/main" id="{22E14C8E-A2B0-406B-97D8-57B5B9CA400D}"/>
+                <a16:creationId xmlns:a16="http://schemas.microsoft.com/office/drawing/2014/main" id="{9BA29DD5-0810-4C9C-8E89-7D5FB401B064}"/>
               </a:ext>
             </a:extLst>
           </p:cNvPr>
@@ -8259,7 +8259,7 @@
           <p:cNvPr id="29" name="">
             <a:extLst xmlns:a="http://schemas.openxmlformats.org/drawingml/2006/main">
               <a:ext uri="{FF2B5EF4-FFF2-40B4-BE49-F238E27FC236}">
-                <a16:creationId xmlns:a16="http://schemas.microsoft.com/office/drawing/2014/main" id="{1D462E9C-F996-4D1B-93A8-3DBBA961A4C5}"/>
+                <a16:creationId xmlns:a16="http://schemas.microsoft.com/office/drawing/2014/main" id="{3D74658F-94D0-4F4C-B2AE-72441AB69D99}"/>
               </a:ext>
             </a:extLst>
           </p:cNvPr>
@@ -8316,7 +8316,7 @@
           <p:cNvPr id="30" name="">
             <a:extLst xmlns:a="http://schemas.openxmlformats.org/drawingml/2006/main">
               <a:ext uri="{FF2B5EF4-FFF2-40B4-BE49-F238E27FC236}">
-                <a16:creationId xmlns:a16="http://schemas.microsoft.com/office/drawing/2014/main" id="{8B06ACE5-3101-4C08-98C2-CD110AC7AC96}"/>
+                <a16:creationId xmlns:a16="http://schemas.microsoft.com/office/drawing/2014/main" id="{36ABBC13-0CC2-48AD-A397-01DA9A974F5A}"/>
               </a:ext>
             </a:extLst>
           </p:cNvPr>
@@ -8373,7 +8373,7 @@
           <p:cNvPr id="31" name="">
             <a:extLst xmlns:a="http://schemas.openxmlformats.org/drawingml/2006/main">
               <a:ext uri="{FF2B5EF4-FFF2-40B4-BE49-F238E27FC236}">
-                <a16:creationId xmlns:a16="http://schemas.microsoft.com/office/drawing/2014/main" id="{69DCCE3C-A506-4EB9-AA9C-EB2A088CB5E6}"/>
+                <a16:creationId xmlns:a16="http://schemas.microsoft.com/office/drawing/2014/main" id="{A5AECB74-699D-4D01-B37D-B6A5BBD97F1E}"/>
               </a:ext>
             </a:extLst>
           </p:cNvPr>
@@ -8430,7 +8430,7 @@
           <p:cNvPr id="32" name="">
             <a:extLst xmlns:a="http://schemas.openxmlformats.org/drawingml/2006/main">
               <a:ext uri="{FF2B5EF4-FFF2-40B4-BE49-F238E27FC236}">
-                <a16:creationId xmlns:a16="http://schemas.microsoft.com/office/drawing/2014/main" id="{30C24AE9-5881-4A63-8C8C-D1487E0945B9}"/>
+                <a16:creationId xmlns:a16="http://schemas.microsoft.com/office/drawing/2014/main" id="{195EEFCA-9D02-4C48-BFB9-59EB75E05E46}"/>
               </a:ext>
             </a:extLst>
           </p:cNvPr>
@@ -8487,7 +8487,7 @@
           <p:cNvPr id="33" name="">
             <a:extLst xmlns:a="http://schemas.openxmlformats.org/drawingml/2006/main">
               <a:ext uri="{FF2B5EF4-FFF2-40B4-BE49-F238E27FC236}">
-                <a16:creationId xmlns:a16="http://schemas.microsoft.com/office/drawing/2014/main" id="{C7F17F36-BC99-4F65-A8BA-DF7FEFE3AB1A}"/>
+                <a16:creationId xmlns:a16="http://schemas.microsoft.com/office/drawing/2014/main" id="{6A1A1825-0369-4821-AD58-347CCE9EE5FE}"/>
               </a:ext>
             </a:extLst>
           </p:cNvPr>
@@ -8534,7 +8534,7 @@
                 <a:ea typeface="Malgun Gothic"/>
                 <a:cs typeface="Malgun Gothic"/>
               </a:rPr>
-              <a:t>숙고 전용 4 Case · 3회</a:t>
+              <a:t>숙고 전용 4 Case</a:t>
             </a:r>
           </a:p>
         </p:txBody>
@@ -8544,7 +8544,7 @@
           <p:cNvPr id="34" name="">
             <a:extLst xmlns:a="http://schemas.openxmlformats.org/drawingml/2006/main">
               <a:ext uri="{FF2B5EF4-FFF2-40B4-BE49-F238E27FC236}">
-                <a16:creationId xmlns:a16="http://schemas.microsoft.com/office/drawing/2014/main" id="{043A31BA-79BA-4A20-B9AD-FBCF96731654}"/>
+                <a16:creationId xmlns:a16="http://schemas.microsoft.com/office/drawing/2014/main" id="{C3B1046A-DCBF-4593-A097-015ACC359FC5}"/>
               </a:ext>
             </a:extLst>
           </p:cNvPr>
@@ -8591,7 +8591,7 @@
                 <a:ea typeface="Malgun Gothic"/>
                 <a:cs typeface="Malgun Gothic"/>
               </a:rPr>
-              <a:t>재현되는 차이 1건</a:t>
+              <a:t>Mock On 4/4 · Off 3/4</a:t>
             </a:r>
           </a:p>
         </p:txBody>
@@ -8601,7 +8601,7 @@
           <p:cNvPr id="35" name="">
             <a:extLst xmlns:a="http://schemas.openxmlformats.org/drawingml/2006/main">
               <a:ext uri="{FF2B5EF4-FFF2-40B4-BE49-F238E27FC236}">
-                <a16:creationId xmlns:a16="http://schemas.microsoft.com/office/drawing/2014/main" id="{0AD4AD10-A69E-4995-8346-6FE6C46D6F66}"/>
+                <a16:creationId xmlns:a16="http://schemas.microsoft.com/office/drawing/2014/main" id="{18944B0C-C0D3-4892-92F4-6353B66D79B1}"/>
               </a:ext>
             </a:extLst>
           </p:cNvPr>
@@ -8648,7 +8648,7 @@
                 <a:ea typeface="Malgun Gothic"/>
                 <a:cs typeface="Malgun Gothic"/>
               </a:rPr>
-              <a:t>DLB-02: On 3/3 통과, Off 3/3 실패</a:t>
+              <a:t>LLM 없는 결정론 경로에서 재현</a:t>
             </a:r>
           </a:p>
         </p:txBody>
@@ -8658,7 +8658,7 @@
           <p:cNvPr id="36" name="">
             <a:extLst xmlns:a="http://schemas.openxmlformats.org/drawingml/2006/main">
               <a:ext uri="{FF2B5EF4-FFF2-40B4-BE49-F238E27FC236}">
-                <a16:creationId xmlns:a16="http://schemas.microsoft.com/office/drawing/2014/main" id="{580CEF93-DD34-4B7A-8EF4-FF8992016866}"/>
+                <a16:creationId xmlns:a16="http://schemas.microsoft.com/office/drawing/2014/main" id="{A961A47F-39B9-4AF6-8049-839F735DCF53}"/>
               </a:ext>
             </a:extLst>
           </p:cNvPr>
@@ -8715,7 +8715,7 @@
           <p:cNvPr id="37" name="">
             <a:extLst xmlns:a="http://schemas.openxmlformats.org/drawingml/2006/main">
               <a:ext uri="{FF2B5EF4-FFF2-40B4-BE49-F238E27FC236}">
-                <a16:creationId xmlns:a16="http://schemas.microsoft.com/office/drawing/2014/main" id="{64B50644-3C83-4A39-A74B-2F8B053F6666}"/>
+                <a16:creationId xmlns:a16="http://schemas.microsoft.com/office/drawing/2014/main" id="{22BC7500-3D6D-4453-B8FB-E861C6D7F96C}"/>
               </a:ext>
             </a:extLst>
           </p:cNvPr>
@@ -8772,7 +8772,7 @@
           <p:cNvPr id="38" name="">
             <a:extLst xmlns:a="http://schemas.openxmlformats.org/drawingml/2006/main">
               <a:ext uri="{FF2B5EF4-FFF2-40B4-BE49-F238E27FC236}">
-                <a16:creationId xmlns:a16="http://schemas.microsoft.com/office/drawing/2014/main" id="{60D60258-420A-4ADD-BDC8-5ACA6A4EA1E5}"/>
+                <a16:creationId xmlns:a16="http://schemas.microsoft.com/office/drawing/2014/main" id="{CBA5467F-E415-4FB4-A373-BED542AD45B2}"/>
               </a:ext>
             </a:extLst>
           </p:cNvPr>
@@ -8829,7 +8829,7 @@
           <p:cNvPr id="39" name="">
             <a:extLst xmlns:a="http://schemas.openxmlformats.org/drawingml/2006/main">
               <a:ext uri="{FF2B5EF4-FFF2-40B4-BE49-F238E27FC236}">
-                <a16:creationId xmlns:a16="http://schemas.microsoft.com/office/drawing/2014/main" id="{DCC07A96-F902-4A4C-A7B8-B32A56E3A2DB}"/>
+                <a16:creationId xmlns:a16="http://schemas.microsoft.com/office/drawing/2014/main" id="{F67D4B16-EB13-4A11-B90C-22BEABA7C02C}"/>
               </a:ext>
             </a:extLst>
           </p:cNvPr>
@@ -8886,7 +8886,7 @@
           <p:cNvPr id="40" name="">
             <a:extLst xmlns:a="http://schemas.openxmlformats.org/drawingml/2006/main">
               <a:ext uri="{FF2B5EF4-FFF2-40B4-BE49-F238E27FC236}">
-                <a16:creationId xmlns:a16="http://schemas.microsoft.com/office/drawing/2014/main" id="{802DB9D0-DDA5-4372-960C-C1BE0407B585}"/>
+                <a16:creationId xmlns:a16="http://schemas.microsoft.com/office/drawing/2014/main" id="{CAD5E631-0911-44DE-968C-CA4638D6D61B}"/>
               </a:ext>
             </a:extLst>
           </p:cNvPr>
@@ -8941,7 +8941,7 @@
     </p:spTree>
     <p:extLst>
       <p:ext uri="{BB962C8B-B14F-4D97-AF65-F5344CB8AC3E}">
-        <p14:creationId xmlns:p14="http://schemas.microsoft.com/office/powerpoint/2010/main" val="1029891108"/>
+        <p14:creationId xmlns:p14="http://schemas.microsoft.com/office/powerpoint/2010/main" val="509430761"/>
       </p:ext>
     </p:extLst>
   </p:cSld>

</xml_diff>